<commit_message>
Align slide text and speaker notes with textbook wording
Remove analogies and interpretive summaries; notes now follow the
textbook sentences in presentation tone.

Co-Authored-By: Claude Opus 5.5 <noreply@anthropic.com>
Claude-Session: https://claude.ai/code/session_01VWyfvPXCzvV2mTdib2g56M
</commit_message>
<xml_diff>
--- a/slides/교육과정의_계획과_운영_합본.pptx
+++ b/slides/교육과정의_계획과_운영_합본.pptx
@@ -610,13 +610,13 @@
           <a:p>
             <a:r>
               <a:rPr lang="en-US" dirty="0"/>
-              <a:t>교육과정의 구성 요소는 학자마다 조금씩 다르게 말하지만, 가장 많이 쓰는 네 가지는 교육목적, 교육내용, 교육방법, 교육평가입니다.
-이 네 가지는 타일러(Tyler)라는 학자가 던진 네 가지 질문과 연결됩니다. 타일러는 교육과정을 짤 때 이 네 가지를 꼭 물어봐야 한다고 했어요.
-첫째, 무엇을 목표로 할까? 이것이 교육목표입니다.
-둘째, 목표를 이루려면 어떤 경험을 줘야 할까? 이것이 교육내용입니다.
-셋째, 그 경험을 어떻게 짜야 가장 효과적일까? 이것이 교수-학습 방법입니다.
-넷째, 목표를 이뤘는지 어떻게 알 수 있을까? 이것이 평가입니다.
-여행 계획에 비유하면, 어디로 갈지 정하고, 무엇을 볼지 고르고, 어떤 순서로 다닐지 짜고, 다녀와서 어땠는지 돌아보는 것과 같아요.</a:t>
+              <a:t>교육과정에 대한 개념적 정의가 다양하므로 교육과정 구성요소 또한 학자마다 서로 다를 수 있지만, 가장 일반적인 교육과정 구성요소는 교육목적, 교육내용, 교육방법, 교육평가입니다.
+타일러(Tyler)는 교육과정을 체계화하는 데 있어서 다음과 같은 네 가지 질문을 해야 한다고 제시하고 있습니다.
+첫째, 학교가 성취해야 할 교육목표는 무엇인가?
+둘째, 교육목표를 달성하기 위해 어떤 교육적 경험이 제공될 수 있는가?
+셋째, 교육적 경험은 어떻게 하면 가장 효과적으로 조직할 수 있는가?
+넷째, 교육목표들이 달성되었는지를 어떻게 알 수 있는가?
+타일러가 제시한 네 가지 질문에 기초하면, 영유아교육과정의 구성은 영유아에게 가치 있는 교육목표를 설정하고, 목표를 달성하도록 돕는 적절한 교육 내용과 방법을 선정 및 조직하고, 의도한 목표가 제대로 달성되었는지를 확인하는 평가 작업 등이 핵심적인 요소가 됩니다.</a:t>
             </a:r>
             <a:endParaRPr lang="en-US" dirty="0"/>
           </a:p>
@@ -704,10 +704,8 @@
           <a:p>
             <a:r>
               <a:rPr lang="en-US" dirty="0"/>
-              <a:t>이 네 가지 요소는 그냥 나열된 것이 아니라, 교육과정이 실제로 진행되는 순서이기도 합니다.
-먼저 우리 기관의 생각과 철학에 맞는 교육목표를 세웁니다. 다음으로 그 목표를 이루는 데 꼭 필요한 교육내용을 고릅니다. 그리고 고른 내용을 잘 정리하고, 아이들의 발달과 흥미에 맞는 가르치는 방법을 정합니다. 그다음 평가를 하고, 평가 결과를 다음 교육계획에 반영합니다.
-그래서 그림처럼 한 바퀴 돌고 나면 다시 처음으로 이어지는 구조예요.
-타일러의 모형은 비판도 받지만, 우리나라 초·중·고 교육과정은 이 틀을 바탕으로 만들어져 왔습니다. 영유아교육과정도 마찬가지로 이 네 가지 요소를 담고 있습니다.</a:t>
+              <a:t>타일러의 교육과정 모형에 대해 비판하면서도 우리나라 초·중·고등학교 교육과정은 타일러의 교육과정 체제에 의존해 왔으며, 이 모형은 교육과정을 개념화하는 데도 많은 영향을 미쳤습니다. 따라서 우리나라 영유아교육과정을 구성하는 기본 요소에도 교육목표와 교육내용, 교수-학습 방법, 평가 등의 네 가지 요소가 포함됩니다.
+즉, 각 기관의 철학에 부합하는 교육목표의 설정과 그러한 교육목표를 달성하는 데 반드시 필요한 교육내용의 선정, 잘 선정된 교육내용의 조직 및 영유아의 발달과 흥미에 적합한 교수방법의 결정, 평가, 그리고 평가 결과를 차기 교육계획 수립에 적절히 반영하는 것 등은 교육과정의 구성요소이자 교육과정이 실행되는 순서이기도 합니다.</a:t>
             </a:r>
             <a:endParaRPr lang="en-US" dirty="0"/>
           </a:p>
@@ -795,10 +793,9 @@
           <a:p>
             <a:r>
               <a:rPr lang="en-US" dirty="0"/>
-              <a:t>이제 영유아교육과정을 짤 때 어떤 특징이 있어야 하는지 네 가지로 살펴보겠습니다. 먼저 두 가지입니다.
-첫째, 교육내용 간의 통합입니다. 아이들은 국어, 과학, 미술처럼 과목을 나눠서 배우는 것보다, 여러 가지가 섞인 경험을 통해 더 잘 배웁니다. 예를 들어 '가을'이라는 주제로 놀면, 가을 과일을 만들고, 과일가게 놀이를 하고, 간판과 가격표도 쓰면서 여러 영역을 한꺼번에 자연스럽게 배우게 됩니다.
-둘째, 놀이 중심으로 운영하는 것입니다. 선생님이 지식을 가르치려고 하기보다, 아이가 스스로 놀면서 배우도록 해야 합니다. 그래서 놀이 시간을 충분히 주고, 바깥놀이나 익숙한 물건, 자연물을 이용한 놀이도 권장합니다.
-이때 선생님은 놀이를 이끄는 사람이 아니라, 아이를 잘 지켜보고 필요할 때 도와주는 '놀이지원자'입니다.</a:t>
+              <a:t>다음은 교육과정 구성의 특징입니다.
+첫째, 교육내용 간의 통합입니다. 영유아는 분리된 교과별 학습보다 통합된 경험을 통해 더 잘 배웁니다. 따라서 학습경험을 국어, 사회, 과학, 미술 등 교과로 분리하여 접근하는 것보다는 유아의 경험을 중심으로 교육과정의 영역이 자연스럽게 통합되면서 배움이 이루어지도록 운영해야 합니다. 영유아에게 친근하며 관심 있는 주제를 중심으로 통합한 놀이 경험, 예를 들어 주제 '가을' 전개 시 가을 과일 만들기, 과일 가게 놀이, 간판과 가격표 쓰기 등을 통해 영유아들은 각 교과 혹은 학문영역 간의 지식을 서로 잘 연관 지을 수 있고 추상적인 개념을 이해할 수 있게 됩니다.
+둘째, 놀이 중심 교육과정으로 운영하는 것입니다. 유아와 놀이를 최우선으로 존중하는 교육과정으로 운영되어야 합니다. 이를 위해 충분한 놀이시간을 확보하고, 교사가 활동을 통해 지식을 가르치려는 접근보다는 유아 스스로 놀이하는 과정에서 배움이 이루어지도록 장려해야 합니다. 충분한 바깥놀이 시간을 제공하고 친숙한 사물이나 자연물을 이용한 놀이가 이루어지도록 장려합니다. 교사는 놀이지원자로서 유아를 관찰하고 필요한 지원과 상호작용을 합니다.</a:t>
             </a:r>
             <a:endParaRPr lang="en-US" dirty="0"/>
           </a:p>
@@ -886,10 +883,8 @@
           <a:p>
             <a:r>
               <a:rPr lang="en-US" dirty="0"/>
-              <a:t>나머지 두 가지 특징입니다.
-셋째, 흥미와 요구를 반영하는 것입니다. 교육과정은 아이들의 흥미를 최대한 존중하면서 발달에 맞는 내용을 골라야 해요. 그런데 주의할 점이 있습니다. 흥미를 반영한다는 것이 '아이가 좋아하는 것이면 다 좋은 교육과정'이라는 뜻은 아니에요. 선생님이 아이들을 잘 관찰하고 평가해서, 의미 있는 주제나 놀이를 골라 교육적인 활동으로 이어 줘야 합니다.
-넷째, 다양성을 반영하는 것입니다. 아이들마다 발달 속도, 기질, 자라 온 문화적 배경이 모두 다릅니다. 특히 영아는 한 명 한 명의 차이가 크고 몇 개월 차이로도 많이 달라서, 반 전체 계획보다 개인별 보육계획이 더 알맞습니다. 누리과정도 나이별로 되어 있지만, 실제로 쓸 때는 아이 한 명 한 명을 평가해서 수준에 맞는 계획을 세우는 것이 좋습니다.
-또 우리 사회가 다문화 사회가 된 만큼, 아이와 가정의 다양성을 담은 다문화교육도 계획해야 합니다.</a:t>
+              <a:t>셋째, 흥미와 요구를 반영한 교육적 경험입니다. 영유아를 위한 교육과정은 영유아의 흥미를 최대한 존중하면서 발달적 요구에 적합한 것을 내용으로 선정해야 합니다. 흥미에 기초한다는 것은 단순히 영유아가 좋아하는 것, 지금 경험하는 것이 좋은 교육과정을 의미하는 것은 아니라는 점에 유의해야 합니다. 교사는 주의 깊은 관찰과 영유아에 대한 평가를 통해 개별 및 전체 영유아에게 의미 있는 주제나 놀이를 선별하고, 이를 교육적인 활동으로 연결하는 것이 필요합니다.
+넷째, 개인차와 문화적 특성 등의 다양성 반영입니다. 영유아를 위한 교육과정은 영유아기의 발달적 독특성뿐만 아니라 개별 영유아의 발달 특성, 개인차, 기질, 사회문화적 배경 차이 등의 다양성을 반영해야 합니다. 특히 영아기는 개인별 발달 차이와 월령별 발달 차이가 크게 나타나므로 학급별 계획보다는 개인별 보육계획을 수립하는 것이 적합합니다. 누리과정도 연령별로 구성되어 있으나, 이를 적용할 때는 학급별 교육계획 시 담당교사가 영유아의 개인별 평가에 기초한 수준별 교육계획을 수립하는 것이 바람직합니다. 또한 우리 사회가 다문화 사회로 진입한 만큼 유아와 가정의 다양성을 반영한 다문화교육을 계획해야 합니다.</a:t>
             </a:r>
             <a:endParaRPr lang="en-US" dirty="0"/>
           </a:p>
@@ -977,11 +972,9 @@
           <a:p>
             <a:r>
               <a:rPr lang="en-US" dirty="0"/>
-              <a:t>정리하겠습니다.
-교육과정은 목표, 내용, 방법, 평가의 네 가지 요소로 이루어지고, 이것은 교육이 진행되는 순서이기도 합니다.
-그리고 영유아교육과정은 네 가지 특징을 가져야 합니다. 여러 내용을 통합하고, 놀이를 중심으로 하고, 아이의 흥미와 요구를 반영하고, 아이마다 다른 다양성을 반영하는 것입니다.
-한마디로, 아이가 놀이 속에서 자연스럽게 배우도록 짜는 것이 영유아교육과정 구성의 핵심입니다.
-그럼 마지막으로, 실제로 교육과정을 어떻게 계획하고 운영하는지 살펴보겠습니다.</a:t>
+              <a:t>정리하겠습니다. 영유아교육과정을 구성하는 기본 요소는 교육목표, 교육내용, 교수-학습 방법, 평가이며, 이는 교육과정의 구성요소이자 교육과정이 실행되는 순서이기도 합니다.
+그리고 교육과정 구성의 특징은 교육내용 간의 통합, 놀이 중심 교육과정으로 운영, 흥미와 요구를 반영한 교육적 경험, 개인차와 문화적 특성 등의 다양성 반영입니다.
+다음으로 세 번째 부분, '영유아교육과정의 계획 및 운영'을 살펴보겠습니다.</a:t>
             </a:r>
             <a:endParaRPr lang="en-US" dirty="0"/>
           </a:p>
@@ -1070,7 +1063,7 @@
             <a:r>
               <a:rPr lang="en-US" dirty="0"/>
               <a:t>마지막 세 번째 부분은 '영유아교육과정의 계획 및 운영'입니다.
-어린이집과 유치원이 교육과정을 계획하고 운영할 때 무엇을 기준으로 삼는지, 그리고 나라에서 정한 표준보육과정에는 어떤 내용이 담겨 있는지 살펴보겠습니다.</a:t>
+교육과정 계획·운영의 지침, 표준보육과정의 총론과 운영, 연령별 목표 및 내용, 그리고 관련 법규와 지침의 이해 순서로 살펴보겠습니다.</a:t>
             </a:r>
             <a:endParaRPr lang="en-US" dirty="0"/>
           </a:p>
@@ -1158,10 +1151,9 @@
           <a:p>
             <a:r>
               <a:rPr lang="en-US" dirty="0"/>
-              <a:t>어린이집과 유치원이 교육과정을 계획할 때는 교육과정에 대한 전문 지식만 있으면 되는 게 아닙니다. 여러 가지 기준을 함께 살펴봐야 해요.
-우리 원이 추구하는 교육 방향, 나라에서 정한 교육과정, 우리 지역의 유아교육 방향, 그해의 유치원 교육과정 편성·운영 지침, 어린이집 보육사업안내 등을 모두 참고합니다.
-오른쪽 표를 보시면, 나라에서 정한 교육과정은 이렇게 나뉩니다. 0~2세는 어린이집의 표준보육과정만 있고, 3~5세는 어린이집이든 유치원이든 누리과정으로 내용이 같습니다.
-그래서 선생님들이 함께 이 교육과정을 공부하고, 우리 기관에 어떻게 반영할지 의논하는 것이 중요합니다. 오늘은 어린이집의 표준보육과정을 중심으로 살펴보겠습니다.</a:t>
+              <a:t>어린이집과 유치원의 교육과정을 계획하고 운영하기 위해서는 교육과정에 대한 전문적 지식만 필요한 것이 아닙니다. 각 원이 추구하는 교육 방향뿐 아니라 국가수준의 교육과정, 소속한 지역의 유아교육 방향, 해당 연도의 유치원 교육과정 편성·운영 지침, 어린이집 보육사업안내 등을 지침으로 운영해야 하기 때문입니다.
+어린이집은 표준보육과정, 유치원은 유치원 교육과정(누리과정)이 고시되어 있으므로 교원이 함께 이를 연구하고 각 기관의 교육에 어떻게 반영할지 협의하도록 합니다.
+표 5-1과 같이 3~5세는 공통교육과정(누리과정)을 적용하여 내용이 동일하므로, 여기서는 제4차 표준보육과정(보건복지부 고시 제2020-75호, 2020. 4. 9)을 중심으로 살펴보겠습니다.</a:t>
             </a:r>
             <a:endParaRPr lang="en-US" dirty="0"/>
           </a:p>
@@ -1249,10 +1241,11 @@
           <a:p>
             <a:r>
               <a:rPr lang="en-US" dirty="0"/>
-              <a:t>먼저 표준보육과정이 어떤 사람으로 키우고 싶은지, 즉 '추구하는 인간상'입니다. 건강한 사람, 자주적인 사람, 창의적인 사람, 감성이 풍부한 사람, 더불어 사는 사람, 이렇게 다섯 가지예요.
-표준보육과정의 목적은 아이들이 놀이를 통해 몸과 마음이 건강하게 골고루 자라고, 바른 인성과 민주 시민의 기초를 기르는 것입니다.
-목표는 0~2세와 3~5세로 나뉘는데, 다섯 가지 목표를 인간상과 나란히 놓고 보면 서로 짝을 이루는 것을 볼 수 있어요.
-차이를 보면, 0~2세는 '관심을 가진다', '스스로 하고자 한다'처럼 시작하는 단계이고, 3~5세는 '생활습관을 기른다', '해결하는 능력을 기른다', '태도를 기른다'처럼 한 단계 더 나아갑니다. 나이에 맞게 목표가 조금씩 깊어지는 거예요.</a:t>
+              <a:t>먼저 표준보육과정의 총론입니다. 추구하는 인간상은 건강한 사람, 자주적인 사람, 창의적인 사람, 감성이 풍부한 사람, 더불어 사는 사람입니다.
+표준보육과정의 목적은 영유아가 놀이를 통해 심신의 건강과 조화로운 발달을 이루고, 바른 인성과 민주 시민의 기초를 형성하는 데에 있습니다.
+이를 실현하기 위한 목표는 다음과 같습니다.
+0~1세 보육과정 및 2세 보육과정 목표는 자신의 소중함을 알고 건강하고 안전한 환경에서 즐겁게 생활한다, 자신의 일을 스스로 하고자 한다, 호기심을 가지고 탐색하며 상상력을 기른다, 일상에서 아름다움에 관심을 가지고 감성을 기른다, 사람과 자연을 존중하고 소통하는 데 관심을 가진다 입니다.
+3~5세 보육과정 목표는 자신의 소중함을 알고 건강하고 안전한 생활습관을 기른다, 자신의 일을 스스로 해결하는 기초능력을 기른다, 호기심과 탐구심을 가지고 상상력과 창의력을 기른다, 일상에서 아름다움을 느끼고 문화적 감수성을 기른다, 사람과 자연을 존중하고 배려하며 소통하는 태도를 기른다 입니다.</a:t>
             </a:r>
             <a:endParaRPr lang="en-US" dirty="0"/>
           </a:p>
@@ -1340,12 +1333,12 @@
           <a:p>
             <a:r>
               <a:rPr lang="en-US" dirty="0"/>
-              <a:t>다음은 표준보육과정을 만들 때 중요하게 생각한 점, '구성의 중점'입니다. 기본 전제는 아이 한 명 한 명이 저마다의 특성을 가진 소중한 존재라는 것이에요.
-첫째, 0~5세 모든 아이에게 적용할 수 있게 만들었습니다.
-둘째, 앞에서 본 인간상을 이루기 위한 지식, 기능, 태도와 가치를 담았습니다.
-셋째, 신체운동·건강, 의사소통, 사회관계, 예술경험, 자연탐구의 5개 영역을 중심으로 구성했습니다.
-넷째, 0~5세 아이들이 꼭 경험해야 할 내용으로 채웠습니다.
-다섯째, 초등학교 교육과정과 자연스럽게 이어지도록 했습니다.</a:t>
+              <a:t>표준보육과정은 영유아가 개별적인 특성을 지닌 고유한 존재임을 전제로 다음 사항에 중점을 두고 구성합니다.
+가. 0~5세 모든 영유아에게 적용할 수 있도록 구성한다.
+나. 추구하는 인간상 구현을 위한 지식, 기능, 태도 및 가치를 반영하여 구성한다.
+다. 신체운동·건강, 의사소통, 사회관계, 예술경험, 자연탐구의 5개 영역을 중심으로 구성한다.
+라. 0~5세 영유아가 경험해야 할 내용으로 구성한다.
+마. 초등학교 교육과정과의 연계성을 고려하여 구성한다.</a:t>
             </a:r>
             <a:endParaRPr lang="en-US" dirty="0"/>
           </a:p>
@@ -1433,10 +1426,10 @@
           <a:p>
             <a:r>
               <a:rPr lang="en-US" dirty="0"/>
-              <a:t>그럼 실제로 어떻게 운영할까요? 편성·운영, 교수·학습, 평가 세 부분으로 나눠 볼게요.
-편성·운영에서는 기관의 운영 시간과 형편에 맞게 계획을 세우고, 하루 일과에 바깥놀이를 넣어 충분히 놀 수 있게 합니다. 성별, 장애, 종교, 가족이나 문화 배경 때문에 차별받지 않도록 하고, 아이의 발달과 장애 정도에 맞게 조정합니다. 가정, 지역사회와 함께하고, 교사 연수를 통해 계속 더 좋아지도록 합니다.
-교수·학습에서는 아이가 흥미에 따라 자유롭게 놀고, 놀이를 통해 배우도록 합니다. 실내외 환경을 다양하게 꾸미고, 아이와 친구, 아이와 선생님, 아이와 환경이 활발하게 주고받도록 합니다. 5개 영역이 아이의 경험 속에서 자연스럽게 합쳐지게 하고, 쉬는 것과 일상생활, 배우는 방식도 아이마다 맞춰 줍니다.
-평가는 운영이 잘 되고 있는지 점검하고 더 좋게 만들기 위해 합니다. 아이의 특성과 변화, 그리고 운영이 잘 되었는지를 평가하고, 목적에 맞는 방법을 씁니다. 평가 결과는 아이를 더 잘 이해하고 운영을 고치는 자료로 활용합니다.</a:t>
+              <a:t>다음은 표준보육과정의 운영입니다.
+먼저 편성·운영입니다. 각 기관의 운영 시간에 맞추어 편성하고, 표준보육과정을 바탕으로 각 기관의 실정에 적합한 계획을 수립하여 운영합니다. 하루일과에서 바깥놀이를 포함하여 영유아의 놀이가 충분히 이루어지도록 편성하고, 성, 신체적 특성, 장애, 종교, 가족 및 문화적 배경 등에 따른 차별이 없도록 편성하여 운영합니다. 영유아의 발달과 장애 정도에 따라 조정하여 운영하고, 가정과 지역사회와의 협력과 참여에 기반하여 운영하며, 교사 연수를 통해 표준보육과정의 운영을 개선할 수 있도록 합니다.
+교수·학습에서 교사는 영유아가 흥미와 관심에 따라 놀이에 자유롭게 참여하고 즐기도록 하고, 놀이를 통해 배우도록 합니다. 다양한 놀이와 활동을 경험할 수 있도록 실내외 환경을 구성하고, 영유아와 영유아, 영유아와 교사, 영유아와 환경 사이에 능동적인 상호작용이 이루어지도록 합니다. 5개 영역의 내용이 통합적으로 영유아의 경험과 연계되도록 하고, 개별 영유아의 요구에 따라 휴식과 일상생활이 원활히 이루어지도록 하며, 영유아의 연령, 발달, 장애, 배경 등을 고려하여 개별 특성에 적합한 방식으로 배우도록 합니다.
+평가는 표준보육과정 운영의 질을 진단하고 개선하기 위해 계획하고 실시합니다. 영유아의 특성 및 변화 정도와 표준보육과정의 운영을 평가하고, 평가의 목적에 따라 적합한 방법을 사용하여 평가합니다. 평가의 결과는 영유아에 대한 이해와 표준보육과정 운영 개선을 위한 자료로 활용할 수 있습니다.</a:t>
             </a:r>
             <a:endParaRPr lang="en-US" dirty="0"/>
           </a:p>
@@ -1525,9 +1518,9 @@
             <a:r>
               <a:rPr lang="en-US" dirty="0"/>
               <a:t>오늘 발표 순서입니다.
-첫째, 교육과정이 무엇이고 어떻게 바뀌어 왔는지 알아보는 '영유아교육과정의 이해'.
-둘째, 교육과정이 무엇으로 이루어져 있고 어떤 특징을 가져야 하는지 보는 '영유아교육과정의 구성'.
-셋째, 실제로 어떻게 계획하고 운영하는지 보는 '영유아교육과정의 계획 및 운영'입니다.</a:t>
+첫째, '영유아교육과정의 이해'.
+둘째, '영유아교육과정의 구성'.
+셋째, '영유아교육과정의 계획 및 운영'입니다.</a:t>
             </a:r>
             <a:endParaRPr lang="en-US" dirty="0"/>
           </a:p>
@@ -1615,15 +1608,14 @@
           <a:p>
             <a:r>
               <a:rPr lang="en-US" dirty="0"/>
-              <a:t>이번에는 연령별 목표와 내용입니다. 교재에는 0~1세, 2세, 3~5세로 나눈 자세한 표가 있는데요(교육부고시 제2024-23호), 오늘은 큰 틀만 보겠습니다.
-모든 연령이 똑같이 5개 영역으로 되어 있고, 각 영역 안에 '내용범주'가 있습니다.
-신체운동·건강은 신체활동 즐기기, 건강하게 생활하기, 안전하게 생활하기.
-의사소통은 듣기와 말하기, 읽기와 쓰기에 관심 가지기, 책과 이야기 즐기기.
-사회관계는 나를 알고 존중하기, 더불어 생활하기.
-예술경험은 아름다움 찾아보기, 창의적으로 표현하기.
+              <a:t>0~1세, 2세, 3~5세 연령별 목표 및 내용은 표 5-2, 표 5-3, 표 5-4에 제시되어 있습니다(교육부고시 제2024-23호). 3~5세 영역별 목표 및 내용은 유치원교육과정과 동일합니다.
+세 연령 모두 신체운동·건강, 의사소통, 사회관계, 예술경험, 자연탐구의 5개 영역으로 되어 있습니다.
+신체운동·건강의 내용범주는 신체활동 즐기기, 건강하게 생활하기, 안전하게 생활하기입니다.
+의사소통은 듣기와 말하기, 읽기와 쓰기에 관심 가지기, 책과 이야기 즐기기입니다.
+사회관계는 나를 알고 존중하기, 더불어 생활하기이고, 3~5세에는 사회에 관심 가지기가 있습니다.
+예술경험은 아름다움 찾아보기, 창의적으로 표현하기이고, 3~5세에는 예술 감상하기가 있습니다.
 자연탐구는 탐구 과정 즐기기, 생활 속에서 탐구하기, 자연과 더불어 살기입니다.
-3~5세가 되면 사회관계에 '사회에 관심 가지기', 예술경험에 '예술 감상하기'가 더해집니다.
-같은 범주라도 나이에 따라 내용이 깊어져요. 예를 들어 '안전하게 생활하기'를 보면, 0~1세는 '위험하다는 말에 주의한다', 2세는 '위험한 상황에 대처하는 방법을 경험한다', 3~5세는 '안전사고, 화재, 재난, 학대, 유괴 등에 대처하는 방법을 경험한다'로 점점 넓어집니다.</a:t>
+예를 들어 '안전하게 생활하기'의 내용을 보면, 0~1세는 '위험하다는 말에 주의한다', 2세는 '위험한 상황에 대처하는 방법을 경험한다', 3~5세는 '안전사고, 화재, 재난, 학대, 유괴 등에 대처하는 방법을 경험한다'로 제시되어 있습니다.</a:t>
             </a:r>
             <a:endParaRPr lang="en-US" dirty="0"/>
           </a:p>
@@ -1711,12 +1703,11 @@
           <a:p>
             <a:r>
               <a:rPr lang="en-US" dirty="0"/>
-              <a:t>마지막으로 관련 법규와 지침입니다. 교육과정을 계획할 때는 먼저 교육청의 지침을 확인하고, 꼭 가르쳐야 하는 내용이 있으면 반드시 넣어야 합니다. 교육청 지침에는 바뀐 법의 내용과 지역 교육청, 지방자치단체의 지침이 담겨 있기 때문이에요.
-유치원은 매년 교육청별 유치원 교육과정 편성·운영 지침과 유아교육계획을, 어린이집은 보육사업안내서와 업무별 매뉴얼을 참고하면 됩니다. 교육청마다 내용이 다를 수 있으니 꼭 우리 교육청 자료를 봐야 하고, 운영계획서나 1년 학사일정을 짤 때도 마찬가지입니다.
-오른쪽은 예시로 2025학년도 경기도 유치원 교육과정 편성·운영 지침의 목차입니다(경기도교육청, 2025). 경기교육의 방향부터 영역별 목표와 내용, 운영 지원까지 다섯 부분으로 되어 있어요.
-정리하면, 교육과정을 잘 운영하려면 나라의 교육과정을 이해하고, 지역과 기관의 지침까지 함께 살펴야 한다는 것입니다.
-오늘 발표를 한 줄로 정리하면, 교육과정은 아이가 골고루 자라도록 돕는 설계도이고, 놀이를 중심으로 구성하며, 나라와 지역의 기준을 바탕으로 우리 기관에 맞게 운영한다는 것입니다.
-이상으로 발표를 마치겠습니다. 들어 주셔서 감사합니다.</a:t>
+              <a:t>다음은 관련 법규와 지침의 이해입니다.
+유아교육기관의 교육과정을 계획하는 경우에도 사전에 교육청의 지침을 파악하며, 필수 교육 내용이 있는 경우 이를 교육과정에 반영하여야 합니다. 관련청의 지침은 유치원과 어린이집에 적용되는 법령의 변경 사항을 정확하게 반영하면서, 아울러 각 지역 교육청과 지방자치단체의 지침 사항을 반영하고 있는 중요한 문서입니다.
+유치원의 경우 매년 교육청별 유치원교육과정 편성·운영지침과 유아교육계획을 참조하며, 어린이집은 보육사업안내서와 업무별 매뉴얼을 참고하면 됩니다. 또한 상위법에 따라 교육청이 정하도록 되어 있는 내용에 대해서는 각 교육청마다 다를 수 있으므로 반드시 소속 교육청의 계획서와 지침을 참조하도록 합니다. 매년 운영계획서를 작성하고 연간 학사일정 등을 정할 때도 소속청의 지침을 숙지하고 반영합니다.
+표 5-5는 2025학년도 경기도 유치원 교육과정 편성·운영 지침의 목차입니다(경기도교육청, 2025). 제1부 경기교육의 방향, 제2부 경기유아교육의 방향, 제3부 경기도 유치원 교육과정 편성·운영, 제4부 경기도 유치원 교육과정 영역별 목표 및 내용, 제5부 경기도 유치원 교육과정 편성·운영 지원으로 구성되어 있습니다.
+이상으로 5장 '교육과정의 계획과 운영' 발표를 마치겠습니다. 들어 주셔서 감사합니다.</a:t>
             </a:r>
             <a:endParaRPr lang="en-US" dirty="0"/>
           </a:p>
@@ -1805,7 +1796,7 @@
             <a:r>
               <a:rPr lang="en-US" dirty="0"/>
               <a:t>먼저 첫 번째 부분, '영유아교육과정의 이해'입니다.
-유치원과 어린이집에서 아이들에게 '무엇을, 어떻게 가르칠지' 정해 놓은 계획, 즉 교육과정이 무슨 뜻인지 알아보고, 어떻게 바뀌어 왔는지, 요즘 누리과정은 어떤 방향인지 살펴보겠습니다.</a:t>
+교육과정의 정의, 유치원교육과정과 누리과정, 어린이집 표준보육과정, 그리고 2019 개정 누리과정의 혁신 방향 순서로 살펴보겠습니다.</a:t>
             </a:r>
             <a:endParaRPr lang="en-US" dirty="0"/>
           </a:p>
@@ -1893,10 +1884,10 @@
           <a:p>
             <a:r>
               <a:rPr lang="en-US" dirty="0"/>
-              <a:t>교육과정이라는 말, 많이 들어 보셨죠? 간단히 말하면 '무엇을, 어떤 순서로 가르치고 배울지 정리한 것'입니다.
-그런데 누구 입장에서 보느냐에 따라 뜻이 조금 달라져요. 선생님 입장에서 보면 '가르칠 내용과 계획'이고, 학생 입장에서 보면 '실제로 배우고 경험한 것'입니다(이귀윤, 1990).
-오른쪽 그림을 보시면, 넓게 보면 학생이 경험하는 모든 것이 교육과정이고, 좁게 보면 미리 짜 놓은 과목이나 수업 계획만을 말합니다.
-방인옥 등(1999)은 교육과정을 '아이가 몸과 마음 모두 골고루 자라도록 돕기 위해, 가르치고 배우는 경험을 잘 짜 놓은 설계도'라고 했습니다. 집을 지을 때 설계도가 필요하듯이, 교육에도 설계도가 필요하다는 뜻이에요.</a:t>
+              <a:t>유치원과 어린이집 운영의 가장 기본적인 목적은 영유아를 교육하기 위한 우수한 교육과정을 운영하는 것입니다.
+교육과정이란 목표와 일정한 순서로 배열된 학습의 코스와 더불어 교육내용이나 경험내용을 의미합니다. 이는 교사를 중심으로 보면 가르치는 내용이나 교과 혹은 의도적 계획으로 정의되며, 배우는 학생을 중심으로 보면 학습경험 또는 학습 결과로 정의됩니다(이귀윤, 1990).
+또한 방인옥 등(1999)은 교육과정을 '학습자의 전인적 성장과 발달을 돕기 위해서 학교가 의미하는 교육적 상황을 마련하고 모든 종류의 교수-학습 경험을 체계적으로 구성한 설계도'라고 정의하고 있습니다.
+넓은 의미로는 '학생이 경험하는 모든 것'이라고 정의하기도 하고, 좁은 의미로는 '계획된 교과목 또는 교수요목'으로 정의하기도 합니다.</a:t>
             </a:r>
             <a:endParaRPr lang="en-US" dirty="0"/>
           </a:p>
@@ -1984,11 +1975,9 @@
           <a:p>
             <a:r>
               <a:rPr lang="en-US" dirty="0"/>
-              <a:t>그럼 유치원 교육과정은 어떻게 바뀌어 왔을까요?
-우리나라 유치원 교육과정은 1969년에 처음 만들어졌고, 2007년까지 모두 여섯 번 고쳐졌습니다.
-그런데 예전에는 유치원은 유치원 교육과정, 어린이집은 표준보육과정, 이렇게 따로따로였어요. 같은 나이의 아이인데도 다니는 곳에 따라 배우는 내용이 달랐던 거죠.
-그래서 둘을 하나로 합친 것이 바로 '누리과정'입니다. 목적은 두 가지예요. 첫째, 초등학교에 들어가기 전 교육의 질을 높이는 것. 둘째, 어디에 다니든 모든 아이가 같은 출발선에서 시작할 수 있게 하는 것입니다.
-누리과정은 2013년부터 만 3~5세 아이들에게 적용되었고, 2020년부터는 '아이 중심, 놀이 중심'으로 바뀐 개정 누리과정을 쓰고 있습니다.</a:t>
+              <a:t>우리나라 유치원교육과정은 1969년 처음으로 제정된 이후 2007년에 이르기까지 여섯 차례 개정되었습니다.
+현재는 유치원과 어린이집 3~5세를 위한 공통교육과정으로 누리과정을 시행하고 있습니다. 누리과정은 지금까지 이원화되어 있는 유치원교육과정과 어린이집 표준보육과정을 일원화하여 취학 전 교육의 질을 제고하여, 생애초기 출발점 평등을 보장하려는 취지로 개발된 것입니다(교육과학기술부·보건복지부, 2012; 2013; 2019).
+2013년에는 유치원과 어린이집 교육·보육과정을 통합하여 만 3~5세 유아를 위한 누리과정이 시행되었으며, 2020년부터 유아중심·놀이중심의 개정 누리과정이 적용되고 있습니다.</a:t>
             </a:r>
             <a:endParaRPr lang="en-US" dirty="0"/>
           </a:p>
@@ -2076,10 +2065,10 @@
           <a:p>
             <a:r>
               <a:rPr lang="en-US" dirty="0"/>
-              <a:t>이번에는 어린이집의 표준보육과정입니다. 표준보육과정은 어린이집에서 아이들이 배우고 경험해야 할 것을 나라에서 정해 놓은 기준이에요.
-왜 필요해졌을까요? 1990년대 후반부터 어린이집이 크게 늘었습니다. 핵가족이 많아지고, 일하는 엄마들도 계속 늘었고, 어릴 때의 경험이 아이 발달에 아주 중요하다는 생각도 커졌기 때문이에요.
-이제 어린이집은 일부 가정만 보내는 곳이 아니라, 누구나 다니는 곳이 되었습니다. 그러다 보니 '어린이집마다 제각각 하지 말고, 나라에서 공통 기준을 정해 주자'는 필요가 생긴 거죠.
-그래서 2004년 영유아보육법에 '표준보육과정을 만들어 보급해야 한다'는 내용이 들어갔고, 2007년에 처음 발표되었습니다. 이후 2013년에 3차, 2020년에 4차로 바뀌었고, 2025년에는 0~2세 아이들을 위한 2024 개정 표준보육과정이 나왔습니다.</a:t>
+              <a:t>어린이집은 국가수준 보육과정으로 표준보육과정이 보급되었습니다. 표준보육과정이란 어린이집에서 영유아가 경험해야 할 바람직한 태도와 가치, 지식, 기술 등을 제시한 국가수준의 보편적 교육과정입니다.
+표준보육과정의 개발은 1990년대 후반 어린이집의 양적인 증가와 관련되어 있습니다. 핵가족화와 취업모의 지속적인 증가, 그리고 출생 후 조기 경험이 인간의 발달에 결정적이라는 영유아기 교육에 대한 중요성이 더욱 부각되면서 영유아가 어린이집에 다니는 것이 보편화되었습니다. 이에 어린이집에서 영유아에게 언제, 무엇을 목표로 어떤 경험을 제공할 것인가에 대한 국가수준의 지침이 필요하게 되었습니다.
+2004년 1월 29일 전면 개정된 영유아보육법 제29조 제2항에 표준보육과정을 개발, 보급하여야 함이 명시되었습니다. 2007년에 표준보육과정이 공포되었으며, 이후 2013년에 제3차 어린이집 표준보육과정으로 개정되고(보건복지부, 2013b), 2020년에는 제4차 어린이집 표준보육과정이 고시되었습니다(보건복지부, 2020).
+그리고 2025년에는 「유보통합 실행계획(안)」에서 0~5세 영유아교육과정이 마련되기 전에 표준보육과정(0~2세)의 일부개정의 필요성에 따라 2024 개정 표준보육과정(0~2세)이 고시되었습니다.</a:t>
             </a:r>
             <a:endParaRPr lang="en-US" dirty="0"/>
           </a:p>
@@ -2167,11 +2156,12 @@
           <a:p>
             <a:r>
               <a:rPr lang="en-US" dirty="0"/>
-              <a:t>그럼 지금 쓰고 있는 2019 개정 누리과정은 무엇이 달라졌을까요? 모든 아이가 같은 출발선에서 시작하게 하자는 교육부의 계획(교육부, 2017)에 따라 바뀌었고, 크게 세 가지가 달라졌습니다.
-첫째, 초등학교 공부를 미리 준비시키는 대신, 아이 한 명 한 명의 특성을 살피도록 했습니다.
-둘째, 선생님이 짜 놓은 계획대로 가르치기보다 아이들이 자유롭게 놀게 하고, 선생님은 옆에서 잘 지켜보고 기록하면서 함께하도록 했습니다.
-셋째, 예전에는 5개 영역, 주제, 소주제처럼 너무 자세하게 정해져 있었는데, 이것을 줄여서 현장 선생님들이 상황에 맞게 판단할 수 있게 했습니다.
-한마디로 '아이 중심, 놀이 중심'이고, 2020년부터 유치원과 어린이집 모두에서 쓰이고 있습니다.</a:t>
+              <a:t>유치원과 어린이집의 공통교육과정인 2019 개정 누리과정은 교육부가 출발선 평등을 실현하기 위한 '유아교육 혁신방안'에 의거하여 개정된 것입니다.
+혁신방향은 다음과 같습니다.
+첫째, 초등학교 준비 위주의 학습보다는 개별 유아에 대한 다양한 특성을 고려한 내용으로 구성해야 한다.
+둘째, 교사계획서 위주, 학습 위주의 교육보다는 유아의 자유놀이를 권장하며 관찰과 기록 등 유아와의 상호작용을 강조해야 한다.
+셋째, 5개 영역, 주제-소주제 등 구성체계가 지나치게 세부적이므로 현장의 자율성을 존중하기 위해 세부내용을 삭제해야 한다(교육부, 2017).
+이와 같은 방향을 반영하여 '유아 중심·놀이 중심 교육과정'으로 개정된 누리과정은 2020년부터 유치원과 어린이집 공통교육과정으로 적용되고 있습니다.</a:t>
             </a:r>
             <a:endParaRPr lang="en-US" dirty="0"/>
           </a:p>
@@ -2259,12 +2249,9 @@
           <a:p>
             <a:r>
               <a:rPr lang="en-US" dirty="0"/>
-              <a:t>마지막으로 정리하겠습니다. 지금 0~2세 아이들은 어린이집 표준보육과정을, 3~5세 아이들은 유치원이든 어린이집이든 똑같이 누리과정을 따릅니다.
-세 가지만 기억해 주세요.
-하나, 교육과정은 아이가 골고루 자라도록 돕는 교육의 설계도입니다.
-둘, 누리과정은 따로 있던 유치원과 어린이집의 교육과정을 하나로 합친 것입니다.
-셋, 2019 개정 누리과정의 핵심은 아이 중심, 놀이 중심입니다.
-다음으로, 이런 교육과정이 무엇으로 이루어져 있는지 살펴보겠습니다.</a:t>
+              <a:t>정리하겠습니다. 0~2세는 어린이집 표준보육과정, 3~5세는 유치원과 어린이집의 공통교육과정인 누리과정이 적용됩니다.
+교육과정은 학습자의 전인적 성장과 발달을 돕기 위해 모든 종류의 교수-학습 경험을 체계적으로 구성한 설계도입니다. 누리과정은 이원화되어 있던 유치원교육과정과 어린이집 표준보육과정을 일원화하여 취학 전 교육의 질을 제고하고 생애초기 출발점 평등을 보장하려는 취지로 개발되었습니다. 그리고 2019 개정 누리과정은 '유아 중심·놀이 중심 교육과정'으로 개정되었습니다.
+다음으로 두 번째 부분, '영유아교육과정의 구성'을 살펴보겠습니다.</a:t>
             </a:r>
             <a:endParaRPr lang="en-US" dirty="0"/>
           </a:p>
@@ -2353,7 +2340,7 @@
             <a:r>
               <a:rPr lang="en-US" dirty="0"/>
               <a:t>두 번째 부분은 '영유아교육과정의 구성'입니다.
-교육과정이 무엇으로 이루어져 있는지, 그리고 영유아를 위한 교육과정은 어떤 특징을 가져야 하는지 말씀드리겠습니다.</a:t>
+교육과정의 구성 요소와 교육과정 구성의 특징 순서로 살펴보겠습니다.</a:t>
             </a:r>
             <a:endParaRPr lang="en-US" dirty="0"/>
           </a:p>
@@ -3265,8 +3252,8 @@
         </p:nvSpPr>
         <p:spPr>
           <a:xfrm>
-            <a:off x="594360" y="2423160"/>
-            <a:ext cx="1645920" cy="822960"/>
+            <a:off x="566928" y="2331720"/>
+            <a:ext cx="1700784" cy="868680"/>
           </a:xfrm>
           <a:prstGeom prst="rect">
             <a:avLst/>
@@ -3282,7 +3269,7 @@
               <a:buNone/>
             </a:pPr>
             <a:r>
-              <a:rPr lang="en-US" sz="1200" dirty="0">
+              <a:rPr lang="en-US" sz="1100" dirty="0">
                 <a:solidFill>
                   <a:srgbClr val="6E7B73"/>
                 </a:solidFill>
@@ -3290,26 +3277,9 @@
                 <a:ea typeface="Malgun Gothic" pitchFamily="34" charset="-122"/>
                 <a:cs typeface="Malgun Gothic" pitchFamily="34" charset="-120"/>
               </a:rPr>
-              <a:t>학교가 성취해야 할</a:t>
-            </a:r>
-            <a:endParaRPr lang="en-US" sz="1200" dirty="0"/>
-          </a:p>
-          <a:p>
-            <a:pPr algn="ctr" indent="0" marL="0">
-              <a:buNone/>
-            </a:pPr>
-            <a:r>
-              <a:rPr lang="en-US" sz="1200" dirty="0">
-                <a:solidFill>
-                  <a:srgbClr val="6E7B73"/>
-                </a:solidFill>
-                <a:latin typeface="Malgun Gothic" pitchFamily="34" charset="0"/>
-                <a:ea typeface="Malgun Gothic" pitchFamily="34" charset="-122"/>
-                <a:cs typeface="Malgun Gothic" pitchFamily="34" charset="-120"/>
-              </a:rPr>
-              <a:t>교육목표는 무엇인가?</a:t>
-            </a:r>
-            <a:endParaRPr lang="en-US" sz="1200" dirty="0"/>
+              <a:t>학교가 성취해야 할 교육목표는 무엇인가?</a:t>
+            </a:r>
+            <a:endParaRPr lang="en-US" sz="1100" dirty="0"/>
           </a:p>
         </p:txBody>
       </p:sp>
@@ -3465,8 +3435,8 @@
         </p:nvSpPr>
         <p:spPr>
           <a:xfrm>
-            <a:off x="2697480" y="2423160"/>
-            <a:ext cx="1645920" cy="822960"/>
+            <a:off x="2670048" y="2331720"/>
+            <a:ext cx="1700784" cy="868680"/>
           </a:xfrm>
           <a:prstGeom prst="rect">
             <a:avLst/>
@@ -3482,7 +3452,7 @@
               <a:buNone/>
             </a:pPr>
             <a:r>
-              <a:rPr lang="en-US" sz="1200" dirty="0">
+              <a:rPr lang="en-US" sz="1100" dirty="0">
                 <a:solidFill>
                   <a:srgbClr val="6E7B73"/>
                 </a:solidFill>
@@ -3490,26 +3460,9 @@
                 <a:ea typeface="Malgun Gothic" pitchFamily="34" charset="-122"/>
                 <a:cs typeface="Malgun Gothic" pitchFamily="34" charset="-120"/>
               </a:rPr>
-              <a:t>목표 달성을 위해 어떤</a:t>
-            </a:r>
-            <a:endParaRPr lang="en-US" sz="1200" dirty="0"/>
-          </a:p>
-          <a:p>
-            <a:pPr algn="ctr" indent="0" marL="0">
-              <a:buNone/>
-            </a:pPr>
-            <a:r>
-              <a:rPr lang="en-US" sz="1200" dirty="0">
-                <a:solidFill>
-                  <a:srgbClr val="6E7B73"/>
-                </a:solidFill>
-                <a:latin typeface="Malgun Gothic" pitchFamily="34" charset="0"/>
-                <a:ea typeface="Malgun Gothic" pitchFamily="34" charset="-122"/>
-                <a:cs typeface="Malgun Gothic" pitchFamily="34" charset="-120"/>
-              </a:rPr>
-              <a:t>교육적 경험을 제공할까?</a:t>
-            </a:r>
-            <a:endParaRPr lang="en-US" sz="1200" dirty="0"/>
+              <a:t>교육목표를 달성하기 위해 어떤 교육적 경험이 제공될 수 있는가?</a:t>
+            </a:r>
+            <a:endParaRPr lang="en-US" sz="1100" dirty="0"/>
           </a:p>
         </p:txBody>
       </p:sp>
@@ -3665,8 +3618,8 @@
         </p:nvSpPr>
         <p:spPr>
           <a:xfrm>
-            <a:off x="4800600" y="2423160"/>
-            <a:ext cx="1645920" cy="822960"/>
+            <a:off x="4773168" y="2331720"/>
+            <a:ext cx="1700784" cy="868680"/>
           </a:xfrm>
           <a:prstGeom prst="rect">
             <a:avLst/>
@@ -3682,7 +3635,7 @@
               <a:buNone/>
             </a:pPr>
             <a:r>
-              <a:rPr lang="en-US" sz="1200" dirty="0">
+              <a:rPr lang="en-US" sz="1100" dirty="0">
                 <a:solidFill>
                   <a:srgbClr val="6E7B73"/>
                 </a:solidFill>
@@ -3690,26 +3643,9 @@
                 <a:ea typeface="Malgun Gothic" pitchFamily="34" charset="-122"/>
                 <a:cs typeface="Malgun Gothic" pitchFamily="34" charset="-120"/>
               </a:rPr>
-              <a:t>교육적 경험을 어떻게</a:t>
-            </a:r>
-            <a:endParaRPr lang="en-US" sz="1200" dirty="0"/>
-          </a:p>
-          <a:p>
-            <a:pPr algn="ctr" indent="0" marL="0">
-              <a:buNone/>
-            </a:pPr>
-            <a:r>
-              <a:rPr lang="en-US" sz="1200" dirty="0">
-                <a:solidFill>
-                  <a:srgbClr val="6E7B73"/>
-                </a:solidFill>
-                <a:latin typeface="Malgun Gothic" pitchFamily="34" charset="0"/>
-                <a:ea typeface="Malgun Gothic" pitchFamily="34" charset="-122"/>
-                <a:cs typeface="Malgun Gothic" pitchFamily="34" charset="-120"/>
-              </a:rPr>
-              <a:t>효과적으로 조직할까?</a:t>
-            </a:r>
-            <a:endParaRPr lang="en-US" sz="1200" dirty="0"/>
+              <a:t>교육적 경험은 어떻게 하면 가장 효과적으로 조직할 수 있는가?</a:t>
+            </a:r>
+            <a:endParaRPr lang="en-US" sz="1100" dirty="0"/>
           </a:p>
         </p:txBody>
       </p:sp>
@@ -3865,8 +3801,8 @@
         </p:nvSpPr>
         <p:spPr>
           <a:xfrm>
-            <a:off x="6903720" y="2423160"/>
-            <a:ext cx="1645920" cy="822960"/>
+            <a:off x="6876288" y="2331720"/>
+            <a:ext cx="1700784" cy="868680"/>
           </a:xfrm>
           <a:prstGeom prst="rect">
             <a:avLst/>
@@ -3882,7 +3818,7 @@
               <a:buNone/>
             </a:pPr>
             <a:r>
-              <a:rPr lang="en-US" sz="1200" dirty="0">
+              <a:rPr lang="en-US" sz="1100" dirty="0">
                 <a:solidFill>
                   <a:srgbClr val="6E7B73"/>
                 </a:solidFill>
@@ -3890,26 +3826,9 @@
                 <a:ea typeface="Malgun Gothic" pitchFamily="34" charset="-122"/>
                 <a:cs typeface="Malgun Gothic" pitchFamily="34" charset="-120"/>
               </a:rPr>
-              <a:t>목표가 달성되었는지</a:t>
-            </a:r>
-            <a:endParaRPr lang="en-US" sz="1200" dirty="0"/>
-          </a:p>
-          <a:p>
-            <a:pPr algn="ctr" indent="0" marL="0">
-              <a:buNone/>
-            </a:pPr>
-            <a:r>
-              <a:rPr lang="en-US" sz="1200" dirty="0">
-                <a:solidFill>
-                  <a:srgbClr val="6E7B73"/>
-                </a:solidFill>
-                <a:latin typeface="Malgun Gothic" pitchFamily="34" charset="0"/>
-                <a:ea typeface="Malgun Gothic" pitchFamily="34" charset="-122"/>
-                <a:cs typeface="Malgun Gothic" pitchFamily="34" charset="-120"/>
-              </a:rPr>
-              <a:t>어떻게 알 수 있을까?</a:t>
-            </a:r>
-            <a:endParaRPr lang="en-US" sz="1200" dirty="0"/>
+              <a:t>교육목표들이 달성되었는지를 어떻게 알 수 있는가?</a:t>
+            </a:r>
+            <a:endParaRPr lang="en-US" sz="1100" dirty="0"/>
           </a:p>
         </p:txBody>
       </p:sp>
@@ -4024,7 +3943,7 @@
                 <a:ea typeface="Malgun Gothic" pitchFamily="34" charset="-122"/>
                 <a:cs typeface="Malgun Gothic" pitchFamily="34" charset="-120"/>
               </a:rPr>
-              <a:t>→ 우리나라 영유아교육과정에도 이 네 가지 요소가 포함된다</a:t>
+              <a:t>→ 우리나라 영유아교육과정을 구성하는 기본 요소에도 네 가지 요소가 포함된다</a:t>
             </a:r>
             <a:endParaRPr lang="en-US" sz="1400" dirty="0"/>
           </a:p>
@@ -4216,7 +4135,7 @@
                 <a:ea typeface="Malgun Gothic" pitchFamily="34" charset="-122"/>
                 <a:cs typeface="Malgun Gothic" pitchFamily="34" charset="-120"/>
               </a:rPr>
-              <a:t>계속</a:t>
+              <a:t>실행</a:t>
             </a:r>
             <a:endParaRPr lang="en-US" sz="1400" dirty="0"/>
           </a:p>
@@ -4233,7 +4152,7 @@
                 <a:ea typeface="Malgun Gothic" pitchFamily="34" charset="-122"/>
                 <a:cs typeface="Malgun Gothic" pitchFamily="34" charset="-120"/>
               </a:rPr>
-              <a:t>순환</a:t>
+              <a:t>순서</a:t>
             </a:r>
             <a:endParaRPr lang="en-US" sz="1400" dirty="0"/>
           </a:p>
@@ -4875,7 +4794,7 @@
                 <a:ea typeface="Malgun Gothic" pitchFamily="34" charset="-122"/>
                 <a:cs typeface="Malgun Gothic" pitchFamily="34" charset="-120"/>
               </a:rPr>
-              <a:t>다음 계획에</a:t>
+              <a:t>차기 교육계획</a:t>
             </a:r>
             <a:endParaRPr lang="en-US" sz="1100" dirty="0"/>
           </a:p>
@@ -4892,7 +4811,7 @@
                 <a:ea typeface="Malgun Gothic" pitchFamily="34" charset="-122"/>
                 <a:cs typeface="Malgun Gothic" pitchFamily="34" charset="-120"/>
               </a:rPr>
-              <a:t>반영</a:t>
+              <a:t>수립에 반영</a:t>
             </a:r>
             <a:endParaRPr lang="en-US" sz="1100" dirty="0"/>
           </a:p>
@@ -4953,7 +4872,7 @@
                 <a:ea typeface="Malgun Gothic" pitchFamily="34" charset="-122"/>
                 <a:cs typeface="Malgun Gothic" pitchFamily="34" charset="-120"/>
               </a:rPr>
-              <a:t>각 단계의 기준</a:t>
+              <a:t>구성요소이자 실행 순서</a:t>
             </a:r>
             <a:endParaRPr lang="en-US" sz="1400" dirty="0"/>
           </a:p>
@@ -4967,8 +4886,8 @@
         </p:nvSpPr>
         <p:spPr>
           <a:xfrm>
-            <a:off x="5577840" y="1737360"/>
-            <a:ext cx="3017520" cy="914400"/>
+            <a:off x="5577840" y="1691640"/>
+            <a:ext cx="3017520" cy="1005840"/>
           </a:xfrm>
           <a:prstGeom prst="rect">
             <a:avLst/>
@@ -4982,13 +4901,13 @@
           <a:p>
             <a:pPr marL="342900" indent="-342900">
               <a:spcAft>
-                <a:spcPts val="400"/>
+                <a:spcPts val="300"/>
               </a:spcAft>
               <a:buSzPct val="100000"/>
               <a:buChar char="•"/>
             </a:pPr>
             <a:r>
-              <a:rPr lang="en-US" sz="1200" dirty="0">
+              <a:rPr lang="en-US" sz="1050" dirty="0">
                 <a:solidFill>
                   <a:srgbClr val="33413A"/>
                 </a:solidFill>
@@ -4996,20 +4915,20 @@
                 <a:ea typeface="Malgun Gothic" pitchFamily="34" charset="-122"/>
                 <a:cs typeface="Malgun Gothic" pitchFamily="34" charset="-120"/>
               </a:rPr>
-              <a:t>목표: 기관의 철학에 부합</a:t>
-            </a:r>
-            <a:endParaRPr lang="en-US" sz="1200" dirty="0"/>
+              <a:t>각 기관의 철학에 부합하는 교육목표의 설정</a:t>
+            </a:r>
+            <a:endParaRPr lang="en-US" sz="1050" dirty="0"/>
           </a:p>
           <a:p>
             <a:pPr marL="342900" indent="-342900">
               <a:spcAft>
-                <a:spcPts val="400"/>
+                <a:spcPts val="300"/>
               </a:spcAft>
               <a:buSzPct val="100000"/>
               <a:buChar char="•"/>
             </a:pPr>
             <a:r>
-              <a:rPr lang="en-US" sz="1200" dirty="0">
+              <a:rPr lang="en-US" sz="1050" dirty="0">
                 <a:solidFill>
                   <a:srgbClr val="33413A"/>
                 </a:solidFill>
@@ -5017,20 +4936,20 @@
                 <a:ea typeface="Malgun Gothic" pitchFamily="34" charset="-122"/>
                 <a:cs typeface="Malgun Gothic" pitchFamily="34" charset="-120"/>
               </a:rPr>
-              <a:t>내용: 목표 달성에 꼭 필요한 것</a:t>
-            </a:r>
-            <a:endParaRPr lang="en-US" sz="1200" dirty="0"/>
+              <a:t>교육목표 달성에 반드시 필요한 교육내용의 선정</a:t>
+            </a:r>
+            <a:endParaRPr lang="en-US" sz="1050" dirty="0"/>
           </a:p>
           <a:p>
             <a:pPr marL="342900" indent="-342900">
               <a:spcAft>
-                <a:spcPts val="400"/>
+                <a:spcPts val="300"/>
               </a:spcAft>
               <a:buSzPct val="100000"/>
               <a:buChar char="•"/>
             </a:pPr>
             <a:r>
-              <a:rPr lang="en-US" sz="1200" dirty="0">
+              <a:rPr lang="en-US" sz="1050" dirty="0">
                 <a:solidFill>
                   <a:srgbClr val="33413A"/>
                 </a:solidFill>
@@ -5038,9 +4957,9 @@
                 <a:ea typeface="Malgun Gothic" pitchFamily="34" charset="-122"/>
                 <a:cs typeface="Malgun Gothic" pitchFamily="34" charset="-120"/>
               </a:rPr>
-              <a:t>방법: 영유아의 발달과 흥미에 적합</a:t>
-            </a:r>
-            <a:endParaRPr lang="en-US" sz="1200" dirty="0"/>
+              <a:t>교육내용의 조직 및 영유아의 발달과 흥미에 적합한 교수방법의 결정</a:t>
+            </a:r>
+            <a:endParaRPr lang="en-US" sz="1050" dirty="0"/>
           </a:p>
         </p:txBody>
       </p:sp>
@@ -5113,8 +5032,8 @@
         </p:nvSpPr>
         <p:spPr>
           <a:xfrm>
-            <a:off x="5577840" y="3383280"/>
-            <a:ext cx="2971800" cy="868680"/>
+            <a:off x="5577840" y="3364992"/>
+            <a:ext cx="2971800" cy="914400"/>
           </a:xfrm>
           <a:prstGeom prst="rect">
             <a:avLst/>
@@ -5130,7 +5049,7 @@
               <a:buNone/>
             </a:pPr>
             <a:r>
-              <a:rPr lang="en-US" sz="1200" dirty="0">
+              <a:rPr lang="en-US" sz="1050" dirty="0">
                 <a:solidFill>
                   <a:srgbClr val="33413A"/>
                 </a:solidFill>
@@ -5138,9 +5057,9 @@
                 <a:ea typeface="Malgun Gothic" pitchFamily="34" charset="-122"/>
                 <a:cs typeface="Malgun Gothic" pitchFamily="34" charset="-120"/>
               </a:rPr>
-              <a:t>비판을 받으면서도 우리나라 초·중·고 교육과정의 기본 틀이 되었고, 교육과정 개념화에도 큰 영향을 미침</a:t>
-            </a:r>
-            <a:endParaRPr lang="en-US" sz="1200" dirty="0"/>
+              <a:t>타일러의 교육과정 모형에 대해 비판하면서도 우리나라 초·중·고등학교 교육과정은 타일러의 교육과정 체제에 의존해 왔으며, 교육과정을 개념화하는 데도 많은 영향을 미침</a:t>
+            </a:r>
+            <a:endParaRPr lang="en-US" sz="1050" dirty="0"/>
           </a:p>
         </p:txBody>
       </p:sp>
@@ -5937,7 +5856,7 @@
               <a:buNone/>
             </a:pPr>
             <a:r>
-              <a:rPr lang="en-US" sz="1300" dirty="0">
+              <a:rPr lang="en-US" sz="1200" dirty="0">
                 <a:solidFill>
                   <a:srgbClr val="33413A"/>
                 </a:solidFill>
@@ -5947,7 +5866,7 @@
               </a:rPr>
               <a:t>충분한 놀이시간 확보</a:t>
             </a:r>
-            <a:endParaRPr lang="en-US" sz="1300" dirty="0"/>
+            <a:endParaRPr lang="en-US" sz="1200" dirty="0"/>
           </a:p>
         </p:txBody>
       </p:sp>
@@ -6020,7 +5939,7 @@
               <a:buNone/>
             </a:pPr>
             <a:r>
-              <a:rPr lang="en-US" sz="1300" dirty="0">
+              <a:rPr lang="en-US" sz="1200" dirty="0">
                 <a:solidFill>
                   <a:srgbClr val="33413A"/>
                 </a:solidFill>
@@ -6028,9 +5947,9 @@
                 <a:ea typeface="Malgun Gothic" pitchFamily="34" charset="-122"/>
                 <a:cs typeface="Malgun Gothic" pitchFamily="34" charset="-120"/>
               </a:rPr>
-              <a:t>유아 스스로 놀이하며 배움</a:t>
-            </a:r>
-            <a:endParaRPr lang="en-US" sz="1300" dirty="0"/>
+              <a:t>유아 스스로 놀이하는 과정에서 배움</a:t>
+            </a:r>
+            <a:endParaRPr lang="en-US" sz="1200" dirty="0"/>
           </a:p>
         </p:txBody>
       </p:sp>
@@ -6103,7 +6022,7 @@
               <a:buNone/>
             </a:pPr>
             <a:r>
-              <a:rPr lang="en-US" sz="1300" dirty="0">
+              <a:rPr lang="en-US" sz="1200" dirty="0">
                 <a:solidFill>
                   <a:srgbClr val="33413A"/>
                 </a:solidFill>
@@ -6111,9 +6030,26 @@
                 <a:ea typeface="Malgun Gothic" pitchFamily="34" charset="-122"/>
                 <a:cs typeface="Malgun Gothic" pitchFamily="34" charset="-120"/>
               </a:rPr>
-              <a:t>바깥놀이·자연물 놀이 장려</a:t>
-            </a:r>
-            <a:endParaRPr lang="en-US" sz="1300" dirty="0"/>
+              <a:t>충분한 바깥놀이, 친숙한 사물·</a:t>
+            </a:r>
+            <a:endParaRPr lang="en-US" sz="1200" dirty="0"/>
+          </a:p>
+          <a:p>
+            <a:pPr indent="0" marL="0">
+              <a:buNone/>
+            </a:pPr>
+            <a:r>
+              <a:rPr lang="en-US" sz="1200" dirty="0">
+                <a:solidFill>
+                  <a:srgbClr val="33413A"/>
+                </a:solidFill>
+                <a:latin typeface="Malgun Gothic" pitchFamily="34" charset="0"/>
+                <a:ea typeface="Malgun Gothic" pitchFamily="34" charset="-122"/>
+                <a:cs typeface="Malgun Gothic" pitchFamily="34" charset="-120"/>
+              </a:rPr>
+              <a:t>자연물을 이용한 놀이 장려</a:t>
+            </a:r>
+            <a:endParaRPr lang="en-US" sz="1200" dirty="0"/>
           </a:p>
         </p:txBody>
       </p:sp>
@@ -6186,7 +6122,7 @@
               <a:buNone/>
             </a:pPr>
             <a:r>
-              <a:rPr lang="en-US" sz="1300" b="1" dirty="0">
+              <a:rPr lang="en-US" sz="1200" b="1" dirty="0">
                 <a:solidFill>
                   <a:srgbClr val="33413A"/>
                 </a:solidFill>
@@ -6196,14 +6132,14 @@
               </a:rPr>
               <a:t>교사 = 놀이지원자</a:t>
             </a:r>
-            <a:endParaRPr lang="en-US" sz="1300" dirty="0"/>
+            <a:endParaRPr lang="en-US" sz="1200" dirty="0"/>
           </a:p>
           <a:p>
             <a:pPr indent="0" marL="0">
               <a:buNone/>
             </a:pPr>
             <a:r>
-              <a:rPr lang="en-US" sz="1300" b="1" dirty="0">
+              <a:rPr lang="en-US" sz="1200" b="1" dirty="0">
                 <a:solidFill>
                   <a:srgbClr val="33413A"/>
                 </a:solidFill>
@@ -6211,9 +6147,9 @@
                 <a:ea typeface="Malgun Gothic" pitchFamily="34" charset="-122"/>
                 <a:cs typeface="Malgun Gothic" pitchFamily="34" charset="-120"/>
               </a:rPr>
-              <a:t>(관찰·지원·상호작용)</a:t>
-            </a:r>
-            <a:endParaRPr lang="en-US" sz="1300" dirty="0"/>
+              <a:t>(관찰, 필요한 지원과 상호작용)</a:t>
+            </a:r>
+            <a:endParaRPr lang="en-US" sz="1200" dirty="0"/>
           </a:p>
         </p:txBody>
       </p:sp>
@@ -6460,7 +6396,7 @@
               <a:buNone/>
             </a:pPr>
             <a:r>
-              <a:rPr lang="en-US" sz="1200" b="1" dirty="0">
+              <a:rPr lang="en-US" sz="1100" b="1" dirty="0">
                 <a:solidFill>
                   <a:srgbClr val="B45A64"/>
                 </a:solidFill>
@@ -6468,9 +6404,9 @@
                 <a:ea typeface="Malgun Gothic" pitchFamily="34" charset="-122"/>
                 <a:cs typeface="Malgun Gothic" pitchFamily="34" charset="-120"/>
               </a:rPr>
-              <a:t>주의! '좋아하는 것 = 좋은 교육과정'은 아님</a:t>
-            </a:r>
-            <a:endParaRPr lang="en-US" sz="1200" dirty="0"/>
+              <a:t>유의: 흥미에 기초 ≠ 단순히 영유아가 좋아하는 것</a:t>
+            </a:r>
+            <a:endParaRPr lang="en-US" sz="1100" dirty="0"/>
           </a:p>
         </p:txBody>
       </p:sp>
@@ -6529,7 +6465,7 @@
                 <a:ea typeface="Malgun Gothic" pitchFamily="34" charset="-122"/>
                 <a:cs typeface="Malgun Gothic" pitchFamily="34" charset="-120"/>
               </a:rPr>
-              <a:t>영유아의 흥미 존중 + 발달적 요구</a:t>
+              <a:t>흥미 존중 + 발달적 요구에 적합한 내용</a:t>
             </a:r>
             <a:endParaRPr lang="en-US" sz="1200" dirty="0"/>
           </a:p>
@@ -6629,7 +6565,7 @@
                 <a:ea typeface="Malgun Gothic" pitchFamily="34" charset="-122"/>
                 <a:cs typeface="Malgun Gothic" pitchFamily="34" charset="-120"/>
               </a:rPr>
-              <a:t>교사의 주의 깊은 관찰·평가</a:t>
+              <a:t>교사의 주의 깊은 관찰과 평가</a:t>
             </a:r>
             <a:endParaRPr lang="en-US" sz="1200" dirty="0"/>
           </a:p>
@@ -6729,7 +6665,7 @@
                 <a:ea typeface="Malgun Gothic" pitchFamily="34" charset="-122"/>
                 <a:cs typeface="Malgun Gothic" pitchFamily="34" charset="-120"/>
               </a:rPr>
-              <a:t>의미 있는 주제·놀이 선별</a:t>
+              <a:t>의미 있는 주제나 놀이 선별</a:t>
             </a:r>
             <a:endParaRPr lang="en-US" sz="1200" dirty="0"/>
           </a:p>
@@ -6829,7 +6765,7 @@
                 <a:ea typeface="Malgun Gothic" pitchFamily="34" charset="-122"/>
                 <a:cs typeface="Malgun Gothic" pitchFamily="34" charset="-120"/>
               </a:rPr>
-              <a:t>교육적 활동으로 연결</a:t>
+              <a:t>교육적인 활동으로 연결</a:t>
             </a:r>
             <a:endParaRPr lang="en-US" sz="1200" dirty="0"/>
           </a:p>
@@ -7217,7 +7153,7 @@
                 <a:ea typeface="Malgun Gothic" pitchFamily="34" charset="-122"/>
                 <a:cs typeface="Malgun Gothic" pitchFamily="34" charset="-120"/>
               </a:rPr>
-              <a:t>영아</a:t>
+              <a:t>영아기</a:t>
             </a:r>
             <a:endParaRPr lang="en-US" sz="1100" dirty="0"/>
           </a:p>
@@ -7232,7 +7168,7 @@
         <p:spPr>
           <a:xfrm>
             <a:off x="5486400" y="2542032"/>
-            <a:ext cx="3063240" cy="320040"/>
+            <a:ext cx="3108960" cy="320040"/>
           </a:xfrm>
           <a:prstGeom prst="rect">
             <a:avLst/>
@@ -7248,7 +7184,7 @@
               <a:buNone/>
             </a:pPr>
             <a:r>
-              <a:rPr lang="en-US" sz="1300" b="1" dirty="0">
+              <a:rPr lang="en-US" sz="1150" b="1" dirty="0">
                 <a:solidFill>
                   <a:srgbClr val="33413A"/>
                 </a:solidFill>
@@ -7256,9 +7192,9 @@
                 <a:ea typeface="Malgun Gothic" pitchFamily="34" charset="-122"/>
                 <a:cs typeface="Malgun Gothic" pitchFamily="34" charset="-120"/>
               </a:rPr>
-              <a:t>개인별 보육계획 수립</a:t>
-            </a:r>
-            <a:endParaRPr lang="en-US" sz="1300" dirty="0"/>
+              <a:t>학급별 계획보다 개인별 보육계획</a:t>
+            </a:r>
+            <a:endParaRPr lang="en-US" sz="1150" dirty="0"/>
           </a:p>
         </p:txBody>
       </p:sp>
@@ -7354,7 +7290,7 @@
         <p:spPr>
           <a:xfrm>
             <a:off x="5486400" y="3319272"/>
-            <a:ext cx="3063240" cy="320040"/>
+            <a:ext cx="3108960" cy="320040"/>
           </a:xfrm>
           <a:prstGeom prst="rect">
             <a:avLst/>
@@ -7370,7 +7306,7 @@
               <a:buNone/>
             </a:pPr>
             <a:r>
-              <a:rPr lang="en-US" sz="1300" b="1" dirty="0">
+              <a:rPr lang="en-US" sz="1150" b="1" dirty="0">
                 <a:solidFill>
                   <a:srgbClr val="33413A"/>
                 </a:solidFill>
@@ -7378,9 +7314,9 @@
                 <a:ea typeface="Malgun Gothic" pitchFamily="34" charset="-122"/>
                 <a:cs typeface="Malgun Gothic" pitchFamily="34" charset="-120"/>
               </a:rPr>
-              <a:t>개인별 평가 기반 수준별 계획</a:t>
-            </a:r>
-            <a:endParaRPr lang="en-US" sz="1300" dirty="0"/>
+              <a:t>개인별 평가에 기초한 수준별 교육계획</a:t>
+            </a:r>
+            <a:endParaRPr lang="en-US" sz="1150" dirty="0"/>
           </a:p>
         </p:txBody>
       </p:sp>
@@ -7476,7 +7412,7 @@
         <p:spPr>
           <a:xfrm>
             <a:off x="5486400" y="4096512"/>
-            <a:ext cx="3063240" cy="320040"/>
+            <a:ext cx="3108960" cy="320040"/>
           </a:xfrm>
           <a:prstGeom prst="rect">
             <a:avLst/>
@@ -7492,7 +7428,7 @@
               <a:buNone/>
             </a:pPr>
             <a:r>
-              <a:rPr lang="en-US" sz="1300" b="1" dirty="0">
+              <a:rPr lang="en-US" sz="1150" b="1" dirty="0">
                 <a:solidFill>
                   <a:srgbClr val="33413A"/>
                 </a:solidFill>
@@ -7500,9 +7436,9 @@
                 <a:ea typeface="Malgun Gothic" pitchFamily="34" charset="-122"/>
                 <a:cs typeface="Malgun Gothic" pitchFamily="34" charset="-120"/>
               </a:rPr>
-              <a:t>다문화교육 계획</a:t>
-            </a:r>
-            <a:endParaRPr lang="en-US" sz="1300" dirty="0"/>
+              <a:t>유아와 가정의 다양성을 반영한 다문화교육</a:t>
+            </a:r>
+            <a:endParaRPr lang="en-US" sz="1150" dirty="0"/>
           </a:p>
         </p:txBody>
       </p:sp>
@@ -7610,7 +7546,7 @@
                 <a:ea typeface="Malgun Gothic" pitchFamily="34" charset="-122"/>
                 <a:cs typeface="Malgun Gothic" pitchFamily="34" charset="-120"/>
               </a:rPr>
-              <a:t>구성 요소 (= 실행 순서)</a:t>
+              <a:t>구성요소 (= 교육과정이 실행되는 순서)</a:t>
             </a:r>
             <a:endParaRPr lang="en-US" sz="1400" dirty="0"/>
           </a:p>
@@ -8293,7 +8229,7 @@
                 <a:ea typeface="Malgun Gothic" pitchFamily="34" charset="-122"/>
                 <a:cs typeface="Malgun Gothic" pitchFamily="34" charset="-120"/>
               </a:rPr>
-              <a:t>아이가 놀이 속에서 자연스럽게 배우도록 구성하는 것이 핵심</a:t>
+              <a:t>평가 결과는 차기 교육계획 수립에 적절히 반영</a:t>
             </a:r>
             <a:endParaRPr lang="en-US" sz="1700" dirty="0"/>
           </a:p>
@@ -8729,7 +8665,7 @@
                 <a:ea typeface="Malgun Gothic" pitchFamily="34" charset="-122"/>
                 <a:cs typeface="Malgun Gothic" pitchFamily="34" charset="-120"/>
               </a:rPr>
-              <a:t>무엇을 기준으로 계획할까?</a:t>
+              <a:t>교육과정 계획·운영의 지침</a:t>
             </a:r>
             <a:endParaRPr lang="en-US" sz="2800" dirty="0"/>
           </a:p>
@@ -8768,7 +8704,7 @@
                 <a:ea typeface="Malgun Gothic" pitchFamily="34" charset="-122"/>
                 <a:cs typeface="Malgun Gothic" pitchFamily="34" charset="-120"/>
               </a:rPr>
-              <a:t>전문 지식 + 다음 지침들을 함께 참고</a:t>
+              <a:t>전문적 지식 + 다음을 지침으로 운영</a:t>
             </a:r>
             <a:endParaRPr lang="en-US" sz="1400" dirty="0"/>
           </a:p>
@@ -10009,7 +9945,7 @@
                 <a:ea typeface="Malgun Gothic" pitchFamily="34" charset="-122"/>
                 <a:cs typeface="Malgun Gothic" pitchFamily="34" charset="-120"/>
               </a:rPr>
-              <a:t>3~5세는 누리과정으로 내용이 동일</a:t>
+              <a:t>3~5세는 공통교육과정(누리과정)으로 내용이 동일</a:t>
             </a:r>
             <a:endParaRPr lang="en-US" sz="1200" dirty="0"/>
           </a:p>
@@ -10029,7 +9965,27 @@
                 <a:ea typeface="Malgun Gothic" pitchFamily="34" charset="-122"/>
                 <a:cs typeface="Malgun Gothic" pitchFamily="34" charset="-120"/>
               </a:rPr>
-              <a:t>→ 교원이 함께 연구하고, 각 기관의 교육에 어떻게 반영할지 협의</a:t>
+              <a:t>→ 교원이 함께 연구하고 각 기관의 교육에 어떻게 반영할지 협의</a:t>
+            </a:r>
+            <a:endParaRPr lang="en-US" sz="1200" dirty="0"/>
+          </a:p>
+          <a:p>
+            <a:pPr indent="0" marL="0">
+              <a:spcAft>
+                <a:spcPts val="400"/>
+              </a:spcAft>
+              <a:buNone/>
+            </a:pPr>
+            <a:r>
+              <a:rPr lang="en-US" sz="1050" dirty="0">
+                <a:solidFill>
+                  <a:srgbClr val="6E7B73"/>
+                </a:solidFill>
+                <a:latin typeface="Malgun Gothic" pitchFamily="34" charset="0"/>
+                <a:ea typeface="Malgun Gothic" pitchFamily="34" charset="-122"/>
+                <a:cs typeface="Malgun Gothic" pitchFamily="34" charset="-120"/>
+              </a:rPr>
+              <a:t>※ 제4차 표준보육과정(보건복지부 고시 제2020-75호) 중심</a:t>
             </a:r>
             <a:endParaRPr lang="en-US" sz="1200" dirty="0"/>
           </a:p>
@@ -10167,21 +10123,365 @@
       </p:sp>
       <p:sp>
         <p:nvSpPr>
-          <p:cNvPr id="5" name="Shape 3"/>
+          <p:cNvPr id="5" name="Text 3"/>
+          <p:cNvSpPr txBox="1"/>
+          <p:nvPr/>
+        </p:nvSpPr>
+        <p:spPr>
+          <a:xfrm>
+            <a:off x="457200" y="1005840"/>
+            <a:ext cx="3657600" cy="274320"/>
+          </a:xfrm>
+          <a:prstGeom prst="rect">
+            <a:avLst/>
+          </a:prstGeom>
+          <a:noFill/>
+          <a:ln/>
+        </p:spPr>
+        <p:txBody>
+          <a:bodyPr wrap="square" lIns="0" tIns="0" rIns="0" bIns="0" rtlCol="0" anchor="ctr"/>
+          <a:lstStyle/>
+          <a:p>
+            <a:pPr indent="0" marL="0">
+              <a:buNone/>
+            </a:pPr>
+            <a:r>
+              <a:rPr lang="en-US" sz="1300" b="1" dirty="0">
+                <a:solidFill>
+                  <a:srgbClr val="5E8C6A"/>
+                </a:solidFill>
+                <a:latin typeface="Malgun Gothic" pitchFamily="34" charset="0"/>
+                <a:ea typeface="Malgun Gothic" pitchFamily="34" charset="-122"/>
+                <a:cs typeface="Malgun Gothic" pitchFamily="34" charset="-120"/>
+              </a:rPr>
+              <a:t>추구하는 인간상</a:t>
+            </a:r>
+            <a:endParaRPr lang="en-US" sz="1300" dirty="0"/>
+          </a:p>
+        </p:txBody>
+      </p:sp>
+      <p:sp>
+        <p:nvSpPr>
+          <p:cNvPr id="6" name="Shape 4"/>
           <p:cNvSpPr/>
           <p:nvPr/>
         </p:nvSpPr>
         <p:spPr>
           <a:xfrm>
-            <a:off x="457200" y="1051560"/>
-            <a:ext cx="8229600" cy="548640"/>
+            <a:off x="457200" y="1325880"/>
+            <a:ext cx="1517904" cy="411480"/>
           </a:xfrm>
           <a:prstGeom prst="roundRect">
             <a:avLst>
-              <a:gd name="adj" fmla="val 25000"/>
+              <a:gd name="adj" fmla="val 48889"/>
             </a:avLst>
           </a:prstGeom>
           <a:solidFill>
+            <a:srgbClr val="FCE4D8"/>
+          </a:solidFill>
+          <a:ln/>
+        </p:spPr>
+      </p:sp>
+      <p:sp>
+        <p:nvSpPr>
+          <p:cNvPr id="7" name="Text 5"/>
+          <p:cNvSpPr txBox="1"/>
+          <p:nvPr/>
+        </p:nvSpPr>
+        <p:spPr>
+          <a:xfrm>
+            <a:off x="457200" y="1325880"/>
+            <a:ext cx="1517904" cy="411480"/>
+          </a:xfrm>
+          <a:prstGeom prst="rect">
+            <a:avLst/>
+          </a:prstGeom>
+          <a:noFill/>
+          <a:ln/>
+        </p:spPr>
+        <p:txBody>
+          <a:bodyPr wrap="square" lIns="0" tIns="0" rIns="0" bIns="0" rtlCol="0" anchor="ctr"/>
+          <a:lstStyle/>
+          <a:p>
+            <a:pPr algn="ctr" indent="0" marL="0">
+              <a:buNone/>
+            </a:pPr>
+            <a:r>
+              <a:rPr lang="en-US" sz="1200" b="1" dirty="0">
+                <a:solidFill>
+                  <a:srgbClr val="33413A"/>
+                </a:solidFill>
+                <a:latin typeface="Malgun Gothic" pitchFamily="34" charset="0"/>
+                <a:ea typeface="Malgun Gothic" pitchFamily="34" charset="-122"/>
+                <a:cs typeface="Malgun Gothic" pitchFamily="34" charset="-120"/>
+              </a:rPr>
+              <a:t>건강한 사람</a:t>
+            </a:r>
+            <a:endParaRPr lang="en-US" sz="1200" dirty="0"/>
+          </a:p>
+        </p:txBody>
+      </p:sp>
+      <p:sp>
+        <p:nvSpPr>
+          <p:cNvPr id="8" name="Shape 6"/>
+          <p:cNvSpPr/>
+          <p:nvPr/>
+        </p:nvSpPr>
+        <p:spPr>
+          <a:xfrm>
+            <a:off x="2139696" y="1325880"/>
+            <a:ext cx="1517904" cy="411480"/>
+          </a:xfrm>
+          <a:prstGeom prst="roundRect">
+            <a:avLst>
+              <a:gd name="adj" fmla="val 48889"/>
+            </a:avLst>
+          </a:prstGeom>
+          <a:solidFill>
+            <a:srgbClr val="FDF3D6"/>
+          </a:solidFill>
+          <a:ln/>
+        </p:spPr>
+      </p:sp>
+      <p:sp>
+        <p:nvSpPr>
+          <p:cNvPr id="9" name="Text 7"/>
+          <p:cNvSpPr txBox="1"/>
+          <p:nvPr/>
+        </p:nvSpPr>
+        <p:spPr>
+          <a:xfrm>
+            <a:off x="2139696" y="1325880"/>
+            <a:ext cx="1517904" cy="411480"/>
+          </a:xfrm>
+          <a:prstGeom prst="rect">
+            <a:avLst/>
+          </a:prstGeom>
+          <a:noFill/>
+          <a:ln/>
+        </p:spPr>
+        <p:txBody>
+          <a:bodyPr wrap="square" lIns="0" tIns="0" rIns="0" bIns="0" rtlCol="0" anchor="ctr"/>
+          <a:lstStyle/>
+          <a:p>
+            <a:pPr algn="ctr" indent="0" marL="0">
+              <a:buNone/>
+            </a:pPr>
+            <a:r>
+              <a:rPr lang="en-US" sz="1200" b="1" dirty="0">
+                <a:solidFill>
+                  <a:srgbClr val="33413A"/>
+                </a:solidFill>
+                <a:latin typeface="Malgun Gothic" pitchFamily="34" charset="0"/>
+                <a:ea typeface="Malgun Gothic" pitchFamily="34" charset="-122"/>
+                <a:cs typeface="Malgun Gothic" pitchFamily="34" charset="-120"/>
+              </a:rPr>
+              <a:t>자주적인 사람</a:t>
+            </a:r>
+            <a:endParaRPr lang="en-US" sz="1200" dirty="0"/>
+          </a:p>
+        </p:txBody>
+      </p:sp>
+      <p:sp>
+        <p:nvSpPr>
+          <p:cNvPr id="10" name="Shape 8"/>
+          <p:cNvSpPr/>
+          <p:nvPr/>
+        </p:nvSpPr>
+        <p:spPr>
+          <a:xfrm>
+            <a:off x="3822192" y="1325880"/>
+            <a:ext cx="1517904" cy="411480"/>
+          </a:xfrm>
+          <a:prstGeom prst="roundRect">
+            <a:avLst>
+              <a:gd name="adj" fmla="val 48889"/>
+            </a:avLst>
+          </a:prstGeom>
+          <a:solidFill>
+            <a:srgbClr val="DCEBDD"/>
+          </a:solidFill>
+          <a:ln/>
+        </p:spPr>
+      </p:sp>
+      <p:sp>
+        <p:nvSpPr>
+          <p:cNvPr id="11" name="Text 9"/>
+          <p:cNvSpPr txBox="1"/>
+          <p:nvPr/>
+        </p:nvSpPr>
+        <p:spPr>
+          <a:xfrm>
+            <a:off x="3822192" y="1325880"/>
+            <a:ext cx="1517904" cy="411480"/>
+          </a:xfrm>
+          <a:prstGeom prst="rect">
+            <a:avLst/>
+          </a:prstGeom>
+          <a:noFill/>
+          <a:ln/>
+        </p:spPr>
+        <p:txBody>
+          <a:bodyPr wrap="square" lIns="0" tIns="0" rIns="0" bIns="0" rtlCol="0" anchor="ctr"/>
+          <a:lstStyle/>
+          <a:p>
+            <a:pPr algn="ctr" indent="0" marL="0">
+              <a:buNone/>
+            </a:pPr>
+            <a:r>
+              <a:rPr lang="en-US" sz="1200" b="1" dirty="0">
+                <a:solidFill>
+                  <a:srgbClr val="33413A"/>
+                </a:solidFill>
+                <a:latin typeface="Malgun Gothic" pitchFamily="34" charset="0"/>
+                <a:ea typeface="Malgun Gothic" pitchFamily="34" charset="-122"/>
+                <a:cs typeface="Malgun Gothic" pitchFamily="34" charset="-120"/>
+              </a:rPr>
+              <a:t>창의적인 사람</a:t>
+            </a:r>
+            <a:endParaRPr lang="en-US" sz="1200" dirty="0"/>
+          </a:p>
+        </p:txBody>
+      </p:sp>
+      <p:sp>
+        <p:nvSpPr>
+          <p:cNvPr id="12" name="Shape 10"/>
+          <p:cNvSpPr/>
+          <p:nvPr/>
+        </p:nvSpPr>
+        <p:spPr>
+          <a:xfrm>
+            <a:off x="5504688" y="1325880"/>
+            <a:ext cx="1517904" cy="411480"/>
+          </a:xfrm>
+          <a:prstGeom prst="roundRect">
+            <a:avLst>
+              <a:gd name="adj" fmla="val 48889"/>
+            </a:avLst>
+          </a:prstGeom>
+          <a:solidFill>
+            <a:srgbClr val="F9E1E3"/>
+          </a:solidFill>
+          <a:ln/>
+        </p:spPr>
+      </p:sp>
+      <p:sp>
+        <p:nvSpPr>
+          <p:cNvPr id="13" name="Text 11"/>
+          <p:cNvSpPr txBox="1"/>
+          <p:nvPr/>
+        </p:nvSpPr>
+        <p:spPr>
+          <a:xfrm>
+            <a:off x="5504688" y="1325880"/>
+            <a:ext cx="1517904" cy="411480"/>
+          </a:xfrm>
+          <a:prstGeom prst="rect">
+            <a:avLst/>
+          </a:prstGeom>
+          <a:noFill/>
+          <a:ln/>
+        </p:spPr>
+        <p:txBody>
+          <a:bodyPr wrap="square" lIns="0" tIns="0" rIns="0" bIns="0" rtlCol="0" anchor="ctr"/>
+          <a:lstStyle/>
+          <a:p>
+            <a:pPr algn="ctr" indent="0" marL="0">
+              <a:buNone/>
+            </a:pPr>
+            <a:r>
+              <a:rPr lang="en-US" sz="1200" b="1" dirty="0">
+                <a:solidFill>
+                  <a:srgbClr val="33413A"/>
+                </a:solidFill>
+                <a:latin typeface="Malgun Gothic" pitchFamily="34" charset="0"/>
+                <a:ea typeface="Malgun Gothic" pitchFamily="34" charset="-122"/>
+                <a:cs typeface="Malgun Gothic" pitchFamily="34" charset="-120"/>
+              </a:rPr>
+              <a:t>감성이 풍부한 사람</a:t>
+            </a:r>
+            <a:endParaRPr lang="en-US" sz="1200" dirty="0"/>
+          </a:p>
+        </p:txBody>
+      </p:sp>
+      <p:sp>
+        <p:nvSpPr>
+          <p:cNvPr id="14" name="Shape 12"/>
+          <p:cNvSpPr/>
+          <p:nvPr/>
+        </p:nvSpPr>
+        <p:spPr>
+          <a:xfrm>
+            <a:off x="7187184" y="1325880"/>
+            <a:ext cx="1517904" cy="411480"/>
+          </a:xfrm>
+          <a:prstGeom prst="roundRect">
+            <a:avLst>
+              <a:gd name="adj" fmla="val 48889"/>
+            </a:avLst>
+          </a:prstGeom>
+          <a:solidFill>
+            <a:srgbClr val="EDE6F3"/>
+          </a:solidFill>
+          <a:ln/>
+        </p:spPr>
+      </p:sp>
+      <p:sp>
+        <p:nvSpPr>
+          <p:cNvPr id="15" name="Text 13"/>
+          <p:cNvSpPr txBox="1"/>
+          <p:nvPr/>
+        </p:nvSpPr>
+        <p:spPr>
+          <a:xfrm>
+            <a:off x="7187184" y="1325880"/>
+            <a:ext cx="1517904" cy="411480"/>
+          </a:xfrm>
+          <a:prstGeom prst="rect">
+            <a:avLst/>
+          </a:prstGeom>
+          <a:noFill/>
+          <a:ln/>
+        </p:spPr>
+        <p:txBody>
+          <a:bodyPr wrap="square" lIns="0" tIns="0" rIns="0" bIns="0" rtlCol="0" anchor="ctr"/>
+          <a:lstStyle/>
+          <a:p>
+            <a:pPr algn="ctr" indent="0" marL="0">
+              <a:buNone/>
+            </a:pPr>
+            <a:r>
+              <a:rPr lang="en-US" sz="1200" b="1" dirty="0">
+                <a:solidFill>
+                  <a:srgbClr val="33413A"/>
+                </a:solidFill>
+                <a:latin typeface="Malgun Gothic" pitchFamily="34" charset="0"/>
+                <a:ea typeface="Malgun Gothic" pitchFamily="34" charset="-122"/>
+                <a:cs typeface="Malgun Gothic" pitchFamily="34" charset="-120"/>
+              </a:rPr>
+              <a:t>더불어 사는 사람</a:t>
+            </a:r>
+            <a:endParaRPr lang="en-US" sz="1200" dirty="0"/>
+          </a:p>
+        </p:txBody>
+      </p:sp>
+      <p:sp>
+        <p:nvSpPr>
+          <p:cNvPr id="16" name="Shape 14"/>
+          <p:cNvSpPr/>
+          <p:nvPr/>
+        </p:nvSpPr>
+        <p:spPr>
+          <a:xfrm>
+            <a:off x="457200" y="1874520"/>
+            <a:ext cx="8229600" cy="502920"/>
+          </a:xfrm>
+          <a:prstGeom prst="roundRect">
+            <a:avLst>
+              <a:gd name="adj" fmla="val 27273"/>
+            </a:avLst>
+          </a:prstGeom>
+          <a:solidFill>
             <a:srgbClr val="F4F7F4"/>
           </a:solidFill>
           <a:ln/>
@@ -10189,14 +10489,14 @@
       </p:sp>
       <p:sp>
         <p:nvSpPr>
-          <p:cNvPr id="6" name="Text 4"/>
-          <p:cNvSpPr txBox="1"/>
-          <p:nvPr/>
-        </p:nvSpPr>
-        <p:spPr>
-          <a:xfrm>
-            <a:off x="640080" y="1051560"/>
-            <a:ext cx="7863840" cy="548640"/>
+          <p:cNvPr id="17" name="Text 15"/>
+          <p:cNvSpPr txBox="1"/>
+          <p:nvPr/>
+        </p:nvSpPr>
+        <p:spPr>
+          <a:xfrm>
+            <a:off x="640080" y="1874520"/>
+            <a:ext cx="7863840" cy="502920"/>
           </a:xfrm>
           <a:prstGeom prst="rect">
             <a:avLst/>
@@ -10212,7 +10512,7 @@
               <a:buNone/>
             </a:pPr>
             <a:r>
-              <a:rPr lang="en-US" sz="1300" b="1" dirty="0">
+              <a:rPr lang="en-US" sz="1200" b="1" dirty="0">
                 <a:solidFill>
                   <a:srgbClr val="5E8C6A"/>
                 </a:solidFill>
@@ -10226,7 +10526,7 @@
               <a:buNone/>
             </a:pPr>
             <a:r>
-              <a:rPr lang="en-US" sz="1300" dirty="0">
+              <a:rPr lang="en-US" sz="1200" dirty="0">
                 <a:solidFill>
                   <a:srgbClr val="33413A"/>
                 </a:solidFill>
@@ -10234,1259 +10534,44 @@
                 <a:ea typeface="Malgun Gothic" pitchFamily="34" charset="-122"/>
                 <a:cs typeface="Malgun Gothic" pitchFamily="34" charset="-120"/>
               </a:rPr>
-              <a:t>놀이를 통해 심신의 건강과 조화로운 발달 + 바른 인성과 민주 시민의 기초 형성</a:t>
-            </a:r>
-            <a:endParaRPr lang="en-US" sz="1300" dirty="0"/>
-          </a:p>
-        </p:txBody>
-      </p:sp>
-      <p:graphicFrame>
-        <p:nvGraphicFramePr>
-          <p:cNvPr id="18" name="Table 0"/>
-          <p:cNvGraphicFramePr>
-            <a:graphicFrameLocks noGrp="1"/>
-          </p:cNvGraphicFramePr>
-          <p:nvPr>
-            <p:extLst>
-              <p:ext uri="{D42A27DB-BD31-4B8C-83A1-F6EECF244321}">
-                <p14:modId xmlns:p14="http://schemas.microsoft.com/office/powerpoint/2010/main" val="1579011935"/>
-              </p:ext>
-            </p:extLst>
-          </p:nvPr>
-        </p:nvGraphicFramePr>
-        <p:xfrm>
-          <a:off x="457200" y="1783080"/>
-          <a:ext cx="8229600" cy="914400"/>
-        </p:xfrm>
-        <a:graphic>
-          <a:graphicData uri="http://schemas.openxmlformats.org/drawingml/2006/table">
-            <a:tbl>
-              <a:tblPr/>
-              <a:tblGrid>
-                <a:gridCol w="1828800"/>
-                <a:gridCol w="3200400"/>
-                <a:gridCol w="3200400"/>
-              </a:tblGrid>
-              <a:tr h="347472">
-                <a:tc>
-                  <a:txBody>
-                    <a:bodyPr/>
-                    <a:lstStyle/>
-                    <a:p>
-                      <a:pPr algn="ctr" indent="0" marL="0">
-                        <a:buNone/>
-                      </a:pPr>
-                      <a:r>
-                        <a:rPr lang="en-US" sz="1100" b="1" dirty="0">
-                          <a:solidFill>
-                            <a:srgbClr val="33413A"/>
-                          </a:solidFill>
-                          <a:latin typeface="Malgun Gothic" pitchFamily="34" charset="0"/>
-                          <a:ea typeface="Malgun Gothic" pitchFamily="34" charset="-122"/>
-                          <a:cs typeface="Malgun Gothic" pitchFamily="34" charset="-120"/>
-                        </a:rPr>
-                        <a:t>추구하는 인간상</a:t>
-                      </a:r>
-                      <a:endParaRPr lang="en-US" sz="1100" dirty="0">
-                        <a:latin typeface="Malgun Gothic" charset="0"/>
-                        <a:ea typeface="Malgun Gothic" charset="0"/>
-                        <a:cs typeface="Malgun Gothic" charset="0"/>
-                      </a:endParaRPr>
-                    </a:p>
-                  </a:txBody>
-                  <a:tcPr marL="45720" marR="45720" marT="45720" marB="45720" anchor="ctr">
-                    <a:lnL w="12700" cap="flat" cmpd="sng" algn="ctr">
-                      <a:solidFill>
-                        <a:srgbClr val="E1E8E2"/>
-                      </a:solidFill>
-                      <a:prstDash val="solid"/>
-                      <a:round/>
-                      <a:headEnd type="none" w="med" len="med"/>
-                      <a:tailEnd type="none" w="med" len="med"/>
-                    </a:lnL>
-                    <a:lnR w="12700" cap="flat" cmpd="sng" algn="ctr">
-                      <a:solidFill>
-                        <a:srgbClr val="E1E8E2"/>
-                      </a:solidFill>
-                      <a:prstDash val="solid"/>
-                      <a:round/>
-                      <a:headEnd type="none" w="med" len="med"/>
-                      <a:tailEnd type="none" w="med" len="med"/>
-                    </a:lnR>
-                    <a:lnT w="12700" cap="flat" cmpd="sng" algn="ctr">
-                      <a:solidFill>
-                        <a:srgbClr val="E1E8E2"/>
-                      </a:solidFill>
-                      <a:prstDash val="solid"/>
-                      <a:round/>
-                      <a:headEnd type="none" w="med" len="med"/>
-                      <a:tailEnd type="none" w="med" len="med"/>
-                    </a:lnT>
-                    <a:lnB w="12700" cap="flat" cmpd="sng" algn="ctr">
-                      <a:solidFill>
-                        <a:srgbClr val="E1E8E2"/>
-                      </a:solidFill>
-                      <a:prstDash val="solid"/>
-                      <a:round/>
-                      <a:headEnd type="none" w="med" len="med"/>
-                      <a:tailEnd type="none" w="med" len="med"/>
-                    </a:lnB>
-                    <a:solidFill>
-                      <a:srgbClr val="DCEBDD"/>
-                    </a:solidFill>
-                  </a:tcPr>
-                </a:tc>
-                <a:tc>
-                  <a:txBody>
-                    <a:bodyPr/>
-                    <a:lstStyle/>
-                    <a:p>
-                      <a:pPr algn="ctr" indent="0" marL="0">
-                        <a:buNone/>
-                      </a:pPr>
-                      <a:r>
-                        <a:rPr lang="en-US" sz="1100" b="1" dirty="0">
-                          <a:solidFill>
-                            <a:srgbClr val="33413A"/>
-                          </a:solidFill>
-                          <a:latin typeface="Malgun Gothic" pitchFamily="34" charset="0"/>
-                          <a:ea typeface="Malgun Gothic" pitchFamily="34" charset="-122"/>
-                          <a:cs typeface="Malgun Gothic" pitchFamily="34" charset="-120"/>
-                        </a:rPr>
-                        <a:t>0~2세 목표</a:t>
-                      </a:r>
-                      <a:endParaRPr lang="en-US" sz="1100" dirty="0">
-                        <a:latin typeface="Malgun Gothic" charset="0"/>
-                        <a:ea typeface="Malgun Gothic" charset="0"/>
-                        <a:cs typeface="Malgun Gothic" charset="0"/>
-                      </a:endParaRPr>
-                    </a:p>
-                  </a:txBody>
-                  <a:tcPr marL="45720" marR="45720" marT="45720" marB="45720" anchor="ctr">
-                    <a:lnL w="12700" cap="flat" cmpd="sng" algn="ctr">
-                      <a:solidFill>
-                        <a:srgbClr val="E1E8E2"/>
-                      </a:solidFill>
-                      <a:prstDash val="solid"/>
-                      <a:round/>
-                      <a:headEnd type="none" w="med" len="med"/>
-                      <a:tailEnd type="none" w="med" len="med"/>
-                    </a:lnL>
-                    <a:lnR w="12700" cap="flat" cmpd="sng" algn="ctr">
-                      <a:solidFill>
-                        <a:srgbClr val="E1E8E2"/>
-                      </a:solidFill>
-                      <a:prstDash val="solid"/>
-                      <a:round/>
-                      <a:headEnd type="none" w="med" len="med"/>
-                      <a:tailEnd type="none" w="med" len="med"/>
-                    </a:lnR>
-                    <a:lnT w="12700" cap="flat" cmpd="sng" algn="ctr">
-                      <a:solidFill>
-                        <a:srgbClr val="E1E8E2"/>
-                      </a:solidFill>
-                      <a:prstDash val="solid"/>
-                      <a:round/>
-                      <a:headEnd type="none" w="med" len="med"/>
-                      <a:tailEnd type="none" w="med" len="med"/>
-                    </a:lnT>
-                    <a:lnB w="12700" cap="flat" cmpd="sng" algn="ctr">
-                      <a:solidFill>
-                        <a:srgbClr val="E1E8E2"/>
-                      </a:solidFill>
-                      <a:prstDash val="solid"/>
-                      <a:round/>
-                      <a:headEnd type="none" w="med" len="med"/>
-                      <a:tailEnd type="none" w="med" len="med"/>
-                    </a:lnB>
-                    <a:solidFill>
-                      <a:srgbClr val="DCEBDD"/>
-                    </a:solidFill>
-                  </a:tcPr>
-                </a:tc>
-                <a:tc>
-                  <a:txBody>
-                    <a:bodyPr/>
-                    <a:lstStyle/>
-                    <a:p>
-                      <a:pPr algn="ctr" indent="0" marL="0">
-                        <a:buNone/>
-                      </a:pPr>
-                      <a:r>
-                        <a:rPr lang="en-US" sz="1100" b="1" dirty="0">
-                          <a:solidFill>
-                            <a:srgbClr val="33413A"/>
-                          </a:solidFill>
-                          <a:latin typeface="Malgun Gothic" pitchFamily="34" charset="0"/>
-                          <a:ea typeface="Malgun Gothic" pitchFamily="34" charset="-122"/>
-                          <a:cs typeface="Malgun Gothic" pitchFamily="34" charset="-120"/>
-                        </a:rPr>
-                        <a:t>3~5세 목표</a:t>
-                      </a:r>
-                      <a:endParaRPr lang="en-US" sz="1100" dirty="0">
-                        <a:latin typeface="Malgun Gothic" charset="0"/>
-                        <a:ea typeface="Malgun Gothic" charset="0"/>
-                        <a:cs typeface="Malgun Gothic" charset="0"/>
-                      </a:endParaRPr>
-                    </a:p>
-                  </a:txBody>
-                  <a:tcPr marL="45720" marR="45720" marT="45720" marB="45720" anchor="ctr">
-                    <a:lnL w="12700" cap="flat" cmpd="sng" algn="ctr">
-                      <a:solidFill>
-                        <a:srgbClr val="E1E8E2"/>
-                      </a:solidFill>
-                      <a:prstDash val="solid"/>
-                      <a:round/>
-                      <a:headEnd type="none" w="med" len="med"/>
-                      <a:tailEnd type="none" w="med" len="med"/>
-                    </a:lnL>
-                    <a:lnR w="12700" cap="flat" cmpd="sng" algn="ctr">
-                      <a:solidFill>
-                        <a:srgbClr val="E1E8E2"/>
-                      </a:solidFill>
-                      <a:prstDash val="solid"/>
-                      <a:round/>
-                      <a:headEnd type="none" w="med" len="med"/>
-                      <a:tailEnd type="none" w="med" len="med"/>
-                    </a:lnR>
-                    <a:lnT w="12700" cap="flat" cmpd="sng" algn="ctr">
-                      <a:solidFill>
-                        <a:srgbClr val="E1E8E2"/>
-                      </a:solidFill>
-                      <a:prstDash val="solid"/>
-                      <a:round/>
-                      <a:headEnd type="none" w="med" len="med"/>
-                      <a:tailEnd type="none" w="med" len="med"/>
-                    </a:lnT>
-                    <a:lnB w="12700" cap="flat" cmpd="sng" algn="ctr">
-                      <a:solidFill>
-                        <a:srgbClr val="E1E8E2"/>
-                      </a:solidFill>
-                      <a:prstDash val="solid"/>
-                      <a:round/>
-                      <a:headEnd type="none" w="med" len="med"/>
-                      <a:tailEnd type="none" w="med" len="med"/>
-                    </a:lnB>
-                    <a:solidFill>
-                      <a:srgbClr val="DCEBDD"/>
-                    </a:solidFill>
-                  </a:tcPr>
-                </a:tc>
-              </a:tr>
-              <a:tr h="457200">
-                <a:tc>
-                  <a:txBody>
-                    <a:bodyPr/>
-                    <a:lstStyle/>
-                    <a:p>
-                      <a:pPr algn="ctr" indent="0" marL="0">
-                        <a:buNone/>
-                      </a:pPr>
-                      <a:r>
-                        <a:rPr lang="en-US" sz="1100" b="1" dirty="0">
-                          <a:solidFill>
-                            <a:srgbClr val="33413A"/>
-                          </a:solidFill>
-                          <a:latin typeface="Malgun Gothic" pitchFamily="34" charset="0"/>
-                          <a:ea typeface="Malgun Gothic" pitchFamily="34" charset="-122"/>
-                          <a:cs typeface="Malgun Gothic" pitchFamily="34" charset="-120"/>
-                        </a:rPr>
-                        <a:t>건강한 사람</a:t>
-                      </a:r>
-                      <a:endParaRPr lang="en-US" sz="1100" dirty="0">
-                        <a:latin typeface="Malgun Gothic" charset="0"/>
-                        <a:ea typeface="Malgun Gothic" charset="0"/>
-                        <a:cs typeface="Malgun Gothic" charset="0"/>
-                      </a:endParaRPr>
-                    </a:p>
-                  </a:txBody>
-                  <a:tcPr marL="45720" marR="45720" marT="45720" marB="45720" anchor="ctr">
-                    <a:lnL w="12700" cap="flat" cmpd="sng" algn="ctr">
-                      <a:solidFill>
-                        <a:srgbClr val="E1E8E2"/>
-                      </a:solidFill>
-                      <a:prstDash val="solid"/>
-                      <a:round/>
-                      <a:headEnd type="none" w="med" len="med"/>
-                      <a:tailEnd type="none" w="med" len="med"/>
-                    </a:lnL>
-                    <a:lnR w="12700" cap="flat" cmpd="sng" algn="ctr">
-                      <a:solidFill>
-                        <a:srgbClr val="E1E8E2"/>
-                      </a:solidFill>
-                      <a:prstDash val="solid"/>
-                      <a:round/>
-                      <a:headEnd type="none" w="med" len="med"/>
-                      <a:tailEnd type="none" w="med" len="med"/>
-                    </a:lnR>
-                    <a:lnT w="12700" cap="flat" cmpd="sng" algn="ctr">
-                      <a:solidFill>
-                        <a:srgbClr val="E1E8E2"/>
-                      </a:solidFill>
-                      <a:prstDash val="solid"/>
-                      <a:round/>
-                      <a:headEnd type="none" w="med" len="med"/>
-                      <a:tailEnd type="none" w="med" len="med"/>
-                    </a:lnT>
-                    <a:lnB w="12700" cap="flat" cmpd="sng" algn="ctr">
-                      <a:solidFill>
-                        <a:srgbClr val="E1E8E2"/>
-                      </a:solidFill>
-                      <a:prstDash val="solid"/>
-                      <a:round/>
-                      <a:headEnd type="none" w="med" len="med"/>
-                      <a:tailEnd type="none" w="med" len="med"/>
-                    </a:lnB>
-                    <a:solidFill>
-                      <a:srgbClr val="FCE4D8"/>
-                    </a:solidFill>
-                  </a:tcPr>
-                </a:tc>
-                <a:tc>
-                  <a:txBody>
-                    <a:bodyPr/>
-                    <a:lstStyle/>
-                    <a:p>
-                      <a:pPr algn="l" indent="0" marL="0">
-                        <a:buNone/>
-                      </a:pPr>
-                      <a:r>
-                        <a:rPr lang="en-US" sz="1100" dirty="0">
-                          <a:solidFill>
-                            <a:srgbClr val="33413A"/>
-                          </a:solidFill>
-                          <a:latin typeface="Malgun Gothic" pitchFamily="34" charset="0"/>
-                          <a:ea typeface="Malgun Gothic" pitchFamily="34" charset="-122"/>
-                          <a:cs typeface="Malgun Gothic" pitchFamily="34" charset="-120"/>
-                        </a:rPr>
-                        <a:t>건강하고 안전한 환경에서 즐겁게 생활</a:t>
-                      </a:r>
-                      <a:endParaRPr lang="en-US" sz="1100" dirty="0">
-                        <a:latin typeface="Malgun Gothic" charset="0"/>
-                        <a:ea typeface="Malgun Gothic" charset="0"/>
-                        <a:cs typeface="Malgun Gothic" charset="0"/>
-                      </a:endParaRPr>
-                    </a:p>
-                  </a:txBody>
-                  <a:tcPr marL="45720" marR="45720" marT="45720" marB="45720" anchor="ctr">
-                    <a:lnL w="12700" cap="flat" cmpd="sng" algn="ctr">
-                      <a:solidFill>
-                        <a:srgbClr val="E1E8E2"/>
-                      </a:solidFill>
-                      <a:prstDash val="solid"/>
-                      <a:round/>
-                      <a:headEnd type="none" w="med" len="med"/>
-                      <a:tailEnd type="none" w="med" len="med"/>
-                    </a:lnL>
-                    <a:lnR w="12700" cap="flat" cmpd="sng" algn="ctr">
-                      <a:solidFill>
-                        <a:srgbClr val="E1E8E2"/>
-                      </a:solidFill>
-                      <a:prstDash val="solid"/>
-                      <a:round/>
-                      <a:headEnd type="none" w="med" len="med"/>
-                      <a:tailEnd type="none" w="med" len="med"/>
-                    </a:lnR>
-                    <a:lnT w="12700" cap="flat" cmpd="sng" algn="ctr">
-                      <a:solidFill>
-                        <a:srgbClr val="E1E8E2"/>
-                      </a:solidFill>
-                      <a:prstDash val="solid"/>
-                      <a:round/>
-                      <a:headEnd type="none" w="med" len="med"/>
-                      <a:tailEnd type="none" w="med" len="med"/>
-                    </a:lnT>
-                    <a:lnB w="12700" cap="flat" cmpd="sng" algn="ctr">
-                      <a:solidFill>
-                        <a:srgbClr val="E1E8E2"/>
-                      </a:solidFill>
-                      <a:prstDash val="solid"/>
-                      <a:round/>
-                      <a:headEnd type="none" w="med" len="med"/>
-                      <a:tailEnd type="none" w="med" len="med"/>
-                    </a:lnB>
-                  </a:tcPr>
-                </a:tc>
-                <a:tc>
-                  <a:txBody>
-                    <a:bodyPr/>
-                    <a:lstStyle/>
-                    <a:p>
-                      <a:pPr algn="l" indent="0" marL="0">
-                        <a:buNone/>
-                      </a:pPr>
-                      <a:r>
-                        <a:rPr lang="en-US" sz="1100" dirty="0">
-                          <a:solidFill>
-                            <a:srgbClr val="33413A"/>
-                          </a:solidFill>
-                          <a:latin typeface="Malgun Gothic" pitchFamily="34" charset="0"/>
-                          <a:ea typeface="Malgun Gothic" pitchFamily="34" charset="-122"/>
-                          <a:cs typeface="Malgun Gothic" pitchFamily="34" charset="-120"/>
-                        </a:rPr>
-                        <a:t>건강하고 안전한 생활습관을 기름</a:t>
-                      </a:r>
-                      <a:endParaRPr lang="en-US" sz="1100" dirty="0">
-                        <a:latin typeface="Malgun Gothic" charset="0"/>
-                        <a:ea typeface="Malgun Gothic" charset="0"/>
-                        <a:cs typeface="Malgun Gothic" charset="0"/>
-                      </a:endParaRPr>
-                    </a:p>
-                  </a:txBody>
-                  <a:tcPr marL="45720" marR="45720" marT="45720" marB="45720" anchor="ctr">
-                    <a:lnL w="12700" cap="flat" cmpd="sng" algn="ctr">
-                      <a:solidFill>
-                        <a:srgbClr val="E1E8E2"/>
-                      </a:solidFill>
-                      <a:prstDash val="solid"/>
-                      <a:round/>
-                      <a:headEnd type="none" w="med" len="med"/>
-                      <a:tailEnd type="none" w="med" len="med"/>
-                    </a:lnL>
-                    <a:lnR w="12700" cap="flat" cmpd="sng" algn="ctr">
-                      <a:solidFill>
-                        <a:srgbClr val="E1E8E2"/>
-                      </a:solidFill>
-                      <a:prstDash val="solid"/>
-                      <a:round/>
-                      <a:headEnd type="none" w="med" len="med"/>
-                      <a:tailEnd type="none" w="med" len="med"/>
-                    </a:lnR>
-                    <a:lnT w="12700" cap="flat" cmpd="sng" algn="ctr">
-                      <a:solidFill>
-                        <a:srgbClr val="E1E8E2"/>
-                      </a:solidFill>
-                      <a:prstDash val="solid"/>
-                      <a:round/>
-                      <a:headEnd type="none" w="med" len="med"/>
-                      <a:tailEnd type="none" w="med" len="med"/>
-                    </a:lnT>
-                    <a:lnB w="12700" cap="flat" cmpd="sng" algn="ctr">
-                      <a:solidFill>
-                        <a:srgbClr val="E1E8E2"/>
-                      </a:solidFill>
-                      <a:prstDash val="solid"/>
-                      <a:round/>
-                      <a:headEnd type="none" w="med" len="med"/>
-                      <a:tailEnd type="none" w="med" len="med"/>
-                    </a:lnB>
-                  </a:tcPr>
-                </a:tc>
-              </a:tr>
-              <a:tr h="457200">
-                <a:tc>
-                  <a:txBody>
-                    <a:bodyPr/>
-                    <a:lstStyle/>
-                    <a:p>
-                      <a:pPr algn="ctr" indent="0" marL="0">
-                        <a:buNone/>
-                      </a:pPr>
-                      <a:r>
-                        <a:rPr lang="en-US" sz="1100" b="1" dirty="0">
-                          <a:solidFill>
-                            <a:srgbClr val="33413A"/>
-                          </a:solidFill>
-                          <a:latin typeface="Malgun Gothic" pitchFamily="34" charset="0"/>
-                          <a:ea typeface="Malgun Gothic" pitchFamily="34" charset="-122"/>
-                          <a:cs typeface="Malgun Gothic" pitchFamily="34" charset="-120"/>
-                        </a:rPr>
-                        <a:t>자주적인 사람</a:t>
-                      </a:r>
-                      <a:endParaRPr lang="en-US" sz="1100" dirty="0">
-                        <a:latin typeface="Malgun Gothic" charset="0"/>
-                        <a:ea typeface="Malgun Gothic" charset="0"/>
-                        <a:cs typeface="Malgun Gothic" charset="0"/>
-                      </a:endParaRPr>
-                    </a:p>
-                  </a:txBody>
-                  <a:tcPr marL="45720" marR="45720" marT="45720" marB="45720" anchor="ctr">
-                    <a:lnL w="12700" cap="flat" cmpd="sng" algn="ctr">
-                      <a:solidFill>
-                        <a:srgbClr val="E1E8E2"/>
-                      </a:solidFill>
-                      <a:prstDash val="solid"/>
-                      <a:round/>
-                      <a:headEnd type="none" w="med" len="med"/>
-                      <a:tailEnd type="none" w="med" len="med"/>
-                    </a:lnL>
-                    <a:lnR w="12700" cap="flat" cmpd="sng" algn="ctr">
-                      <a:solidFill>
-                        <a:srgbClr val="E1E8E2"/>
-                      </a:solidFill>
-                      <a:prstDash val="solid"/>
-                      <a:round/>
-                      <a:headEnd type="none" w="med" len="med"/>
-                      <a:tailEnd type="none" w="med" len="med"/>
-                    </a:lnR>
-                    <a:lnT w="12700" cap="flat" cmpd="sng" algn="ctr">
-                      <a:solidFill>
-                        <a:srgbClr val="E1E8E2"/>
-                      </a:solidFill>
-                      <a:prstDash val="solid"/>
-                      <a:round/>
-                      <a:headEnd type="none" w="med" len="med"/>
-                      <a:tailEnd type="none" w="med" len="med"/>
-                    </a:lnT>
-                    <a:lnB w="12700" cap="flat" cmpd="sng" algn="ctr">
-                      <a:solidFill>
-                        <a:srgbClr val="E1E8E2"/>
-                      </a:solidFill>
-                      <a:prstDash val="solid"/>
-                      <a:round/>
-                      <a:headEnd type="none" w="med" len="med"/>
-                      <a:tailEnd type="none" w="med" len="med"/>
-                    </a:lnB>
-                    <a:solidFill>
-                      <a:srgbClr val="FDF3D6"/>
-                    </a:solidFill>
-                  </a:tcPr>
-                </a:tc>
-                <a:tc>
-                  <a:txBody>
-                    <a:bodyPr/>
-                    <a:lstStyle/>
-                    <a:p>
-                      <a:pPr algn="l" indent="0" marL="0">
-                        <a:buNone/>
-                      </a:pPr>
-                      <a:r>
-                        <a:rPr lang="en-US" sz="1100" dirty="0">
-                          <a:solidFill>
-                            <a:srgbClr val="33413A"/>
-                          </a:solidFill>
-                          <a:latin typeface="Malgun Gothic" pitchFamily="34" charset="0"/>
-                          <a:ea typeface="Malgun Gothic" pitchFamily="34" charset="-122"/>
-                          <a:cs typeface="Malgun Gothic" pitchFamily="34" charset="-120"/>
-                        </a:rPr>
-                        <a:t>자신의 일을 스스로 하고자 함</a:t>
-                      </a:r>
-                      <a:endParaRPr lang="en-US" sz="1100" dirty="0">
-                        <a:latin typeface="Malgun Gothic" charset="0"/>
-                        <a:ea typeface="Malgun Gothic" charset="0"/>
-                        <a:cs typeface="Malgun Gothic" charset="0"/>
-                      </a:endParaRPr>
-                    </a:p>
-                  </a:txBody>
-                  <a:tcPr marL="45720" marR="45720" marT="45720" marB="45720" anchor="ctr">
-                    <a:lnL w="12700" cap="flat" cmpd="sng" algn="ctr">
-                      <a:solidFill>
-                        <a:srgbClr val="E1E8E2"/>
-                      </a:solidFill>
-                      <a:prstDash val="solid"/>
-                      <a:round/>
-                      <a:headEnd type="none" w="med" len="med"/>
-                      <a:tailEnd type="none" w="med" len="med"/>
-                    </a:lnL>
-                    <a:lnR w="12700" cap="flat" cmpd="sng" algn="ctr">
-                      <a:solidFill>
-                        <a:srgbClr val="E1E8E2"/>
-                      </a:solidFill>
-                      <a:prstDash val="solid"/>
-                      <a:round/>
-                      <a:headEnd type="none" w="med" len="med"/>
-                      <a:tailEnd type="none" w="med" len="med"/>
-                    </a:lnR>
-                    <a:lnT w="12700" cap="flat" cmpd="sng" algn="ctr">
-                      <a:solidFill>
-                        <a:srgbClr val="E1E8E2"/>
-                      </a:solidFill>
-                      <a:prstDash val="solid"/>
-                      <a:round/>
-                      <a:headEnd type="none" w="med" len="med"/>
-                      <a:tailEnd type="none" w="med" len="med"/>
-                    </a:lnT>
-                    <a:lnB w="12700" cap="flat" cmpd="sng" algn="ctr">
-                      <a:solidFill>
-                        <a:srgbClr val="E1E8E2"/>
-                      </a:solidFill>
-                      <a:prstDash val="solid"/>
-                      <a:round/>
-                      <a:headEnd type="none" w="med" len="med"/>
-                      <a:tailEnd type="none" w="med" len="med"/>
-                    </a:lnB>
-                  </a:tcPr>
-                </a:tc>
-                <a:tc>
-                  <a:txBody>
-                    <a:bodyPr/>
-                    <a:lstStyle/>
-                    <a:p>
-                      <a:pPr algn="l" indent="0" marL="0">
-                        <a:buNone/>
-                      </a:pPr>
-                      <a:r>
-                        <a:rPr lang="en-US" sz="1100" dirty="0">
-                          <a:solidFill>
-                            <a:srgbClr val="33413A"/>
-                          </a:solidFill>
-                          <a:latin typeface="Malgun Gothic" pitchFamily="34" charset="0"/>
-                          <a:ea typeface="Malgun Gothic" pitchFamily="34" charset="-122"/>
-                          <a:cs typeface="Malgun Gothic" pitchFamily="34" charset="-120"/>
-                        </a:rPr>
-                        <a:t>스스로 해결하는 기초능력을 기름</a:t>
-                      </a:r>
-                      <a:endParaRPr lang="en-US" sz="1100" dirty="0">
-                        <a:latin typeface="Malgun Gothic" charset="0"/>
-                        <a:ea typeface="Malgun Gothic" charset="0"/>
-                        <a:cs typeface="Malgun Gothic" charset="0"/>
-                      </a:endParaRPr>
-                    </a:p>
-                  </a:txBody>
-                  <a:tcPr marL="45720" marR="45720" marT="45720" marB="45720" anchor="ctr">
-                    <a:lnL w="12700" cap="flat" cmpd="sng" algn="ctr">
-                      <a:solidFill>
-                        <a:srgbClr val="E1E8E2"/>
-                      </a:solidFill>
-                      <a:prstDash val="solid"/>
-                      <a:round/>
-                      <a:headEnd type="none" w="med" len="med"/>
-                      <a:tailEnd type="none" w="med" len="med"/>
-                    </a:lnL>
-                    <a:lnR w="12700" cap="flat" cmpd="sng" algn="ctr">
-                      <a:solidFill>
-                        <a:srgbClr val="E1E8E2"/>
-                      </a:solidFill>
-                      <a:prstDash val="solid"/>
-                      <a:round/>
-                      <a:headEnd type="none" w="med" len="med"/>
-                      <a:tailEnd type="none" w="med" len="med"/>
-                    </a:lnR>
-                    <a:lnT w="12700" cap="flat" cmpd="sng" algn="ctr">
-                      <a:solidFill>
-                        <a:srgbClr val="E1E8E2"/>
-                      </a:solidFill>
-                      <a:prstDash val="solid"/>
-                      <a:round/>
-                      <a:headEnd type="none" w="med" len="med"/>
-                      <a:tailEnd type="none" w="med" len="med"/>
-                    </a:lnT>
-                    <a:lnB w="12700" cap="flat" cmpd="sng" algn="ctr">
-                      <a:solidFill>
-                        <a:srgbClr val="E1E8E2"/>
-                      </a:solidFill>
-                      <a:prstDash val="solid"/>
-                      <a:round/>
-                      <a:headEnd type="none" w="med" len="med"/>
-                      <a:tailEnd type="none" w="med" len="med"/>
-                    </a:lnB>
-                  </a:tcPr>
-                </a:tc>
-              </a:tr>
-              <a:tr h="457200">
-                <a:tc>
-                  <a:txBody>
-                    <a:bodyPr/>
-                    <a:lstStyle/>
-                    <a:p>
-                      <a:pPr algn="ctr" indent="0" marL="0">
-                        <a:buNone/>
-                      </a:pPr>
-                      <a:r>
-                        <a:rPr lang="en-US" sz="1100" b="1" dirty="0">
-                          <a:solidFill>
-                            <a:srgbClr val="33413A"/>
-                          </a:solidFill>
-                          <a:latin typeface="Malgun Gothic" pitchFamily="34" charset="0"/>
-                          <a:ea typeface="Malgun Gothic" pitchFamily="34" charset="-122"/>
-                          <a:cs typeface="Malgun Gothic" pitchFamily="34" charset="-120"/>
-                        </a:rPr>
-                        <a:t>창의적인 사람</a:t>
-                      </a:r>
-                      <a:endParaRPr lang="en-US" sz="1100" dirty="0">
-                        <a:latin typeface="Malgun Gothic" charset="0"/>
-                        <a:ea typeface="Malgun Gothic" charset="0"/>
-                        <a:cs typeface="Malgun Gothic" charset="0"/>
-                      </a:endParaRPr>
-                    </a:p>
-                  </a:txBody>
-                  <a:tcPr marL="45720" marR="45720" marT="45720" marB="45720" anchor="ctr">
-                    <a:lnL w="12700" cap="flat" cmpd="sng" algn="ctr">
-                      <a:solidFill>
-                        <a:srgbClr val="E1E8E2"/>
-                      </a:solidFill>
-                      <a:prstDash val="solid"/>
-                      <a:round/>
-                      <a:headEnd type="none" w="med" len="med"/>
-                      <a:tailEnd type="none" w="med" len="med"/>
-                    </a:lnL>
-                    <a:lnR w="12700" cap="flat" cmpd="sng" algn="ctr">
-                      <a:solidFill>
-                        <a:srgbClr val="E1E8E2"/>
-                      </a:solidFill>
-                      <a:prstDash val="solid"/>
-                      <a:round/>
-                      <a:headEnd type="none" w="med" len="med"/>
-                      <a:tailEnd type="none" w="med" len="med"/>
-                    </a:lnR>
-                    <a:lnT w="12700" cap="flat" cmpd="sng" algn="ctr">
-                      <a:solidFill>
-                        <a:srgbClr val="E1E8E2"/>
-                      </a:solidFill>
-                      <a:prstDash val="solid"/>
-                      <a:round/>
-                      <a:headEnd type="none" w="med" len="med"/>
-                      <a:tailEnd type="none" w="med" len="med"/>
-                    </a:lnT>
-                    <a:lnB w="12700" cap="flat" cmpd="sng" algn="ctr">
-                      <a:solidFill>
-                        <a:srgbClr val="E1E8E2"/>
-                      </a:solidFill>
-                      <a:prstDash val="solid"/>
-                      <a:round/>
-                      <a:headEnd type="none" w="med" len="med"/>
-                      <a:tailEnd type="none" w="med" len="med"/>
-                    </a:lnB>
-                    <a:solidFill>
-                      <a:srgbClr val="DCEBDD"/>
-                    </a:solidFill>
-                  </a:tcPr>
-                </a:tc>
-                <a:tc>
-                  <a:txBody>
-                    <a:bodyPr/>
-                    <a:lstStyle/>
-                    <a:p>
-                      <a:pPr algn="l" indent="0" marL="0">
-                        <a:buNone/>
-                      </a:pPr>
-                      <a:r>
-                        <a:rPr lang="en-US" sz="1100" dirty="0">
-                          <a:solidFill>
-                            <a:srgbClr val="33413A"/>
-                          </a:solidFill>
-                          <a:latin typeface="Malgun Gothic" pitchFamily="34" charset="0"/>
-                          <a:ea typeface="Malgun Gothic" pitchFamily="34" charset="-122"/>
-                          <a:cs typeface="Malgun Gothic" pitchFamily="34" charset="-120"/>
-                        </a:rPr>
-                        <a:t>호기심을 갖고 탐색하며 상상력을 기름</a:t>
-                      </a:r>
-                      <a:endParaRPr lang="en-US" sz="1100" dirty="0">
-                        <a:latin typeface="Malgun Gothic" charset="0"/>
-                        <a:ea typeface="Malgun Gothic" charset="0"/>
-                        <a:cs typeface="Malgun Gothic" charset="0"/>
-                      </a:endParaRPr>
-                    </a:p>
-                  </a:txBody>
-                  <a:tcPr marL="45720" marR="45720" marT="45720" marB="45720" anchor="ctr">
-                    <a:lnL w="12700" cap="flat" cmpd="sng" algn="ctr">
-                      <a:solidFill>
-                        <a:srgbClr val="E1E8E2"/>
-                      </a:solidFill>
-                      <a:prstDash val="solid"/>
-                      <a:round/>
-                      <a:headEnd type="none" w="med" len="med"/>
-                      <a:tailEnd type="none" w="med" len="med"/>
-                    </a:lnL>
-                    <a:lnR w="12700" cap="flat" cmpd="sng" algn="ctr">
-                      <a:solidFill>
-                        <a:srgbClr val="E1E8E2"/>
-                      </a:solidFill>
-                      <a:prstDash val="solid"/>
-                      <a:round/>
-                      <a:headEnd type="none" w="med" len="med"/>
-                      <a:tailEnd type="none" w="med" len="med"/>
-                    </a:lnR>
-                    <a:lnT w="12700" cap="flat" cmpd="sng" algn="ctr">
-                      <a:solidFill>
-                        <a:srgbClr val="E1E8E2"/>
-                      </a:solidFill>
-                      <a:prstDash val="solid"/>
-                      <a:round/>
-                      <a:headEnd type="none" w="med" len="med"/>
-                      <a:tailEnd type="none" w="med" len="med"/>
-                    </a:lnT>
-                    <a:lnB w="12700" cap="flat" cmpd="sng" algn="ctr">
-                      <a:solidFill>
-                        <a:srgbClr val="E1E8E2"/>
-                      </a:solidFill>
-                      <a:prstDash val="solid"/>
-                      <a:round/>
-                      <a:headEnd type="none" w="med" len="med"/>
-                      <a:tailEnd type="none" w="med" len="med"/>
-                    </a:lnB>
-                  </a:tcPr>
-                </a:tc>
-                <a:tc>
-                  <a:txBody>
-                    <a:bodyPr/>
-                    <a:lstStyle/>
-                    <a:p>
-                      <a:pPr algn="l" indent="0" marL="0">
-                        <a:buNone/>
-                      </a:pPr>
-                      <a:r>
-                        <a:rPr lang="en-US" sz="1100" dirty="0">
-                          <a:solidFill>
-                            <a:srgbClr val="33413A"/>
-                          </a:solidFill>
-                          <a:latin typeface="Malgun Gothic" pitchFamily="34" charset="0"/>
-                          <a:ea typeface="Malgun Gothic" pitchFamily="34" charset="-122"/>
-                          <a:cs typeface="Malgun Gothic" pitchFamily="34" charset="-120"/>
-                        </a:rPr>
-                        <a:t>호기심·탐구심, 상상력·창의력을 기름</a:t>
-                      </a:r>
-                      <a:endParaRPr lang="en-US" sz="1100" dirty="0">
-                        <a:latin typeface="Malgun Gothic" charset="0"/>
-                        <a:ea typeface="Malgun Gothic" charset="0"/>
-                        <a:cs typeface="Malgun Gothic" charset="0"/>
-                      </a:endParaRPr>
-                    </a:p>
-                  </a:txBody>
-                  <a:tcPr marL="45720" marR="45720" marT="45720" marB="45720" anchor="ctr">
-                    <a:lnL w="12700" cap="flat" cmpd="sng" algn="ctr">
-                      <a:solidFill>
-                        <a:srgbClr val="E1E8E2"/>
-                      </a:solidFill>
-                      <a:prstDash val="solid"/>
-                      <a:round/>
-                      <a:headEnd type="none" w="med" len="med"/>
-                      <a:tailEnd type="none" w="med" len="med"/>
-                    </a:lnL>
-                    <a:lnR w="12700" cap="flat" cmpd="sng" algn="ctr">
-                      <a:solidFill>
-                        <a:srgbClr val="E1E8E2"/>
-                      </a:solidFill>
-                      <a:prstDash val="solid"/>
-                      <a:round/>
-                      <a:headEnd type="none" w="med" len="med"/>
-                      <a:tailEnd type="none" w="med" len="med"/>
-                    </a:lnR>
-                    <a:lnT w="12700" cap="flat" cmpd="sng" algn="ctr">
-                      <a:solidFill>
-                        <a:srgbClr val="E1E8E2"/>
-                      </a:solidFill>
-                      <a:prstDash val="solid"/>
-                      <a:round/>
-                      <a:headEnd type="none" w="med" len="med"/>
-                      <a:tailEnd type="none" w="med" len="med"/>
-                    </a:lnT>
-                    <a:lnB w="12700" cap="flat" cmpd="sng" algn="ctr">
-                      <a:solidFill>
-                        <a:srgbClr val="E1E8E2"/>
-                      </a:solidFill>
-                      <a:prstDash val="solid"/>
-                      <a:round/>
-                      <a:headEnd type="none" w="med" len="med"/>
-                      <a:tailEnd type="none" w="med" len="med"/>
-                    </a:lnB>
-                  </a:tcPr>
-                </a:tc>
-              </a:tr>
-              <a:tr h="457200">
-                <a:tc>
-                  <a:txBody>
-                    <a:bodyPr/>
-                    <a:lstStyle/>
-                    <a:p>
-                      <a:pPr algn="ctr" indent="0" marL="0">
-                        <a:buNone/>
-                      </a:pPr>
-                      <a:r>
-                        <a:rPr lang="en-US" sz="1100" b="1" dirty="0">
-                          <a:solidFill>
-                            <a:srgbClr val="33413A"/>
-                          </a:solidFill>
-                          <a:latin typeface="Malgun Gothic" pitchFamily="34" charset="0"/>
-                          <a:ea typeface="Malgun Gothic" pitchFamily="34" charset="-122"/>
-                          <a:cs typeface="Malgun Gothic" pitchFamily="34" charset="-120"/>
-                        </a:rPr>
-                        <a:t>감성이 풍부한 사람</a:t>
-                      </a:r>
-                      <a:endParaRPr lang="en-US" sz="1100" dirty="0">
-                        <a:latin typeface="Malgun Gothic" charset="0"/>
-                        <a:ea typeface="Malgun Gothic" charset="0"/>
-                        <a:cs typeface="Malgun Gothic" charset="0"/>
-                      </a:endParaRPr>
-                    </a:p>
-                  </a:txBody>
-                  <a:tcPr marL="45720" marR="45720" marT="45720" marB="45720" anchor="ctr">
-                    <a:lnL w="12700" cap="flat" cmpd="sng" algn="ctr">
-                      <a:solidFill>
-                        <a:srgbClr val="E1E8E2"/>
-                      </a:solidFill>
-                      <a:prstDash val="solid"/>
-                      <a:round/>
-                      <a:headEnd type="none" w="med" len="med"/>
-                      <a:tailEnd type="none" w="med" len="med"/>
-                    </a:lnL>
-                    <a:lnR w="12700" cap="flat" cmpd="sng" algn="ctr">
-                      <a:solidFill>
-                        <a:srgbClr val="E1E8E2"/>
-                      </a:solidFill>
-                      <a:prstDash val="solid"/>
-                      <a:round/>
-                      <a:headEnd type="none" w="med" len="med"/>
-                      <a:tailEnd type="none" w="med" len="med"/>
-                    </a:lnR>
-                    <a:lnT w="12700" cap="flat" cmpd="sng" algn="ctr">
-                      <a:solidFill>
-                        <a:srgbClr val="E1E8E2"/>
-                      </a:solidFill>
-                      <a:prstDash val="solid"/>
-                      <a:round/>
-                      <a:headEnd type="none" w="med" len="med"/>
-                      <a:tailEnd type="none" w="med" len="med"/>
-                    </a:lnT>
-                    <a:lnB w="12700" cap="flat" cmpd="sng" algn="ctr">
-                      <a:solidFill>
-                        <a:srgbClr val="E1E8E2"/>
-                      </a:solidFill>
-                      <a:prstDash val="solid"/>
-                      <a:round/>
-                      <a:headEnd type="none" w="med" len="med"/>
-                      <a:tailEnd type="none" w="med" len="med"/>
-                    </a:lnB>
-                    <a:solidFill>
-                      <a:srgbClr val="F9E1E3"/>
-                    </a:solidFill>
-                  </a:tcPr>
-                </a:tc>
-                <a:tc>
-                  <a:txBody>
-                    <a:bodyPr/>
-                    <a:lstStyle/>
-                    <a:p>
-                      <a:pPr algn="l" indent="0" marL="0">
-                        <a:buNone/>
-                      </a:pPr>
-                      <a:r>
-                        <a:rPr lang="en-US" sz="1100" dirty="0">
-                          <a:solidFill>
-                            <a:srgbClr val="33413A"/>
-                          </a:solidFill>
-                          <a:latin typeface="Malgun Gothic" pitchFamily="34" charset="0"/>
-                          <a:ea typeface="Malgun Gothic" pitchFamily="34" charset="-122"/>
-                          <a:cs typeface="Malgun Gothic" pitchFamily="34" charset="-120"/>
-                        </a:rPr>
-                        <a:t>일상에서 아름다움에 관심, 감성을 기름</a:t>
-                      </a:r>
-                      <a:endParaRPr lang="en-US" sz="1100" dirty="0">
-                        <a:latin typeface="Malgun Gothic" charset="0"/>
-                        <a:ea typeface="Malgun Gothic" charset="0"/>
-                        <a:cs typeface="Malgun Gothic" charset="0"/>
-                      </a:endParaRPr>
-                    </a:p>
-                  </a:txBody>
-                  <a:tcPr marL="45720" marR="45720" marT="45720" marB="45720" anchor="ctr">
-                    <a:lnL w="12700" cap="flat" cmpd="sng" algn="ctr">
-                      <a:solidFill>
-                        <a:srgbClr val="E1E8E2"/>
-                      </a:solidFill>
-                      <a:prstDash val="solid"/>
-                      <a:round/>
-                      <a:headEnd type="none" w="med" len="med"/>
-                      <a:tailEnd type="none" w="med" len="med"/>
-                    </a:lnL>
-                    <a:lnR w="12700" cap="flat" cmpd="sng" algn="ctr">
-                      <a:solidFill>
-                        <a:srgbClr val="E1E8E2"/>
-                      </a:solidFill>
-                      <a:prstDash val="solid"/>
-                      <a:round/>
-                      <a:headEnd type="none" w="med" len="med"/>
-                      <a:tailEnd type="none" w="med" len="med"/>
-                    </a:lnR>
-                    <a:lnT w="12700" cap="flat" cmpd="sng" algn="ctr">
-                      <a:solidFill>
-                        <a:srgbClr val="E1E8E2"/>
-                      </a:solidFill>
-                      <a:prstDash val="solid"/>
-                      <a:round/>
-                      <a:headEnd type="none" w="med" len="med"/>
-                      <a:tailEnd type="none" w="med" len="med"/>
-                    </a:lnT>
-                    <a:lnB w="12700" cap="flat" cmpd="sng" algn="ctr">
-                      <a:solidFill>
-                        <a:srgbClr val="E1E8E2"/>
-                      </a:solidFill>
-                      <a:prstDash val="solid"/>
-                      <a:round/>
-                      <a:headEnd type="none" w="med" len="med"/>
-                      <a:tailEnd type="none" w="med" len="med"/>
-                    </a:lnB>
-                  </a:tcPr>
-                </a:tc>
-                <a:tc>
-                  <a:txBody>
-                    <a:bodyPr/>
-                    <a:lstStyle/>
-                    <a:p>
-                      <a:pPr algn="l" indent="0" marL="0">
-                        <a:buNone/>
-                      </a:pPr>
-                      <a:r>
-                        <a:rPr lang="en-US" sz="1100" dirty="0">
-                          <a:solidFill>
-                            <a:srgbClr val="33413A"/>
-                          </a:solidFill>
-                          <a:latin typeface="Malgun Gothic" pitchFamily="34" charset="0"/>
-                          <a:ea typeface="Malgun Gothic" pitchFamily="34" charset="-122"/>
-                          <a:cs typeface="Malgun Gothic" pitchFamily="34" charset="-120"/>
-                        </a:rPr>
-                        <a:t>아름다움을 느끼고 문화적 감수성을 기름</a:t>
-                      </a:r>
-                      <a:endParaRPr lang="en-US" sz="1100" dirty="0">
-                        <a:latin typeface="Malgun Gothic" charset="0"/>
-                        <a:ea typeface="Malgun Gothic" charset="0"/>
-                        <a:cs typeface="Malgun Gothic" charset="0"/>
-                      </a:endParaRPr>
-                    </a:p>
-                  </a:txBody>
-                  <a:tcPr marL="45720" marR="45720" marT="45720" marB="45720" anchor="ctr">
-                    <a:lnL w="12700" cap="flat" cmpd="sng" algn="ctr">
-                      <a:solidFill>
-                        <a:srgbClr val="E1E8E2"/>
-                      </a:solidFill>
-                      <a:prstDash val="solid"/>
-                      <a:round/>
-                      <a:headEnd type="none" w="med" len="med"/>
-                      <a:tailEnd type="none" w="med" len="med"/>
-                    </a:lnL>
-                    <a:lnR w="12700" cap="flat" cmpd="sng" algn="ctr">
-                      <a:solidFill>
-                        <a:srgbClr val="E1E8E2"/>
-                      </a:solidFill>
-                      <a:prstDash val="solid"/>
-                      <a:round/>
-                      <a:headEnd type="none" w="med" len="med"/>
-                      <a:tailEnd type="none" w="med" len="med"/>
-                    </a:lnR>
-                    <a:lnT w="12700" cap="flat" cmpd="sng" algn="ctr">
-                      <a:solidFill>
-                        <a:srgbClr val="E1E8E2"/>
-                      </a:solidFill>
-                      <a:prstDash val="solid"/>
-                      <a:round/>
-                      <a:headEnd type="none" w="med" len="med"/>
-                      <a:tailEnd type="none" w="med" len="med"/>
-                    </a:lnT>
-                    <a:lnB w="12700" cap="flat" cmpd="sng" algn="ctr">
-                      <a:solidFill>
-                        <a:srgbClr val="E1E8E2"/>
-                      </a:solidFill>
-                      <a:prstDash val="solid"/>
-                      <a:round/>
-                      <a:headEnd type="none" w="med" len="med"/>
-                      <a:tailEnd type="none" w="med" len="med"/>
-                    </a:lnB>
-                  </a:tcPr>
-                </a:tc>
-              </a:tr>
-              <a:tr h="457200">
-                <a:tc>
-                  <a:txBody>
-                    <a:bodyPr/>
-                    <a:lstStyle/>
-                    <a:p>
-                      <a:pPr algn="ctr" indent="0" marL="0">
-                        <a:buNone/>
-                      </a:pPr>
-                      <a:r>
-                        <a:rPr lang="en-US" sz="1100" b="1" dirty="0">
-                          <a:solidFill>
-                            <a:srgbClr val="33413A"/>
-                          </a:solidFill>
-                          <a:latin typeface="Malgun Gothic" pitchFamily="34" charset="0"/>
-                          <a:ea typeface="Malgun Gothic" pitchFamily="34" charset="-122"/>
-                          <a:cs typeface="Malgun Gothic" pitchFamily="34" charset="-120"/>
-                        </a:rPr>
-                        <a:t>더불어 사는 사람</a:t>
-                      </a:r>
-                      <a:endParaRPr lang="en-US" sz="1100" dirty="0">
-                        <a:latin typeface="Malgun Gothic" charset="0"/>
-                        <a:ea typeface="Malgun Gothic" charset="0"/>
-                        <a:cs typeface="Malgun Gothic" charset="0"/>
-                      </a:endParaRPr>
-                    </a:p>
-                  </a:txBody>
-                  <a:tcPr marL="45720" marR="45720" marT="45720" marB="45720" anchor="ctr">
-                    <a:lnL w="12700" cap="flat" cmpd="sng" algn="ctr">
-                      <a:solidFill>
-                        <a:srgbClr val="E1E8E2"/>
-                      </a:solidFill>
-                      <a:prstDash val="solid"/>
-                      <a:round/>
-                      <a:headEnd type="none" w="med" len="med"/>
-                      <a:tailEnd type="none" w="med" len="med"/>
-                    </a:lnL>
-                    <a:lnR w="12700" cap="flat" cmpd="sng" algn="ctr">
-                      <a:solidFill>
-                        <a:srgbClr val="E1E8E2"/>
-                      </a:solidFill>
-                      <a:prstDash val="solid"/>
-                      <a:round/>
-                      <a:headEnd type="none" w="med" len="med"/>
-                      <a:tailEnd type="none" w="med" len="med"/>
-                    </a:lnR>
-                    <a:lnT w="12700" cap="flat" cmpd="sng" algn="ctr">
-                      <a:solidFill>
-                        <a:srgbClr val="E1E8E2"/>
-                      </a:solidFill>
-                      <a:prstDash val="solid"/>
-                      <a:round/>
-                      <a:headEnd type="none" w="med" len="med"/>
-                      <a:tailEnd type="none" w="med" len="med"/>
-                    </a:lnT>
-                    <a:lnB w="12700" cap="flat" cmpd="sng" algn="ctr">
-                      <a:solidFill>
-                        <a:srgbClr val="E1E8E2"/>
-                      </a:solidFill>
-                      <a:prstDash val="solid"/>
-                      <a:round/>
-                      <a:headEnd type="none" w="med" len="med"/>
-                      <a:tailEnd type="none" w="med" len="med"/>
-                    </a:lnB>
-                    <a:solidFill>
-                      <a:srgbClr val="EDE6F3"/>
-                    </a:solidFill>
-                  </a:tcPr>
-                </a:tc>
-                <a:tc>
-                  <a:txBody>
-                    <a:bodyPr/>
-                    <a:lstStyle/>
-                    <a:p>
-                      <a:pPr algn="l" indent="0" marL="0">
-                        <a:buNone/>
-                      </a:pPr>
-                      <a:r>
-                        <a:rPr lang="en-US" sz="1100" dirty="0">
-                          <a:solidFill>
-                            <a:srgbClr val="33413A"/>
-                          </a:solidFill>
-                          <a:latin typeface="Malgun Gothic" pitchFamily="34" charset="0"/>
-                          <a:ea typeface="Malgun Gothic" pitchFamily="34" charset="-122"/>
-                          <a:cs typeface="Malgun Gothic" pitchFamily="34" charset="-120"/>
-                        </a:rPr>
-                        <a:t>사람과 자연을 존중하고 소통에 관심</a:t>
-                      </a:r>
-                      <a:endParaRPr lang="en-US" sz="1100" dirty="0">
-                        <a:latin typeface="Malgun Gothic" charset="0"/>
-                        <a:ea typeface="Malgun Gothic" charset="0"/>
-                        <a:cs typeface="Malgun Gothic" charset="0"/>
-                      </a:endParaRPr>
-                    </a:p>
-                  </a:txBody>
-                  <a:tcPr marL="45720" marR="45720" marT="45720" marB="45720" anchor="ctr">
-                    <a:lnL w="12700" cap="flat" cmpd="sng" algn="ctr">
-                      <a:solidFill>
-                        <a:srgbClr val="E1E8E2"/>
-                      </a:solidFill>
-                      <a:prstDash val="solid"/>
-                      <a:round/>
-                      <a:headEnd type="none" w="med" len="med"/>
-                      <a:tailEnd type="none" w="med" len="med"/>
-                    </a:lnL>
-                    <a:lnR w="12700" cap="flat" cmpd="sng" algn="ctr">
-                      <a:solidFill>
-                        <a:srgbClr val="E1E8E2"/>
-                      </a:solidFill>
-                      <a:prstDash val="solid"/>
-                      <a:round/>
-                      <a:headEnd type="none" w="med" len="med"/>
-                      <a:tailEnd type="none" w="med" len="med"/>
-                    </a:lnR>
-                    <a:lnT w="12700" cap="flat" cmpd="sng" algn="ctr">
-                      <a:solidFill>
-                        <a:srgbClr val="E1E8E2"/>
-                      </a:solidFill>
-                      <a:prstDash val="solid"/>
-                      <a:round/>
-                      <a:headEnd type="none" w="med" len="med"/>
-                      <a:tailEnd type="none" w="med" len="med"/>
-                    </a:lnT>
-                    <a:lnB w="12700" cap="flat" cmpd="sng" algn="ctr">
-                      <a:solidFill>
-                        <a:srgbClr val="E1E8E2"/>
-                      </a:solidFill>
-                      <a:prstDash val="solid"/>
-                      <a:round/>
-                      <a:headEnd type="none" w="med" len="med"/>
-                      <a:tailEnd type="none" w="med" len="med"/>
-                    </a:lnB>
-                  </a:tcPr>
-                </a:tc>
-                <a:tc>
-                  <a:txBody>
-                    <a:bodyPr/>
-                    <a:lstStyle/>
-                    <a:p>
-                      <a:pPr algn="l" indent="0" marL="0">
-                        <a:buNone/>
-                      </a:pPr>
-                      <a:r>
-                        <a:rPr lang="en-US" sz="1100" dirty="0">
-                          <a:solidFill>
-                            <a:srgbClr val="33413A"/>
-                          </a:solidFill>
-                          <a:latin typeface="Malgun Gothic" pitchFamily="34" charset="0"/>
-                          <a:ea typeface="Malgun Gothic" pitchFamily="34" charset="-122"/>
-                          <a:cs typeface="Malgun Gothic" pitchFamily="34" charset="-120"/>
-                        </a:rPr>
-                        <a:t>존중·배려하며 소통하는 태도를 기름</a:t>
-                      </a:r>
-                      <a:endParaRPr lang="en-US" sz="1100" dirty="0">
-                        <a:latin typeface="Malgun Gothic" charset="0"/>
-                        <a:ea typeface="Malgun Gothic" charset="0"/>
-                        <a:cs typeface="Malgun Gothic" charset="0"/>
-                      </a:endParaRPr>
-                    </a:p>
-                  </a:txBody>
-                  <a:tcPr marL="45720" marR="45720" marT="45720" marB="45720" anchor="ctr">
-                    <a:lnL w="12700" cap="flat" cmpd="sng" algn="ctr">
-                      <a:solidFill>
-                        <a:srgbClr val="E1E8E2"/>
-                      </a:solidFill>
-                      <a:prstDash val="solid"/>
-                      <a:round/>
-                      <a:headEnd type="none" w="med" len="med"/>
-                      <a:tailEnd type="none" w="med" len="med"/>
-                    </a:lnL>
-                    <a:lnR w="12700" cap="flat" cmpd="sng" algn="ctr">
-                      <a:solidFill>
-                        <a:srgbClr val="E1E8E2"/>
-                      </a:solidFill>
-                      <a:prstDash val="solid"/>
-                      <a:round/>
-                      <a:headEnd type="none" w="med" len="med"/>
-                      <a:tailEnd type="none" w="med" len="med"/>
-                    </a:lnR>
-                    <a:lnT w="12700" cap="flat" cmpd="sng" algn="ctr">
-                      <a:solidFill>
-                        <a:srgbClr val="E1E8E2"/>
-                      </a:solidFill>
-                      <a:prstDash val="solid"/>
-                      <a:round/>
-                      <a:headEnd type="none" w="med" len="med"/>
-                      <a:tailEnd type="none" w="med" len="med"/>
-                    </a:lnT>
-                    <a:lnB w="12700" cap="flat" cmpd="sng" algn="ctr">
-                      <a:solidFill>
-                        <a:srgbClr val="E1E8E2"/>
-                      </a:solidFill>
-                      <a:prstDash val="solid"/>
-                      <a:round/>
-                      <a:headEnd type="none" w="med" len="med"/>
-                      <a:tailEnd type="none" w="med" len="med"/>
-                    </a:lnB>
-                  </a:tcPr>
-                </a:tc>
-              </a:tr>
-            </a:tbl>
-          </a:graphicData>
-        </a:graphic>
-      </p:graphicFrame>
-      <p:sp>
-        <p:nvSpPr>
-          <p:cNvPr id="8" name="Text 5"/>
-          <p:cNvSpPr txBox="1"/>
-          <p:nvPr/>
-        </p:nvSpPr>
-        <p:spPr>
-          <a:xfrm>
-            <a:off x="457200" y="4526280"/>
-            <a:ext cx="8229600" cy="274320"/>
+              <a:t>영유아가 놀이를 통해 심신의 건강과 조화로운 발달을 이루고, 바른 인성과 민주 시민의 기초를 형성</a:t>
+            </a:r>
+            <a:endParaRPr lang="en-US" sz="1200" dirty="0"/>
+          </a:p>
+        </p:txBody>
+      </p:sp>
+      <p:sp>
+        <p:nvSpPr>
+          <p:cNvPr id="18" name="Shape 16"/>
+          <p:cNvSpPr/>
+          <p:nvPr/>
+        </p:nvSpPr>
+        <p:spPr>
+          <a:xfrm>
+            <a:off x="457200" y="2514600"/>
+            <a:ext cx="4023360" cy="2240280"/>
+          </a:xfrm>
+          <a:prstGeom prst="roundRect">
+            <a:avLst>
+              <a:gd name="adj" fmla="val 6122"/>
+            </a:avLst>
+          </a:prstGeom>
+          <a:solidFill>
+            <a:srgbClr val="FCE4D8"/>
+          </a:solidFill>
+          <a:ln/>
+        </p:spPr>
+      </p:sp>
+      <p:sp>
+        <p:nvSpPr>
+          <p:cNvPr id="19" name="Text 17"/>
+          <p:cNvSpPr txBox="1"/>
+          <p:nvPr/>
+        </p:nvSpPr>
+        <p:spPr>
+          <a:xfrm>
+            <a:off x="640080" y="2587752"/>
+            <a:ext cx="3657600" cy="320040"/>
           </a:xfrm>
           <a:prstGeom prst="rect">
             <a:avLst/>
@@ -11502,17 +10587,332 @@
               <a:buNone/>
             </a:pPr>
             <a:r>
-              <a:rPr lang="en-US" sz="1200" b="1" dirty="0">
-                <a:solidFill>
-                  <a:srgbClr val="5E8C6A"/>
-                </a:solidFill>
-                <a:latin typeface="Malgun Gothic" pitchFamily="34" charset="0"/>
-                <a:ea typeface="Malgun Gothic" pitchFamily="34" charset="-122"/>
-                <a:cs typeface="Malgun Gothic" pitchFamily="34" charset="-120"/>
-              </a:rPr>
-              <a:t>0~2세 "관심을 가진다·하고자 한다" → 3~5세 "습관·능력·태도를 기른다"</a:t>
-            </a:r>
-            <a:endParaRPr lang="en-US" sz="1200" dirty="0"/>
+              <a:rPr lang="en-US" sz="1250" b="1" dirty="0">
+                <a:solidFill>
+                  <a:srgbClr val="C0643E"/>
+                </a:solidFill>
+                <a:latin typeface="Malgun Gothic" pitchFamily="34" charset="0"/>
+                <a:ea typeface="Malgun Gothic" pitchFamily="34" charset="-122"/>
+                <a:cs typeface="Malgun Gothic" pitchFamily="34" charset="-120"/>
+              </a:rPr>
+              <a:t>0~1세 보육과정 및 2세 보육과정 목표</a:t>
+            </a:r>
+            <a:endParaRPr lang="en-US" sz="1250" dirty="0"/>
+          </a:p>
+        </p:txBody>
+      </p:sp>
+      <p:sp>
+        <p:nvSpPr>
+          <p:cNvPr id="20" name="Text 18"/>
+          <p:cNvSpPr txBox="1"/>
+          <p:nvPr/>
+        </p:nvSpPr>
+        <p:spPr>
+          <a:xfrm>
+            <a:off x="640080" y="2926080"/>
+            <a:ext cx="3703320" cy="1783080"/>
+          </a:xfrm>
+          <a:prstGeom prst="rect">
+            <a:avLst/>
+          </a:prstGeom>
+          <a:noFill/>
+          <a:ln/>
+        </p:spPr>
+        <p:txBody>
+          <a:bodyPr wrap="square" lIns="0" tIns="0" rIns="0" bIns="0" rtlCol="0" anchor="t"/>
+          <a:lstStyle/>
+          <a:p>
+            <a:pPr marL="342900" indent="-342900">
+              <a:spcAft>
+                <a:spcPts val="300"/>
+              </a:spcAft>
+              <a:buSzPct val="100000"/>
+              <a:buChar char="•"/>
+            </a:pPr>
+            <a:r>
+              <a:rPr lang="en-US" sz="1050" dirty="0">
+                <a:solidFill>
+                  <a:srgbClr val="33413A"/>
+                </a:solidFill>
+                <a:latin typeface="Malgun Gothic" pitchFamily="34" charset="0"/>
+                <a:ea typeface="Malgun Gothic" pitchFamily="34" charset="-122"/>
+                <a:cs typeface="Malgun Gothic" pitchFamily="34" charset="-120"/>
+              </a:rPr>
+              <a:t>자신의 소중함을 알고, 건강하고 안전한 환경에서 즐겁게 생활한다.</a:t>
+            </a:r>
+            <a:endParaRPr lang="en-US" sz="1050" dirty="0"/>
+          </a:p>
+          <a:p>
+            <a:pPr marL="342900" indent="-342900">
+              <a:spcAft>
+                <a:spcPts val="300"/>
+              </a:spcAft>
+              <a:buSzPct val="100000"/>
+              <a:buChar char="•"/>
+            </a:pPr>
+            <a:r>
+              <a:rPr lang="en-US" sz="1050" dirty="0">
+                <a:solidFill>
+                  <a:srgbClr val="33413A"/>
+                </a:solidFill>
+                <a:latin typeface="Malgun Gothic" pitchFamily="34" charset="0"/>
+                <a:ea typeface="Malgun Gothic" pitchFamily="34" charset="-122"/>
+                <a:cs typeface="Malgun Gothic" pitchFamily="34" charset="-120"/>
+              </a:rPr>
+              <a:t>자신의 일을 스스로 하고자 한다.</a:t>
+            </a:r>
+            <a:endParaRPr lang="en-US" sz="1050" dirty="0"/>
+          </a:p>
+          <a:p>
+            <a:pPr marL="342900" indent="-342900">
+              <a:spcAft>
+                <a:spcPts val="300"/>
+              </a:spcAft>
+              <a:buSzPct val="100000"/>
+              <a:buChar char="•"/>
+            </a:pPr>
+            <a:r>
+              <a:rPr lang="en-US" sz="1050" dirty="0">
+                <a:solidFill>
+                  <a:srgbClr val="33413A"/>
+                </a:solidFill>
+                <a:latin typeface="Malgun Gothic" pitchFamily="34" charset="0"/>
+                <a:ea typeface="Malgun Gothic" pitchFamily="34" charset="-122"/>
+                <a:cs typeface="Malgun Gothic" pitchFamily="34" charset="-120"/>
+              </a:rPr>
+              <a:t>호기심을 가지고 탐색하며 상상력을 기른다.</a:t>
+            </a:r>
+            <a:endParaRPr lang="en-US" sz="1050" dirty="0"/>
+          </a:p>
+          <a:p>
+            <a:pPr marL="342900" indent="-342900">
+              <a:spcAft>
+                <a:spcPts val="300"/>
+              </a:spcAft>
+              <a:buSzPct val="100000"/>
+              <a:buChar char="•"/>
+            </a:pPr>
+            <a:r>
+              <a:rPr lang="en-US" sz="1050" dirty="0">
+                <a:solidFill>
+                  <a:srgbClr val="33413A"/>
+                </a:solidFill>
+                <a:latin typeface="Malgun Gothic" pitchFamily="34" charset="0"/>
+                <a:ea typeface="Malgun Gothic" pitchFamily="34" charset="-122"/>
+                <a:cs typeface="Malgun Gothic" pitchFamily="34" charset="-120"/>
+              </a:rPr>
+              <a:t>일상에서 아름다움에 관심을 가지고 감성을 기른다.</a:t>
+            </a:r>
+            <a:endParaRPr lang="en-US" sz="1050" dirty="0"/>
+          </a:p>
+          <a:p>
+            <a:pPr marL="342900" indent="-342900">
+              <a:spcAft>
+                <a:spcPts val="300"/>
+              </a:spcAft>
+              <a:buSzPct val="100000"/>
+              <a:buChar char="•"/>
+            </a:pPr>
+            <a:r>
+              <a:rPr lang="en-US" sz="1050" dirty="0">
+                <a:solidFill>
+                  <a:srgbClr val="33413A"/>
+                </a:solidFill>
+                <a:latin typeface="Malgun Gothic" pitchFamily="34" charset="0"/>
+                <a:ea typeface="Malgun Gothic" pitchFamily="34" charset="-122"/>
+                <a:cs typeface="Malgun Gothic" pitchFamily="34" charset="-120"/>
+              </a:rPr>
+              <a:t>사람과 자연을 존중하고 소통하는 데 관심을 가진다.</a:t>
+            </a:r>
+            <a:endParaRPr lang="en-US" sz="1050" dirty="0"/>
+          </a:p>
+        </p:txBody>
+      </p:sp>
+      <p:sp>
+        <p:nvSpPr>
+          <p:cNvPr id="21" name="Shape 19"/>
+          <p:cNvSpPr/>
+          <p:nvPr/>
+        </p:nvSpPr>
+        <p:spPr>
+          <a:xfrm>
+            <a:off x="4663440" y="2514600"/>
+            <a:ext cx="4023360" cy="2240280"/>
+          </a:xfrm>
+          <a:prstGeom prst="roundRect">
+            <a:avLst>
+              <a:gd name="adj" fmla="val 6122"/>
+            </a:avLst>
+          </a:prstGeom>
+          <a:solidFill>
+            <a:srgbClr val="FDF3D6"/>
+          </a:solidFill>
+          <a:ln/>
+        </p:spPr>
+      </p:sp>
+      <p:sp>
+        <p:nvSpPr>
+          <p:cNvPr id="22" name="Text 20"/>
+          <p:cNvSpPr txBox="1"/>
+          <p:nvPr/>
+        </p:nvSpPr>
+        <p:spPr>
+          <a:xfrm>
+            <a:off x="4846320" y="2587752"/>
+            <a:ext cx="3657600" cy="320040"/>
+          </a:xfrm>
+          <a:prstGeom prst="rect">
+            <a:avLst/>
+          </a:prstGeom>
+          <a:noFill/>
+          <a:ln/>
+        </p:spPr>
+        <p:txBody>
+          <a:bodyPr wrap="square" lIns="0" tIns="0" rIns="0" bIns="0" rtlCol="0" anchor="ctr"/>
+          <a:lstStyle/>
+          <a:p>
+            <a:pPr indent="0" marL="0">
+              <a:buNone/>
+            </a:pPr>
+            <a:r>
+              <a:rPr lang="en-US" sz="1250" b="1" dirty="0">
+                <a:solidFill>
+                  <a:srgbClr val="B08A2E"/>
+                </a:solidFill>
+                <a:latin typeface="Malgun Gothic" pitchFamily="34" charset="0"/>
+                <a:ea typeface="Malgun Gothic" pitchFamily="34" charset="-122"/>
+                <a:cs typeface="Malgun Gothic" pitchFamily="34" charset="-120"/>
+              </a:rPr>
+              <a:t>3~5세 보육과정 목표</a:t>
+            </a:r>
+            <a:endParaRPr lang="en-US" sz="1250" dirty="0"/>
+          </a:p>
+        </p:txBody>
+      </p:sp>
+      <p:sp>
+        <p:nvSpPr>
+          <p:cNvPr id="23" name="Text 21"/>
+          <p:cNvSpPr txBox="1"/>
+          <p:nvPr/>
+        </p:nvSpPr>
+        <p:spPr>
+          <a:xfrm>
+            <a:off x="4846320" y="2926080"/>
+            <a:ext cx="3703320" cy="1783080"/>
+          </a:xfrm>
+          <a:prstGeom prst="rect">
+            <a:avLst/>
+          </a:prstGeom>
+          <a:noFill/>
+          <a:ln/>
+        </p:spPr>
+        <p:txBody>
+          <a:bodyPr wrap="square" lIns="0" tIns="0" rIns="0" bIns="0" rtlCol="0" anchor="t"/>
+          <a:lstStyle/>
+          <a:p>
+            <a:pPr marL="342900" indent="-342900">
+              <a:spcAft>
+                <a:spcPts val="300"/>
+              </a:spcAft>
+              <a:buSzPct val="100000"/>
+              <a:buChar char="•"/>
+            </a:pPr>
+            <a:r>
+              <a:rPr lang="en-US" sz="1050" dirty="0">
+                <a:solidFill>
+                  <a:srgbClr val="33413A"/>
+                </a:solidFill>
+                <a:latin typeface="Malgun Gothic" pitchFamily="34" charset="0"/>
+                <a:ea typeface="Malgun Gothic" pitchFamily="34" charset="-122"/>
+                <a:cs typeface="Malgun Gothic" pitchFamily="34" charset="-120"/>
+              </a:rPr>
+              <a:t>자신의 소중함을 알고, 건강하고 안전한 생활습관을 기른다.</a:t>
+            </a:r>
+            <a:endParaRPr lang="en-US" sz="1050" dirty="0"/>
+          </a:p>
+          <a:p>
+            <a:pPr marL="342900" indent="-342900">
+              <a:spcAft>
+                <a:spcPts val="300"/>
+              </a:spcAft>
+              <a:buSzPct val="100000"/>
+              <a:buChar char="•"/>
+            </a:pPr>
+            <a:r>
+              <a:rPr lang="en-US" sz="1050" dirty="0">
+                <a:solidFill>
+                  <a:srgbClr val="33413A"/>
+                </a:solidFill>
+                <a:latin typeface="Malgun Gothic" pitchFamily="34" charset="0"/>
+                <a:ea typeface="Malgun Gothic" pitchFamily="34" charset="-122"/>
+                <a:cs typeface="Malgun Gothic" pitchFamily="34" charset="-120"/>
+              </a:rPr>
+              <a:t>자신의 일을 스스로 해결하는 기초능력을 기른다.</a:t>
+            </a:r>
+            <a:endParaRPr lang="en-US" sz="1050" dirty="0"/>
+          </a:p>
+          <a:p>
+            <a:pPr marL="342900" indent="-342900">
+              <a:spcAft>
+                <a:spcPts val="300"/>
+              </a:spcAft>
+              <a:buSzPct val="100000"/>
+              <a:buChar char="•"/>
+            </a:pPr>
+            <a:r>
+              <a:rPr lang="en-US" sz="1050" dirty="0">
+                <a:solidFill>
+                  <a:srgbClr val="33413A"/>
+                </a:solidFill>
+                <a:latin typeface="Malgun Gothic" pitchFamily="34" charset="0"/>
+                <a:ea typeface="Malgun Gothic" pitchFamily="34" charset="-122"/>
+                <a:cs typeface="Malgun Gothic" pitchFamily="34" charset="-120"/>
+              </a:rPr>
+              <a:t>호기심과 탐구심을 가지고 상상력과 창의력을 기른다.</a:t>
+            </a:r>
+            <a:endParaRPr lang="en-US" sz="1050" dirty="0"/>
+          </a:p>
+          <a:p>
+            <a:pPr marL="342900" indent="-342900">
+              <a:spcAft>
+                <a:spcPts val="300"/>
+              </a:spcAft>
+              <a:buSzPct val="100000"/>
+              <a:buChar char="•"/>
+            </a:pPr>
+            <a:r>
+              <a:rPr lang="en-US" sz="1050" dirty="0">
+                <a:solidFill>
+                  <a:srgbClr val="33413A"/>
+                </a:solidFill>
+                <a:latin typeface="Malgun Gothic" pitchFamily="34" charset="0"/>
+                <a:ea typeface="Malgun Gothic" pitchFamily="34" charset="-122"/>
+                <a:cs typeface="Malgun Gothic" pitchFamily="34" charset="-120"/>
+              </a:rPr>
+              <a:t>일상에서 아름다움을 느끼고 문화적 감수성을 기른다.</a:t>
+            </a:r>
+            <a:endParaRPr lang="en-US" sz="1050" dirty="0"/>
+          </a:p>
+          <a:p>
+            <a:pPr marL="342900" indent="-342900">
+              <a:spcAft>
+                <a:spcPts val="300"/>
+              </a:spcAft>
+              <a:buSzPct val="100000"/>
+              <a:buChar char="•"/>
+            </a:pPr>
+            <a:r>
+              <a:rPr lang="en-US" sz="1050" dirty="0">
+                <a:solidFill>
+                  <a:srgbClr val="33413A"/>
+                </a:solidFill>
+                <a:latin typeface="Malgun Gothic" pitchFamily="34" charset="0"/>
+                <a:ea typeface="Malgun Gothic" pitchFamily="34" charset="-122"/>
+                <a:cs typeface="Malgun Gothic" pitchFamily="34" charset="-120"/>
+              </a:rPr>
+              <a:t>사람과 자연을 존중하고 배려하며 소통하는 태도를 기른다.</a:t>
+            </a:r>
+            <a:endParaRPr lang="en-US" sz="1050" dirty="0"/>
           </a:p>
         </p:txBody>
       </p:sp>
@@ -11776,7 +11176,7 @@
               <a:buNone/>
             </a:pPr>
             <a:r>
-              <a:rPr lang="en-US" sz="1200" b="1" dirty="0">
+              <a:rPr lang="en-US" sz="1100" b="1" dirty="0">
                 <a:solidFill>
                   <a:srgbClr val="33413A"/>
                 </a:solidFill>
@@ -11784,16 +11184,16 @@
                 <a:ea typeface="Malgun Gothic" pitchFamily="34" charset="-122"/>
                 <a:cs typeface="Malgun Gothic" pitchFamily="34" charset="-120"/>
               </a:rPr>
-              <a:t>0~5세 모든</a:t>
-            </a:r>
-            <a:endParaRPr lang="en-US" sz="1200" dirty="0"/>
+              <a:t>0~5세 모든 영유아에게</a:t>
+            </a:r>
+            <a:endParaRPr lang="en-US" sz="1100" dirty="0"/>
           </a:p>
           <a:p>
             <a:pPr algn="ctr" indent="0" marL="0">
               <a:buNone/>
             </a:pPr>
             <a:r>
-              <a:rPr lang="en-US" sz="1200" b="1" dirty="0">
+              <a:rPr lang="en-US" sz="1100" b="1" dirty="0">
                 <a:solidFill>
                   <a:srgbClr val="33413A"/>
                 </a:solidFill>
@@ -11801,9 +11201,9 @@
                 <a:ea typeface="Malgun Gothic" pitchFamily="34" charset="-122"/>
                 <a:cs typeface="Malgun Gothic" pitchFamily="34" charset="-120"/>
               </a:rPr>
-              <a:t>영유아에게 적용</a:t>
-            </a:r>
-            <a:endParaRPr lang="en-US" sz="1200" dirty="0"/>
+              <a:t>적용할 수 있도록</a:t>
+            </a:r>
+            <a:endParaRPr lang="en-US" sz="1100" dirty="0"/>
           </a:p>
         </p:txBody>
       </p:sp>
@@ -11898,7 +11298,7 @@
               <a:buNone/>
             </a:pPr>
             <a:r>
-              <a:rPr lang="en-US" sz="1200" b="1" dirty="0">
+              <a:rPr lang="en-US" sz="1100" b="1" dirty="0">
                 <a:solidFill>
                   <a:srgbClr val="33413A"/>
                 </a:solidFill>
@@ -11908,14 +11308,14 @@
               </a:rPr>
               <a:t>인간상 구현을 위한</a:t>
             </a:r>
-            <a:endParaRPr lang="en-US" sz="1200" dirty="0"/>
+            <a:endParaRPr lang="en-US" sz="1100" dirty="0"/>
           </a:p>
           <a:p>
             <a:pPr algn="ctr" indent="0" marL="0">
               <a:buNone/>
             </a:pPr>
             <a:r>
-              <a:rPr lang="en-US" sz="1200" b="1" dirty="0">
+              <a:rPr lang="en-US" sz="1100" b="1" dirty="0">
                 <a:solidFill>
                   <a:srgbClr val="33413A"/>
                 </a:solidFill>
@@ -11923,9 +11323,26 @@
                 <a:ea typeface="Malgun Gothic" pitchFamily="34" charset="-122"/>
                 <a:cs typeface="Malgun Gothic" pitchFamily="34" charset="-120"/>
               </a:rPr>
-              <a:t>지식·기능·태도·가치</a:t>
-            </a:r>
-            <a:endParaRPr lang="en-US" sz="1200" dirty="0"/>
+              <a:t>지식, 기능, 태도</a:t>
+            </a:r>
+            <a:endParaRPr lang="en-US" sz="1100" dirty="0"/>
+          </a:p>
+          <a:p>
+            <a:pPr algn="ctr" indent="0" marL="0">
+              <a:buNone/>
+            </a:pPr>
+            <a:r>
+              <a:rPr lang="en-US" sz="1100" b="1" dirty="0">
+                <a:solidFill>
+                  <a:srgbClr val="33413A"/>
+                </a:solidFill>
+                <a:latin typeface="Malgun Gothic" pitchFamily="34" charset="0"/>
+                <a:ea typeface="Malgun Gothic" pitchFamily="34" charset="-122"/>
+                <a:cs typeface="Malgun Gothic" pitchFamily="34" charset="-120"/>
+              </a:rPr>
+              <a:t>및 가치 반영</a:t>
+            </a:r>
+            <a:endParaRPr lang="en-US" sz="1100" dirty="0"/>
           </a:p>
         </p:txBody>
       </p:sp>
@@ -12020,7 +11437,7 @@
               <a:buNone/>
             </a:pPr>
             <a:r>
-              <a:rPr lang="en-US" sz="1200" b="1" dirty="0">
+              <a:rPr lang="en-US" sz="1100" b="1" dirty="0">
                 <a:solidFill>
                   <a:srgbClr val="33413A"/>
                 </a:solidFill>
@@ -12030,7 +11447,7 @@
               </a:rPr>
               <a:t>5개 영역 중심</a:t>
             </a:r>
-            <a:endParaRPr lang="en-US" sz="1200" dirty="0"/>
+            <a:endParaRPr lang="en-US" sz="1100" dirty="0"/>
           </a:p>
         </p:txBody>
       </p:sp>
@@ -12125,7 +11542,7 @@
               <a:buNone/>
             </a:pPr>
             <a:r>
-              <a:rPr lang="en-US" sz="1200" b="1" dirty="0">
+              <a:rPr lang="en-US" sz="1100" b="1" dirty="0">
                 <a:solidFill>
                   <a:srgbClr val="33413A"/>
                 </a:solidFill>
@@ -12133,16 +11550,16 @@
                 <a:ea typeface="Malgun Gothic" pitchFamily="34" charset="-122"/>
                 <a:cs typeface="Malgun Gothic" pitchFamily="34" charset="-120"/>
               </a:rPr>
-              <a:t>0~5세가 경험해야</a:t>
-            </a:r>
-            <a:endParaRPr lang="en-US" sz="1200" dirty="0"/>
+              <a:t>0~5세 영유아가</a:t>
+            </a:r>
+            <a:endParaRPr lang="en-US" sz="1100" dirty="0"/>
           </a:p>
           <a:p>
             <a:pPr algn="ctr" indent="0" marL="0">
               <a:buNone/>
             </a:pPr>
             <a:r>
-              <a:rPr lang="en-US" sz="1200" b="1" dirty="0">
+              <a:rPr lang="en-US" sz="1100" b="1" dirty="0">
                 <a:solidFill>
                   <a:srgbClr val="33413A"/>
                 </a:solidFill>
@@ -12150,9 +11567,9 @@
                 <a:ea typeface="Malgun Gothic" pitchFamily="34" charset="-122"/>
                 <a:cs typeface="Malgun Gothic" pitchFamily="34" charset="-120"/>
               </a:rPr>
-              <a:t>할 내용</a:t>
-            </a:r>
-            <a:endParaRPr lang="en-US" sz="1200" dirty="0"/>
+              <a:t>경험해야 할 내용</a:t>
+            </a:r>
+            <a:endParaRPr lang="en-US" sz="1100" dirty="0"/>
           </a:p>
         </p:txBody>
       </p:sp>
@@ -12247,7 +11664,7 @@
               <a:buNone/>
             </a:pPr>
             <a:r>
-              <a:rPr lang="en-US" sz="1200" b="1" dirty="0">
+              <a:rPr lang="en-US" sz="1100" b="1" dirty="0">
                 <a:solidFill>
                   <a:srgbClr val="33413A"/>
                 </a:solidFill>
@@ -12257,14 +11674,14 @@
               </a:rPr>
               <a:t>초등학교 교육과정</a:t>
             </a:r>
-            <a:endParaRPr lang="en-US" sz="1200" dirty="0"/>
+            <a:endParaRPr lang="en-US" sz="1100" dirty="0"/>
           </a:p>
           <a:p>
             <a:pPr algn="ctr" indent="0" marL="0">
               <a:buNone/>
             </a:pPr>
             <a:r>
-              <a:rPr lang="en-US" sz="1200" b="1" dirty="0">
+              <a:rPr lang="en-US" sz="1100" b="1" dirty="0">
                 <a:solidFill>
                   <a:srgbClr val="33413A"/>
                 </a:solidFill>
@@ -12272,9 +11689,9 @@
                 <a:ea typeface="Malgun Gothic" pitchFamily="34" charset="-122"/>
                 <a:cs typeface="Malgun Gothic" pitchFamily="34" charset="-120"/>
               </a:rPr>
-              <a:t>과의 연계성</a:t>
-            </a:r>
-            <a:endParaRPr lang="en-US" sz="1200" dirty="0"/>
+              <a:t>과의 연계성 고려</a:t>
+            </a:r>
+            <a:endParaRPr lang="en-US" sz="1100" dirty="0"/>
           </a:p>
         </p:txBody>
       </p:sp>
@@ -12865,8 +12282,8 @@
         </p:nvSpPr>
         <p:spPr>
           <a:xfrm>
-            <a:off x="594360" y="1874520"/>
-            <a:ext cx="2377440" cy="2743200"/>
+            <a:off x="594360" y="1783080"/>
+            <a:ext cx="2377440" cy="2880360"/>
           </a:xfrm>
           <a:prstGeom prst="rect">
             <a:avLst/>
@@ -12880,13 +12297,13 @@
           <a:p>
             <a:pPr marL="342900" indent="-342900">
               <a:spcAft>
-                <a:spcPts val="900"/>
+                <a:spcPts val="400"/>
               </a:spcAft>
               <a:buSzPct val="100000"/>
               <a:buChar char="•"/>
             </a:pPr>
             <a:r>
-              <a:rPr lang="en-US" sz="1250" dirty="0">
+              <a:rPr lang="en-US" sz="1050" dirty="0">
                 <a:solidFill>
                   <a:srgbClr val="33413A"/>
                 </a:solidFill>
@@ -12894,20 +12311,20 @@
                 <a:ea typeface="Malgun Gothic" pitchFamily="34" charset="-122"/>
                 <a:cs typeface="Malgun Gothic" pitchFamily="34" charset="-120"/>
               </a:rPr>
-              <a:t>기관 운영 시간·실정에 맞게 계획</a:t>
-            </a:r>
-            <a:endParaRPr lang="en-US" sz="1250" dirty="0"/>
+              <a:t>각 기관의 운영 시간에 맞추어 편성</a:t>
+            </a:r>
+            <a:endParaRPr lang="en-US" sz="1050" dirty="0"/>
           </a:p>
           <a:p>
             <a:pPr marL="342900" indent="-342900">
               <a:spcAft>
-                <a:spcPts val="900"/>
+                <a:spcPts val="400"/>
               </a:spcAft>
               <a:buSzPct val="100000"/>
               <a:buChar char="•"/>
             </a:pPr>
             <a:r>
-              <a:rPr lang="en-US" sz="1250" dirty="0">
+              <a:rPr lang="en-US" sz="1050" dirty="0">
                 <a:solidFill>
                   <a:srgbClr val="33413A"/>
                 </a:solidFill>
@@ -12915,20 +12332,20 @@
                 <a:ea typeface="Malgun Gothic" pitchFamily="34" charset="-122"/>
                 <a:cs typeface="Malgun Gothic" pitchFamily="34" charset="-120"/>
               </a:rPr>
-              <a:t>바깥놀이 포함, 충분한 놀이</a:t>
-            </a:r>
-            <a:endParaRPr lang="en-US" sz="1250" dirty="0"/>
+              <a:t>기관의 실정에 적합한 계획 수립</a:t>
+            </a:r>
+            <a:endParaRPr lang="en-US" sz="1050" dirty="0"/>
           </a:p>
           <a:p>
             <a:pPr marL="342900" indent="-342900">
               <a:spcAft>
-                <a:spcPts val="900"/>
+                <a:spcPts val="400"/>
               </a:spcAft>
               <a:buSzPct val="100000"/>
               <a:buChar char="•"/>
             </a:pPr>
             <a:r>
-              <a:rPr lang="en-US" sz="1250" dirty="0">
+              <a:rPr lang="en-US" sz="1050" dirty="0">
                 <a:solidFill>
                   <a:srgbClr val="33413A"/>
                 </a:solidFill>
@@ -12936,20 +12353,20 @@
                 <a:ea typeface="Malgun Gothic" pitchFamily="34" charset="-122"/>
                 <a:cs typeface="Malgun Gothic" pitchFamily="34" charset="-120"/>
               </a:rPr>
-              <a:t>성·장애·종교·가족·문화 차별 없이</a:t>
-            </a:r>
-            <a:endParaRPr lang="en-US" sz="1250" dirty="0"/>
+              <a:t>바깥놀이를 포함하여 놀이가 충분히 이루어지도록</a:t>
+            </a:r>
+            <a:endParaRPr lang="en-US" sz="1050" dirty="0"/>
           </a:p>
           <a:p>
             <a:pPr marL="342900" indent="-342900">
               <a:spcAft>
-                <a:spcPts val="900"/>
+                <a:spcPts val="400"/>
               </a:spcAft>
               <a:buSzPct val="100000"/>
               <a:buChar char="•"/>
             </a:pPr>
             <a:r>
-              <a:rPr lang="en-US" sz="1250" dirty="0">
+              <a:rPr lang="en-US" sz="1050" dirty="0">
                 <a:solidFill>
                   <a:srgbClr val="33413A"/>
                 </a:solidFill>
@@ -12957,20 +12374,20 @@
                 <a:ea typeface="Malgun Gothic" pitchFamily="34" charset="-122"/>
                 <a:cs typeface="Malgun Gothic" pitchFamily="34" charset="-120"/>
               </a:rPr>
-              <a:t>발달·장애 정도에 따라 조정</a:t>
-            </a:r>
-            <a:endParaRPr lang="en-US" sz="1250" dirty="0"/>
+              <a:t>성, 신체적 특성, 장애, 종교, 가족 및 문화적 배경 등에 따른 차별이 없도록</a:t>
+            </a:r>
+            <a:endParaRPr lang="en-US" sz="1050" dirty="0"/>
           </a:p>
           <a:p>
             <a:pPr marL="342900" indent="-342900">
               <a:spcAft>
-                <a:spcPts val="900"/>
+                <a:spcPts val="400"/>
               </a:spcAft>
               <a:buSzPct val="100000"/>
               <a:buChar char="•"/>
             </a:pPr>
             <a:r>
-              <a:rPr lang="en-US" sz="1250" dirty="0">
+              <a:rPr lang="en-US" sz="1050" dirty="0">
                 <a:solidFill>
                   <a:srgbClr val="33413A"/>
                 </a:solidFill>
@@ -12978,20 +12395,20 @@
                 <a:ea typeface="Malgun Gothic" pitchFamily="34" charset="-122"/>
                 <a:cs typeface="Malgun Gothic" pitchFamily="34" charset="-120"/>
               </a:rPr>
-              <a:t>가정·지역사회와 협력</a:t>
-            </a:r>
-            <a:endParaRPr lang="en-US" sz="1250" dirty="0"/>
+              <a:t>발달과 장애 정도에 따라 조정</a:t>
+            </a:r>
+            <a:endParaRPr lang="en-US" sz="1050" dirty="0"/>
           </a:p>
           <a:p>
             <a:pPr marL="342900" indent="-342900">
               <a:spcAft>
-                <a:spcPts val="900"/>
+                <a:spcPts val="400"/>
               </a:spcAft>
               <a:buSzPct val="100000"/>
               <a:buChar char="•"/>
             </a:pPr>
             <a:r>
-              <a:rPr lang="en-US" sz="1250" dirty="0">
+              <a:rPr lang="en-US" sz="1050" dirty="0">
                 <a:solidFill>
                   <a:srgbClr val="33413A"/>
                 </a:solidFill>
@@ -12999,9 +12416,30 @@
                 <a:ea typeface="Malgun Gothic" pitchFamily="34" charset="-122"/>
                 <a:cs typeface="Malgun Gothic" pitchFamily="34" charset="-120"/>
               </a:rPr>
-              <a:t>교사 연수로 운영 개선</a:t>
-            </a:r>
-            <a:endParaRPr lang="en-US" sz="1250" dirty="0"/>
+              <a:t>가정과 지역사회와의 협력과 참여에 기반</a:t>
+            </a:r>
+            <a:endParaRPr lang="en-US" sz="1050" dirty="0"/>
+          </a:p>
+          <a:p>
+            <a:pPr marL="342900" indent="-342900">
+              <a:spcAft>
+                <a:spcPts val="400"/>
+              </a:spcAft>
+              <a:buSzPct val="100000"/>
+              <a:buChar char="•"/>
+            </a:pPr>
+            <a:r>
+              <a:rPr lang="en-US" sz="1050" dirty="0">
+                <a:solidFill>
+                  <a:srgbClr val="33413A"/>
+                </a:solidFill>
+                <a:latin typeface="Malgun Gothic" pitchFamily="34" charset="0"/>
+                <a:ea typeface="Malgun Gothic" pitchFamily="34" charset="-122"/>
+                <a:cs typeface="Malgun Gothic" pitchFamily="34" charset="-120"/>
+              </a:rPr>
+              <a:t>교사 연수를 통해 운영 개선</a:t>
+            </a:r>
+            <a:endParaRPr lang="en-US" sz="1050" dirty="0"/>
           </a:p>
         </p:txBody>
       </p:sp>
@@ -13118,8 +12556,8 @@
         </p:nvSpPr>
         <p:spPr>
           <a:xfrm>
-            <a:off x="3401568" y="1874520"/>
-            <a:ext cx="2377440" cy="2743200"/>
+            <a:off x="3401568" y="1783080"/>
+            <a:ext cx="2377440" cy="2880360"/>
           </a:xfrm>
           <a:prstGeom prst="rect">
             <a:avLst/>
@@ -13133,13 +12571,13 @@
           <a:p>
             <a:pPr marL="342900" indent="-342900">
               <a:spcAft>
-                <a:spcPts val="900"/>
+                <a:spcPts val="400"/>
               </a:spcAft>
               <a:buSzPct val="100000"/>
               <a:buChar char="•"/>
             </a:pPr>
             <a:r>
-              <a:rPr lang="en-US" sz="1250" dirty="0">
+              <a:rPr lang="en-US" sz="1050" dirty="0">
                 <a:solidFill>
                   <a:srgbClr val="33413A"/>
                 </a:solidFill>
@@ -13147,20 +12585,20 @@
                 <a:ea typeface="Malgun Gothic" pitchFamily="34" charset="-122"/>
                 <a:cs typeface="Malgun Gothic" pitchFamily="34" charset="-120"/>
               </a:rPr>
-              <a:t>흥미·관심 따라 자유롭게 놀이</a:t>
-            </a:r>
-            <a:endParaRPr lang="en-US" sz="1250" dirty="0"/>
+              <a:t>흥미와 관심에 따라 놀이에 자유롭게 참여하고 즐기도록</a:t>
+            </a:r>
+            <a:endParaRPr lang="en-US" sz="1050" dirty="0"/>
           </a:p>
           <a:p>
             <a:pPr marL="342900" indent="-342900">
               <a:spcAft>
-                <a:spcPts val="900"/>
+                <a:spcPts val="400"/>
               </a:spcAft>
               <a:buSzPct val="100000"/>
               <a:buChar char="•"/>
             </a:pPr>
             <a:r>
-              <a:rPr lang="en-US" sz="1250" dirty="0">
+              <a:rPr lang="en-US" sz="1050" dirty="0">
                 <a:solidFill>
                   <a:srgbClr val="33413A"/>
                 </a:solidFill>
@@ -13168,20 +12606,20 @@
                 <a:ea typeface="Malgun Gothic" pitchFamily="34" charset="-122"/>
                 <a:cs typeface="Malgun Gothic" pitchFamily="34" charset="-120"/>
               </a:rPr>
-              <a:t>놀이를 통해 배우기</a:t>
-            </a:r>
-            <a:endParaRPr lang="en-US" sz="1250" dirty="0"/>
+              <a:t>놀이를 통해 배우도록</a:t>
+            </a:r>
+            <a:endParaRPr lang="en-US" sz="1050" dirty="0"/>
           </a:p>
           <a:p>
             <a:pPr marL="342900" indent="-342900">
               <a:spcAft>
-                <a:spcPts val="900"/>
+                <a:spcPts val="400"/>
               </a:spcAft>
               <a:buSzPct val="100000"/>
               <a:buChar char="•"/>
             </a:pPr>
             <a:r>
-              <a:rPr lang="en-US" sz="1250" dirty="0">
+              <a:rPr lang="en-US" sz="1050" dirty="0">
                 <a:solidFill>
                   <a:srgbClr val="33413A"/>
                 </a:solidFill>
@@ -13189,20 +12627,20 @@
                 <a:ea typeface="Malgun Gothic" pitchFamily="34" charset="-122"/>
                 <a:cs typeface="Malgun Gothic" pitchFamily="34" charset="-120"/>
               </a:rPr>
-              <a:t>다양한 실내외 환경 구성</a:t>
-            </a:r>
-            <a:endParaRPr lang="en-US" sz="1250" dirty="0"/>
+              <a:t>다양한 놀이와 활동을 경험하도록 실내외 환경 구성</a:t>
+            </a:r>
+            <a:endParaRPr lang="en-US" sz="1050" dirty="0"/>
           </a:p>
           <a:p>
             <a:pPr marL="342900" indent="-342900">
               <a:spcAft>
-                <a:spcPts val="900"/>
+                <a:spcPts val="400"/>
               </a:spcAft>
               <a:buSzPct val="100000"/>
               <a:buChar char="•"/>
             </a:pPr>
             <a:r>
-              <a:rPr lang="en-US" sz="1250" dirty="0">
+              <a:rPr lang="en-US" sz="1050" dirty="0">
                 <a:solidFill>
                   <a:srgbClr val="33413A"/>
                 </a:solidFill>
@@ -13210,20 +12648,20 @@
                 <a:ea typeface="Malgun Gothic" pitchFamily="34" charset="-122"/>
                 <a:cs typeface="Malgun Gothic" pitchFamily="34" charset="-120"/>
               </a:rPr>
-              <a:t>능동적 상호작용(영유아·교사·환경)</a:t>
-            </a:r>
-            <a:endParaRPr lang="en-US" sz="1250" dirty="0"/>
+              <a:t>영유아와 영유아·교사·환경 사이 능동적 상호작용</a:t>
+            </a:r>
+            <a:endParaRPr lang="en-US" sz="1050" dirty="0"/>
           </a:p>
           <a:p>
             <a:pPr marL="342900" indent="-342900">
               <a:spcAft>
-                <a:spcPts val="900"/>
+                <a:spcPts val="400"/>
               </a:spcAft>
               <a:buSzPct val="100000"/>
               <a:buChar char="•"/>
             </a:pPr>
             <a:r>
-              <a:rPr lang="en-US" sz="1250" dirty="0">
+              <a:rPr lang="en-US" sz="1050" dirty="0">
                 <a:solidFill>
                   <a:srgbClr val="33413A"/>
                 </a:solidFill>
@@ -13231,20 +12669,20 @@
                 <a:ea typeface="Malgun Gothic" pitchFamily="34" charset="-122"/>
                 <a:cs typeface="Malgun Gothic" pitchFamily="34" charset="-120"/>
               </a:rPr>
-              <a:t>5개 영역을 통합적으로 경험</a:t>
-            </a:r>
-            <a:endParaRPr lang="en-US" sz="1250" dirty="0"/>
+              <a:t>5개 영역의 내용이 통합적으로 경험과 연계</a:t>
+            </a:r>
+            <a:endParaRPr lang="en-US" sz="1050" dirty="0"/>
           </a:p>
           <a:p>
             <a:pPr marL="342900" indent="-342900">
               <a:spcAft>
-                <a:spcPts val="900"/>
+                <a:spcPts val="400"/>
               </a:spcAft>
               <a:buSzPct val="100000"/>
               <a:buChar char="•"/>
             </a:pPr>
             <a:r>
-              <a:rPr lang="en-US" sz="1250" dirty="0">
+              <a:rPr lang="en-US" sz="1050" dirty="0">
                 <a:solidFill>
                   <a:srgbClr val="33413A"/>
                 </a:solidFill>
@@ -13252,9 +12690,30 @@
                 <a:ea typeface="Malgun Gothic" pitchFamily="34" charset="-122"/>
                 <a:cs typeface="Malgun Gothic" pitchFamily="34" charset="-120"/>
               </a:rPr>
-              <a:t>개별 요구·특성에 맞게</a:t>
-            </a:r>
-            <a:endParaRPr lang="en-US" sz="1250" dirty="0"/>
+              <a:t>개별 요구에 따라 휴식과 일상생활이 원활히</a:t>
+            </a:r>
+            <a:endParaRPr lang="en-US" sz="1050" dirty="0"/>
+          </a:p>
+          <a:p>
+            <a:pPr marL="342900" indent="-342900">
+              <a:spcAft>
+                <a:spcPts val="400"/>
+              </a:spcAft>
+              <a:buSzPct val="100000"/>
+              <a:buChar char="•"/>
+            </a:pPr>
+            <a:r>
+              <a:rPr lang="en-US" sz="1050" dirty="0">
+                <a:solidFill>
+                  <a:srgbClr val="33413A"/>
+                </a:solidFill>
+                <a:latin typeface="Malgun Gothic" pitchFamily="34" charset="0"/>
+                <a:ea typeface="Malgun Gothic" pitchFamily="34" charset="-122"/>
+                <a:cs typeface="Malgun Gothic" pitchFamily="34" charset="-120"/>
+              </a:rPr>
+              <a:t>연령, 발달, 장애, 배경 등을 고려해 개별 특성에 적합한 방식으로</a:t>
+            </a:r>
+            <a:endParaRPr lang="en-US" sz="1050" dirty="0"/>
           </a:p>
         </p:txBody>
       </p:sp>
@@ -13371,8 +12830,8 @@
         </p:nvSpPr>
         <p:spPr>
           <a:xfrm>
-            <a:off x="6208776" y="1874520"/>
-            <a:ext cx="2377440" cy="2743200"/>
+            <a:off x="6208776" y="1783080"/>
+            <a:ext cx="2377440" cy="2880360"/>
           </a:xfrm>
           <a:prstGeom prst="rect">
             <a:avLst/>
@@ -13386,13 +12845,13 @@
           <a:p>
             <a:pPr marL="342900" indent="-342900">
               <a:spcAft>
-                <a:spcPts val="900"/>
+                <a:spcPts val="400"/>
               </a:spcAft>
               <a:buSzPct val="100000"/>
               <a:buChar char="•"/>
             </a:pPr>
             <a:r>
-              <a:rPr lang="en-US" sz="1250" dirty="0">
+              <a:rPr lang="en-US" sz="1050" dirty="0">
                 <a:solidFill>
                   <a:srgbClr val="33413A"/>
                 </a:solidFill>
@@ -13400,20 +12859,20 @@
                 <a:ea typeface="Malgun Gothic" pitchFamily="34" charset="-122"/>
                 <a:cs typeface="Malgun Gothic" pitchFamily="34" charset="-120"/>
               </a:rPr>
-              <a:t>운영의 질 진단·개선 위해 계획·실시</a:t>
-            </a:r>
-            <a:endParaRPr lang="en-US" sz="1250" dirty="0"/>
+              <a:t>운영의 질을 진단하고 개선하기 위해 평가를 계획하고 실시</a:t>
+            </a:r>
+            <a:endParaRPr lang="en-US" sz="1050" dirty="0"/>
           </a:p>
           <a:p>
             <a:pPr marL="342900" indent="-342900">
               <a:spcAft>
-                <a:spcPts val="900"/>
+                <a:spcPts val="400"/>
               </a:spcAft>
               <a:buSzPct val="100000"/>
               <a:buChar char="•"/>
             </a:pPr>
             <a:r>
-              <a:rPr lang="en-US" sz="1250" dirty="0">
+              <a:rPr lang="en-US" sz="1050" dirty="0">
                 <a:solidFill>
                   <a:srgbClr val="33413A"/>
                 </a:solidFill>
@@ -13421,20 +12880,20 @@
                 <a:ea typeface="Malgun Gothic" pitchFamily="34" charset="-122"/>
                 <a:cs typeface="Malgun Gothic" pitchFamily="34" charset="-120"/>
               </a:rPr>
-              <a:t>영유아의 특성·변화와 운영을 평가</a:t>
-            </a:r>
-            <a:endParaRPr lang="en-US" sz="1250" dirty="0"/>
+              <a:t>영유아의 특성 및 변화 정도와 표준보육과정의 운영을 평가</a:t>
+            </a:r>
+            <a:endParaRPr lang="en-US" sz="1050" dirty="0"/>
           </a:p>
           <a:p>
             <a:pPr marL="342900" indent="-342900">
               <a:spcAft>
-                <a:spcPts val="900"/>
+                <a:spcPts val="400"/>
               </a:spcAft>
               <a:buSzPct val="100000"/>
               <a:buChar char="•"/>
             </a:pPr>
             <a:r>
-              <a:rPr lang="en-US" sz="1250" dirty="0">
+              <a:rPr lang="en-US" sz="1050" dirty="0">
                 <a:solidFill>
                   <a:srgbClr val="33413A"/>
                 </a:solidFill>
@@ -13442,20 +12901,20 @@
                 <a:ea typeface="Malgun Gothic" pitchFamily="34" charset="-122"/>
                 <a:cs typeface="Malgun Gothic" pitchFamily="34" charset="-120"/>
               </a:rPr>
-              <a:t>목적에 맞는 방법 사용</a:t>
-            </a:r>
-            <a:endParaRPr lang="en-US" sz="1250" dirty="0"/>
+              <a:t>평가의 목적에 따라 적합한 방법 사용</a:t>
+            </a:r>
+            <a:endParaRPr lang="en-US" sz="1050" dirty="0"/>
           </a:p>
           <a:p>
             <a:pPr marL="342900" indent="-342900">
               <a:spcAft>
-                <a:spcPts val="900"/>
+                <a:spcPts val="400"/>
               </a:spcAft>
               <a:buSzPct val="100000"/>
               <a:buChar char="•"/>
             </a:pPr>
             <a:r>
-              <a:rPr lang="en-US" sz="1250" dirty="0">
+              <a:rPr lang="en-US" sz="1050" dirty="0">
                 <a:solidFill>
                   <a:srgbClr val="33413A"/>
                 </a:solidFill>
@@ -13463,9 +12922,9 @@
                 <a:ea typeface="Malgun Gothic" pitchFamily="34" charset="-122"/>
                 <a:cs typeface="Malgun Gothic" pitchFamily="34" charset="-120"/>
               </a:rPr>
-              <a:t>결과는 영유아 이해와 운영 개선에 활용</a:t>
-            </a:r>
-            <a:endParaRPr lang="en-US" sz="1250" dirty="0"/>
+              <a:t>결과는 영유아에 대한 이해와 운영 개선을 위한 자료로 활용</a:t>
+            </a:r>
+            <a:endParaRPr lang="en-US" sz="1050" dirty="0"/>
           </a:p>
         </p:txBody>
       </p:sp>
@@ -16301,13 +15760,13 @@
           <a:p>
             <a:pPr marL="342900" indent="-342900">
               <a:spcAft>
-                <a:spcPts val="600"/>
+                <a:spcPts val="400"/>
               </a:spcAft>
               <a:buSzPct val="100000"/>
               <a:buChar char="•"/>
             </a:pPr>
             <a:r>
-              <a:rPr lang="en-US" sz="1250" dirty="0">
+              <a:rPr lang="en-US" sz="1150" dirty="0">
                 <a:solidFill>
                   <a:srgbClr val="33413A"/>
                 </a:solidFill>
@@ -16315,20 +15774,20 @@
                 <a:ea typeface="Malgun Gothic" pitchFamily="34" charset="-122"/>
                 <a:cs typeface="Malgun Gothic" pitchFamily="34" charset="-120"/>
               </a:rPr>
-              <a:t>교육청 지침을 먼저 파악, 필수 교육 내용은 반드시 반영</a:t>
-            </a:r>
-            <a:endParaRPr lang="en-US" sz="1250" dirty="0"/>
+              <a:t>사전에 교육청의 지침 파악, 필수 교육 내용은 교육과정에 반영</a:t>
+            </a:r>
+            <a:endParaRPr lang="en-US" sz="1150" dirty="0"/>
           </a:p>
           <a:p>
             <a:pPr marL="342900" indent="-342900">
               <a:spcAft>
-                <a:spcPts val="600"/>
+                <a:spcPts val="400"/>
               </a:spcAft>
               <a:buSzPct val="100000"/>
               <a:buChar char="•"/>
             </a:pPr>
             <a:r>
-              <a:rPr lang="en-US" sz="1250" dirty="0">
+              <a:rPr lang="en-US" sz="1150" dirty="0">
                 <a:solidFill>
                   <a:srgbClr val="33413A"/>
                 </a:solidFill>
@@ -16336,20 +15795,20 @@
                 <a:ea typeface="Malgun Gothic" pitchFamily="34" charset="-122"/>
                 <a:cs typeface="Malgun Gothic" pitchFamily="34" charset="-120"/>
               </a:rPr>
-              <a:t>교육청마다 다를 수 있음 → 소속 교육청 계획서·지침 확인</a:t>
-            </a:r>
-            <a:endParaRPr lang="en-US" sz="1250" dirty="0"/>
+              <a:t>교육청이 정하는 내용은 교육청마다 다를 수 있음 → 소속 교육청의 계획서와 지침 참조</a:t>
+            </a:r>
+            <a:endParaRPr lang="en-US" sz="1150" dirty="0"/>
           </a:p>
           <a:p>
             <a:pPr marL="342900" indent="-342900">
               <a:spcAft>
-                <a:spcPts val="600"/>
+                <a:spcPts val="400"/>
               </a:spcAft>
               <a:buSzPct val="100000"/>
               <a:buChar char="•"/>
             </a:pPr>
             <a:r>
-              <a:rPr lang="en-US" sz="1250" dirty="0">
+              <a:rPr lang="en-US" sz="1150" dirty="0">
                 <a:solidFill>
                   <a:srgbClr val="33413A"/>
                 </a:solidFill>
@@ -16357,9 +15816,9 @@
                 <a:ea typeface="Malgun Gothic" pitchFamily="34" charset="-122"/>
                 <a:cs typeface="Malgun Gothic" pitchFamily="34" charset="-120"/>
               </a:rPr>
-              <a:t>운영계획서·연간 학사일정에도 지침 반영</a:t>
-            </a:r>
-            <a:endParaRPr lang="en-US" sz="1250" dirty="0"/>
+              <a:t>운영계획서 작성, 연간 학사일정 결정 시에도 소속청의 지침 숙지·반영</a:t>
+            </a:r>
+            <a:endParaRPr lang="en-US" sz="1150" dirty="0"/>
           </a:p>
         </p:txBody>
       </p:sp>
@@ -17230,7 +16689,7 @@
                 <a:ea typeface="Malgun Gothic" pitchFamily="34" charset="-122"/>
                 <a:cs typeface="Malgun Gothic" pitchFamily="34" charset="-120"/>
               </a:rPr>
-              <a:t>국가수준 교육과정 이해  +  지역·기관의 지침 반영  =  좋은 교육과정 운영</a:t>
+              <a:t>반드시 소속 교육청의 계획서와 지침을 참조</a:t>
             </a:r>
             <a:endParaRPr lang="en-US" sz="1600" dirty="0"/>
           </a:p>
@@ -18213,12 +17672,12 @@
         </p:nvSpPr>
         <p:spPr>
           <a:xfrm>
-            <a:off x="457200" y="3840480"/>
-            <a:ext cx="8229600" cy="868680"/>
+            <a:off x="457200" y="3703320"/>
+            <a:ext cx="8229600" cy="1051560"/>
           </a:xfrm>
           <a:prstGeom prst="roundRect">
             <a:avLst>
-              <a:gd name="adj" fmla="val 12632"/>
+              <a:gd name="adj" fmla="val 10435"/>
             </a:avLst>
           </a:prstGeom>
           <a:solidFill>
@@ -18235,8 +17694,8 @@
         </p:nvSpPr>
         <p:spPr>
           <a:xfrm>
-            <a:off x="685800" y="3931920"/>
-            <a:ext cx="7772400" cy="411480"/>
+            <a:off x="685800" y="3767328"/>
+            <a:ext cx="7772400" cy="640080"/>
           </a:xfrm>
           <a:prstGeom prst="rect">
             <a:avLst/>
@@ -18252,7 +17711,21 @@
               <a:buNone/>
             </a:pPr>
             <a:r>
-              <a:rPr lang="en-US" sz="1600" b="1" dirty="0">
+              <a:rPr lang="en-US" sz="1300" dirty="0">
+                <a:solidFill>
+                  <a:srgbClr val="33413A"/>
+                </a:solidFill>
+                <a:latin typeface="Malgun Gothic" pitchFamily="34" charset="0"/>
+                <a:ea typeface="Malgun Gothic" pitchFamily="34" charset="-122"/>
+                <a:cs typeface="Malgun Gothic" pitchFamily="34" charset="-120"/>
+              </a:rPr>
+              <a:t>"학습자의 전인적 성장과 발달을 돕기 위해서 학교가 의미하는 교육적 상황을 마련하고 모든 종류의 교수-학습 경험을 체계적으로 구성한 </a:t>
+            </a:r>
+            <a:pPr indent="0" marL="0">
+              <a:buNone/>
+            </a:pPr>
+            <a:r>
+              <a:rPr lang="en-US" sz="1300" b="1" dirty="0">
                 <a:solidFill>
                   <a:srgbClr val="5E8C6A"/>
                 </a:solidFill>
@@ -18260,13 +17733,13 @@
                 <a:ea typeface="Malgun Gothic" pitchFamily="34" charset="-122"/>
                 <a:cs typeface="Malgun Gothic" pitchFamily="34" charset="-120"/>
               </a:rPr>
-              <a:t>교육과정 = </a:t>
+              <a:t>설계도</a:t>
             </a:r>
             <a:pPr indent="0" marL="0">
               <a:buNone/>
             </a:pPr>
             <a:r>
-              <a:rPr lang="en-US" sz="1600" dirty="0">
+              <a:rPr lang="en-US" sz="1300" dirty="0">
                 <a:solidFill>
                   <a:srgbClr val="33413A"/>
                 </a:solidFill>
@@ -18274,23 +17747,9 @@
                 <a:ea typeface="Malgun Gothic" pitchFamily="34" charset="-122"/>
                 <a:cs typeface="Malgun Gothic" pitchFamily="34" charset="-120"/>
               </a:rPr>
-              <a:t>전인적 성장·발달을 돕는 교수-학습 경험의 체계적 </a:t>
-            </a:r>
-            <a:pPr indent="0" marL="0">
-              <a:buNone/>
-            </a:pPr>
-            <a:r>
-              <a:rPr lang="en-US" sz="1600" b="1" dirty="0">
-                <a:solidFill>
-                  <a:srgbClr val="5E8C6A"/>
-                </a:solidFill>
-                <a:latin typeface="Malgun Gothic" pitchFamily="34" charset="0"/>
-                <a:ea typeface="Malgun Gothic" pitchFamily="34" charset="-122"/>
-                <a:cs typeface="Malgun Gothic" pitchFamily="34" charset="-120"/>
-              </a:rPr>
-              <a:t>설계도</a:t>
-            </a:r>
-            <a:endParaRPr lang="en-US" sz="1600" dirty="0"/>
+              <a:t>"</a:t>
+            </a:r>
+            <a:endParaRPr lang="en-US" sz="1300" dirty="0"/>
           </a:p>
         </p:txBody>
       </p:sp>
@@ -18302,8 +17761,8 @@
         </p:nvSpPr>
         <p:spPr>
           <a:xfrm>
-            <a:off x="685800" y="4343400"/>
-            <a:ext cx="7772400" cy="274320"/>
+            <a:off x="685800" y="4434840"/>
+            <a:ext cx="7772400" cy="256032"/>
           </a:xfrm>
           <a:prstGeom prst="rect">
             <a:avLst/>
@@ -19435,7 +18894,7 @@
                 <a:ea typeface="Malgun Gothic" pitchFamily="34" charset="-122"/>
                 <a:cs typeface="Malgun Gothic" pitchFamily="34" charset="-120"/>
               </a:rPr>
-              <a:t>왜 필요해졌을까?</a:t>
+              <a:t>표준보육과정 개발의 배경</a:t>
             </a:r>
             <a:endParaRPr lang="en-US" sz="1500" dirty="0"/>
           </a:p>
@@ -19601,7 +19060,7 @@
                 <a:ea typeface="Malgun Gothic" pitchFamily="34" charset="-122"/>
                 <a:cs typeface="Malgun Gothic" pitchFamily="34" charset="-120"/>
               </a:rPr>
-              <a:t>취업모의 지속적 증가</a:t>
+              <a:t>취업모의 지속적인 증가</a:t>
             </a:r>
             <a:endParaRPr lang="en-US" sz="1500" dirty="0"/>
           </a:p>
@@ -19684,7 +19143,7 @@
                 <a:ea typeface="Malgun Gothic" pitchFamily="34" charset="-122"/>
                 <a:cs typeface="Malgun Gothic" pitchFamily="34" charset="-120"/>
               </a:rPr>
-              <a:t>조기 경험의 중요성 부각</a:t>
+              <a:t>영유아기 교육의 중요성 부각</a:t>
             </a:r>
             <a:endParaRPr lang="en-US" sz="1500" dirty="0"/>
           </a:p>
@@ -19748,7 +19207,7 @@
                 <a:ea typeface="Malgun Gothic" pitchFamily="34" charset="-122"/>
                 <a:cs typeface="Malgun Gothic" pitchFamily="34" charset="-120"/>
               </a:rPr>
-              <a:t>어린이집 이용의 보편화</a:t>
+              <a:t>영유아가 어린이집에 다니는 것이 보편화</a:t>
             </a:r>
             <a:endParaRPr lang="en-US" sz="1300" dirty="0"/>
           </a:p>
@@ -19768,11 +19227,8 @@
                 <a:ea typeface="Malgun Gothic" pitchFamily="34" charset="-122"/>
                 <a:cs typeface="Malgun Gothic" pitchFamily="34" charset="-120"/>
               </a:rPr>
-              <a:t>언제, 무엇을 목표로, 어떤 경험을 줄지</a:t>
-            </a:r>
-            <a:endParaRPr lang="en-US" sz="1300" dirty="0"/>
-          </a:p>
-          <a:p>
+              <a:t>→ 언제, 무엇을 목표로 어떤 경험을 제공할 것인가에 대한 </a:t>
+            </a:r>
             <a:pPr indent="0" marL="0">
               <a:spcAft>
                 <a:spcPts val="400"/>
@@ -19780,15 +19236,15 @@
               <a:buNone/>
             </a:pPr>
             <a:r>
-              <a:rPr lang="en-US" sz="1300" dirty="0">
-                <a:solidFill>
-                  <a:srgbClr val="33413A"/>
-                </a:solidFill>
-                <a:latin typeface="Malgun Gothic" pitchFamily="34" charset="0"/>
-                <a:ea typeface="Malgun Gothic" pitchFamily="34" charset="-122"/>
-                <a:cs typeface="Malgun Gothic" pitchFamily="34" charset="-120"/>
-              </a:rPr>
-              <a:t>→ </a:t>
+              <a:rPr lang="en-US" sz="1300" b="1" dirty="0">
+                <a:solidFill>
+                  <a:srgbClr val="5E8C6A"/>
+                </a:solidFill>
+                <a:latin typeface="Malgun Gothic" pitchFamily="34" charset="0"/>
+                <a:ea typeface="Malgun Gothic" pitchFamily="34" charset="-122"/>
+                <a:cs typeface="Malgun Gothic" pitchFamily="34" charset="-120"/>
+              </a:rPr>
+              <a:t>국가수준의 지침</a:t>
             </a:r>
             <a:pPr indent="0" marL="0">
               <a:spcAft>
@@ -19797,23 +19253,6 @@
               <a:buNone/>
             </a:pPr>
             <a:r>
-              <a:rPr lang="en-US" sz="1300" b="1" dirty="0">
-                <a:solidFill>
-                  <a:srgbClr val="5E8C6A"/>
-                </a:solidFill>
-                <a:latin typeface="Malgun Gothic" pitchFamily="34" charset="0"/>
-                <a:ea typeface="Malgun Gothic" pitchFamily="34" charset="-122"/>
-                <a:cs typeface="Malgun Gothic" pitchFamily="34" charset="-120"/>
-              </a:rPr>
-              <a:t>국가수준의 지침</a:t>
-            </a:r>
-            <a:pPr indent="0" marL="0">
-              <a:spcAft>
-                <a:spcPts val="400"/>
-              </a:spcAft>
-              <a:buNone/>
-            </a:pPr>
-            <a:r>
               <a:rPr lang="en-US" sz="1300" dirty="0">
                 <a:solidFill>
                   <a:srgbClr val="33413A"/>
@@ -19822,7 +19261,7 @@
                 <a:ea typeface="Malgun Gothic" pitchFamily="34" charset="-122"/>
                 <a:cs typeface="Malgun Gothic" pitchFamily="34" charset="-120"/>
               </a:rPr>
-              <a:t>이 필요해짐</a:t>
+              <a:t> 필요</a:t>
             </a:r>
             <a:endParaRPr lang="en-US" sz="1300" dirty="0"/>
           </a:p>
@@ -19943,7 +19382,7 @@
                 <a:ea typeface="Malgun Gothic" pitchFamily="34" charset="-122"/>
                 <a:cs typeface="Malgun Gothic" pitchFamily="34" charset="-120"/>
               </a:rPr>
-              <a:t>영유아보육법 제29조 제2항 개정</a:t>
+              <a:t>영유아보육법 전면 개정</a:t>
             </a:r>
             <a:endParaRPr lang="en-US" sz="1200" dirty="0"/>
           </a:p>
@@ -19960,7 +19399,7 @@
                 <a:ea typeface="Malgun Gothic" pitchFamily="34" charset="-122"/>
                 <a:cs typeface="Malgun Gothic" pitchFamily="34" charset="-120"/>
               </a:rPr>
-              <a:t>표준보육과정 개발·보급 명시</a:t>
+              <a:t>제29조 제2항에 개발·보급 명시</a:t>
             </a:r>
             <a:endParaRPr lang="en-US" sz="1200" dirty="0"/>
           </a:p>
@@ -20156,7 +19595,24 @@
                 <a:ea typeface="Malgun Gothic" pitchFamily="34" charset="-122"/>
                 <a:cs typeface="Malgun Gothic" pitchFamily="34" charset="-120"/>
               </a:rPr>
-              <a:t>제3차 표준보육과정 개정</a:t>
+              <a:t>제3차 어린이집 표준보육과정으로</a:t>
+            </a:r>
+            <a:endParaRPr lang="en-US" sz="1200" dirty="0"/>
+          </a:p>
+          <a:p>
+            <a:pPr indent="0" marL="0">
+              <a:buNone/>
+            </a:pPr>
+            <a:r>
+              <a:rPr lang="en-US" sz="1200" dirty="0">
+                <a:solidFill>
+                  <a:srgbClr val="33413A"/>
+                </a:solidFill>
+                <a:latin typeface="Malgun Gothic" pitchFamily="34" charset="0"/>
+                <a:ea typeface="Malgun Gothic" pitchFamily="34" charset="-122"/>
+                <a:cs typeface="Malgun Gothic" pitchFamily="34" charset="-120"/>
+              </a:rPr>
+              <a:t>개정</a:t>
             </a:r>
             <a:endParaRPr lang="en-US" sz="1200" dirty="0"/>
           </a:p>
@@ -20254,7 +19710,7 @@
                 <a:ea typeface="Malgun Gothic" pitchFamily="34" charset="-122"/>
                 <a:cs typeface="Malgun Gothic" pitchFamily="34" charset="-120"/>
               </a:rPr>
-              <a:t>제4차 표준보육과정 고시</a:t>
+              <a:t>제4차 어린이집 표준보육과정 고시</a:t>
             </a:r>
             <a:endParaRPr lang="en-US" sz="1200" dirty="0"/>
           </a:p>
@@ -20665,7 +20121,7 @@
                 <a:ea typeface="Malgun Gothic" pitchFamily="34" charset="-122"/>
                 <a:cs typeface="Malgun Gothic" pitchFamily="34" charset="-120"/>
               </a:rPr>
-              <a:t>초등학교 준비 위주 학습</a:t>
+              <a:t>초등학교 준비 위주의 학습</a:t>
             </a:r>
             <a:endParaRPr lang="en-US" sz="1100" dirty="0"/>
           </a:p>
@@ -20718,8 +20174,8 @@
         </p:nvSpPr>
         <p:spPr>
           <a:xfrm>
-            <a:off x="640080" y="3017520"/>
-            <a:ext cx="2194560" cy="777240"/>
+            <a:off x="640080" y="2999232"/>
+            <a:ext cx="2240280" cy="868680"/>
           </a:xfrm>
           <a:prstGeom prst="rect">
             <a:avLst/>
@@ -20735,7 +20191,7 @@
               <a:buNone/>
             </a:pPr>
             <a:r>
-              <a:rPr lang="en-US" sz="1400" b="1" dirty="0">
+              <a:rPr lang="en-US" sz="1300" b="1" dirty="0">
                 <a:solidFill>
                   <a:srgbClr val="33413A"/>
                 </a:solidFill>
@@ -20743,9 +20199,26 @@
                 <a:ea typeface="Malgun Gothic" pitchFamily="34" charset="-122"/>
                 <a:cs typeface="Malgun Gothic" pitchFamily="34" charset="-120"/>
               </a:rPr>
-              <a:t>개별 유아의 다양한 특성 고려</a:t>
-            </a:r>
-            <a:endParaRPr lang="en-US" sz="1400" dirty="0"/>
+              <a:t>개별 유아에 대한 다양한</a:t>
+            </a:r>
+            <a:endParaRPr lang="en-US" sz="1300" dirty="0"/>
+          </a:p>
+          <a:p>
+            <a:pPr indent="0" marL="0">
+              <a:buNone/>
+            </a:pPr>
+            <a:r>
+              <a:rPr lang="en-US" sz="1300" b="1" dirty="0">
+                <a:solidFill>
+                  <a:srgbClr val="33413A"/>
+                </a:solidFill>
+                <a:latin typeface="Malgun Gothic" pitchFamily="34" charset="0"/>
+                <a:ea typeface="Malgun Gothic" pitchFamily="34" charset="-122"/>
+                <a:cs typeface="Malgun Gothic" pitchFamily="34" charset="-120"/>
+              </a:rPr>
+              <a:t>특성을 고려한 내용</a:t>
+            </a:r>
+            <a:endParaRPr lang="en-US" sz="1300" dirty="0"/>
           </a:p>
         </p:txBody>
       </p:sp>
@@ -20887,7 +20360,7 @@
                 <a:ea typeface="Malgun Gothic" pitchFamily="34" charset="-122"/>
                 <a:cs typeface="Malgun Gothic" pitchFamily="34" charset="-120"/>
               </a:rPr>
-              <a:t>교사계획서·학습 위주 교육</a:t>
+              <a:t>교사계획서 위주, 학습 위주의 교육</a:t>
             </a:r>
             <a:endParaRPr lang="en-US" sz="1100" dirty="0"/>
           </a:p>
@@ -20940,8 +20413,8 @@
         </p:nvSpPr>
         <p:spPr>
           <a:xfrm>
-            <a:off x="3474720" y="3017520"/>
-            <a:ext cx="2194560" cy="777240"/>
+            <a:off x="3474720" y="2999232"/>
+            <a:ext cx="2240280" cy="868680"/>
           </a:xfrm>
           <a:prstGeom prst="rect">
             <a:avLst/>
@@ -20957,7 +20430,7 @@
               <a:buNone/>
             </a:pPr>
             <a:r>
-              <a:rPr lang="en-US" sz="1400" b="1" dirty="0">
+              <a:rPr lang="en-US" sz="1300" b="1" dirty="0">
                 <a:solidFill>
                   <a:srgbClr val="33413A"/>
                 </a:solidFill>
@@ -20965,16 +20438,16 @@
                 <a:ea typeface="Malgun Gothic" pitchFamily="34" charset="-122"/>
                 <a:cs typeface="Malgun Gothic" pitchFamily="34" charset="-120"/>
               </a:rPr>
-              <a:t>자유놀이 권장</a:t>
-            </a:r>
-            <a:endParaRPr lang="en-US" sz="1400" dirty="0"/>
+              <a:t>유아의 자유놀이 권장</a:t>
+            </a:r>
+            <a:endParaRPr lang="en-US" sz="1300" dirty="0"/>
           </a:p>
           <a:p>
             <a:pPr indent="0" marL="0">
               <a:buNone/>
             </a:pPr>
             <a:r>
-              <a:rPr lang="en-US" sz="1400" b="1" dirty="0">
+              <a:rPr lang="en-US" sz="1300" b="1" dirty="0">
                 <a:solidFill>
                   <a:srgbClr val="33413A"/>
                 </a:solidFill>
@@ -20982,9 +20455,26 @@
                 <a:ea typeface="Malgun Gothic" pitchFamily="34" charset="-122"/>
                 <a:cs typeface="Malgun Gothic" pitchFamily="34" charset="-120"/>
               </a:rPr>
-              <a:t>관찰·기록 등 상호작용 강조</a:t>
-            </a:r>
-            <a:endParaRPr lang="en-US" sz="1400" dirty="0"/>
+              <a:t>관찰과 기록 등 유아와의</a:t>
+            </a:r>
+            <a:endParaRPr lang="en-US" sz="1300" dirty="0"/>
+          </a:p>
+          <a:p>
+            <a:pPr indent="0" marL="0">
+              <a:buNone/>
+            </a:pPr>
+            <a:r>
+              <a:rPr lang="en-US" sz="1300" b="1" dirty="0">
+                <a:solidFill>
+                  <a:srgbClr val="33413A"/>
+                </a:solidFill>
+                <a:latin typeface="Malgun Gothic" pitchFamily="34" charset="0"/>
+                <a:ea typeface="Malgun Gothic" pitchFamily="34" charset="-122"/>
+                <a:cs typeface="Malgun Gothic" pitchFamily="34" charset="-120"/>
+              </a:rPr>
+              <a:t>상호작용 강조</a:t>
+            </a:r>
+            <a:endParaRPr lang="en-US" sz="1300" dirty="0"/>
           </a:p>
         </p:txBody>
       </p:sp>
@@ -21126,7 +20616,7 @@
                 <a:ea typeface="Malgun Gothic" pitchFamily="34" charset="-122"/>
                 <a:cs typeface="Malgun Gothic" pitchFamily="34" charset="-120"/>
               </a:rPr>
-              <a:t>5개 영역, 주제-소주제의</a:t>
+              <a:t>5개 영역, 주제-소주제 등</a:t>
             </a:r>
             <a:endParaRPr lang="en-US" sz="1100" dirty="0"/>
           </a:p>
@@ -21143,7 +20633,7 @@
                 <a:ea typeface="Malgun Gothic" pitchFamily="34" charset="-122"/>
                 <a:cs typeface="Malgun Gothic" pitchFamily="34" charset="-120"/>
               </a:rPr>
-              <a:t>지나치게 세부적인 구성</a:t>
+              <a:t>구성체계가 지나치게 세부적</a:t>
             </a:r>
             <a:endParaRPr lang="en-US" sz="1100" dirty="0"/>
           </a:p>
@@ -21196,8 +20686,8 @@
         </p:nvSpPr>
         <p:spPr>
           <a:xfrm>
-            <a:off x="6309360" y="3017520"/>
-            <a:ext cx="2194560" cy="777240"/>
+            <a:off x="6309360" y="2999232"/>
+            <a:ext cx="2240280" cy="868680"/>
           </a:xfrm>
           <a:prstGeom prst="rect">
             <a:avLst/>
@@ -21213,7 +20703,7 @@
               <a:buNone/>
             </a:pPr>
             <a:r>
-              <a:rPr lang="en-US" sz="1400" b="1" dirty="0">
+              <a:rPr lang="en-US" sz="1300" b="1" dirty="0">
                 <a:solidFill>
                   <a:srgbClr val="33413A"/>
                 </a:solidFill>
@@ -21221,16 +20711,16 @@
                 <a:ea typeface="Malgun Gothic" pitchFamily="34" charset="-122"/>
                 <a:cs typeface="Malgun Gothic" pitchFamily="34" charset="-120"/>
               </a:rPr>
-              <a:t>세부내용 삭제로</a:t>
-            </a:r>
-            <a:endParaRPr lang="en-US" sz="1400" dirty="0"/>
+              <a:t>현장의 자율성 존중을 위해</a:t>
+            </a:r>
+            <a:endParaRPr lang="en-US" sz="1300" dirty="0"/>
           </a:p>
           <a:p>
             <a:pPr indent="0" marL="0">
               <a:buNone/>
             </a:pPr>
             <a:r>
-              <a:rPr lang="en-US" sz="1400" b="1" dirty="0">
+              <a:rPr lang="en-US" sz="1300" b="1" dirty="0">
                 <a:solidFill>
                   <a:srgbClr val="33413A"/>
                 </a:solidFill>
@@ -21238,9 +20728,9 @@
                 <a:ea typeface="Malgun Gothic" pitchFamily="34" charset="-122"/>
                 <a:cs typeface="Malgun Gothic" pitchFamily="34" charset="-120"/>
               </a:rPr>
-              <a:t>현장의 자율성 존중</a:t>
-            </a:r>
-            <a:endParaRPr lang="en-US" sz="1400" dirty="0"/>
+              <a:t>세부내용 삭제</a:t>
+            </a:r>
+            <a:endParaRPr lang="en-US" sz="1300" dirty="0"/>
           </a:p>
         </p:txBody>
       </p:sp>
@@ -21291,7 +20781,7 @@
               <a:buNone/>
             </a:pPr>
             <a:r>
-              <a:rPr lang="en-US" sz="1700" b="1" dirty="0">
+              <a:rPr lang="en-US" sz="1400" b="1" dirty="0">
                 <a:solidFill>
                   <a:srgbClr val="FFFFFF"/>
                 </a:solidFill>
@@ -21299,9 +20789,9 @@
                 <a:ea typeface="Malgun Gothic" pitchFamily="34" charset="-122"/>
                 <a:cs typeface="Malgun Gothic" pitchFamily="34" charset="-120"/>
               </a:rPr>
-              <a:t>유아 중심 · 놀이 중심 교육과정  →  2020년부터 유치원·어린이집 공통 적용</a:t>
-            </a:r>
-            <a:endParaRPr lang="en-US" sz="1700" dirty="0"/>
+              <a:t>'유아 중심·놀이 중심 교육과정'  →  2020년부터 유치원과 어린이집 공통교육과정으로 적용</a:t>
+            </a:r>
+            <a:endParaRPr lang="en-US" sz="1400" dirty="0"/>
           </a:p>
         </p:txBody>
       </p:sp>
@@ -21707,7 +21197,7 @@
                 <a:ea typeface="Malgun Gothic" pitchFamily="34" charset="-122"/>
                 <a:cs typeface="Malgun Gothic" pitchFamily="34" charset="-120"/>
               </a:rPr>
-              <a:t>학습자의 전인적 성장·발달을 위한 교수-학습 경험의 설계도</a:t>
+              <a:t>학습자의 전인적 성장과 발달을 돕기 위한 교수-학습 경험의 설계도</a:t>
             </a:r>
             <a:endParaRPr lang="en-US" sz="1400" dirty="0"/>
           </a:p>
@@ -21844,7 +21334,7 @@
                 <a:ea typeface="Malgun Gothic" pitchFamily="34" charset="-122"/>
                 <a:cs typeface="Malgun Gothic" pitchFamily="34" charset="-120"/>
               </a:rPr>
-              <a:t>이원화된 과정을 일원화해 교육의 질과 출발점 평등을 보장</a:t>
+              <a:t>유치원교육과정과 표준보육과정 일원화, 생애초기 출발점 평등 보장</a:t>
             </a:r>
             <a:endParaRPr lang="en-US" sz="1400" dirty="0"/>
           </a:p>
@@ -21981,7 +21471,7 @@
                 <a:ea typeface="Malgun Gothic" pitchFamily="34" charset="-122"/>
                 <a:cs typeface="Malgun Gothic" pitchFamily="34" charset="-120"/>
               </a:rPr>
-              <a:t>유아 중심·놀이 중심, 현장의 자율성 존중</a:t>
+              <a:t>'유아 중심·놀이 중심 교육과정'으로 개정</a:t>
             </a:r>
             <a:endParaRPr lang="en-US" sz="1400" dirty="0"/>
           </a:p>

</xml_diff>